<commit_message>
Update PPT, Word spec, and Architecture MD with ZEL name, Zero wait to leave zero wait to return tagline, and visual flows
</commit_message>
<xml_diff>
--- a/NICE_CXone_WFM_Copilot_Architecture_and_Overview.pptx
+++ b/NICE_CXone_WFM_Copilot_Architecture_and_Overview.pptx
@@ -3100,7 +3100,7 @@
         <p:spPr>
           <a:xfrm>
             <a:off x="0" y="0"/>
-            <a:ext cx="12191695" cy="1051560"/>
+            <a:ext cx="12191695" cy="6858000"/>
           </a:xfrm>
           <a:prstGeom prst="rect">
             <a:avLst/>
@@ -3144,8 +3144,8 @@
         </p:nvSpPr>
         <p:spPr>
           <a:xfrm>
-            <a:off x="731520" y="146304"/>
-            <a:ext cx="10515600" cy="274320"/>
+            <a:off x="822960" y="1097280"/>
+            <a:ext cx="6858000" cy="2560320"/>
           </a:xfrm>
           <a:prstGeom prst="rect">
             <a:avLst/>
@@ -3159,73 +3159,80 @@
           <a:lstStyle/>
           <a:p>
             <a:pPr>
-              <a:defRPr sz="1000" b="1">
+              <a:spcAft>
+                <a:spcPts val="400"/>
+              </a:spcAft>
+              <a:defRPr sz="1100" b="1">
                 <a:solidFill>
                   <a:srgbClr val="0EA5E9"/>
                 </a:solidFill>
               </a:defRPr>
             </a:pPr>
             <a:r>
-              <a:t>EXECUTIVE OVERVIEW &amp; PRODUCT VISION</a:t>
-            </a:r>
-          </a:p>
-        </p:txBody>
-      </p:sp>
-      <p:sp>
-        <p:nvSpPr>
-          <p:cNvPr id="4" name="TextBox 3"/>
-          <p:cNvSpPr txBox="1"/>
-          <p:nvPr/>
-        </p:nvSpPr>
-        <p:spPr>
-          <a:xfrm>
-            <a:off x="731520" y="384048"/>
-            <a:ext cx="10515600" cy="548640"/>
-          </a:xfrm>
-          <a:prstGeom prst="rect">
-            <a:avLst/>
-          </a:prstGeom>
-          <a:noFill/>
-        </p:spPr>
-        <p:txBody>
-          <a:bodyPr wrap="square">
-            <a:spAutoFit/>
-          </a:bodyPr>
-          <a:lstStyle/>
+              <a:t>NICE CXONE INTEL ENGINE</a:t>
+            </a:r>
+          </a:p>
           <a:p>
             <a:pPr>
-              <a:defRPr sz="2200" b="1">
+              <a:defRPr sz="4600" b="1">
                 <a:solidFill>
                   <a:srgbClr val="FFFFFF"/>
                 </a:solidFill>
               </a:defRPr>
             </a:pPr>
             <a:r>
-              <a:t>NICE CXone Autonomous WFM &amp; AI Copilot Platform</a:t>
-            </a:r>
-          </a:p>
-        </p:txBody>
-      </p:sp>
-      <p:sp>
-        <p:nvSpPr>
-          <p:cNvPr id="5" name="Rounded Rectangle 4"/>
+              <a:t>Meet ZEL</a:t>
+            </a:r>
+          </a:p>
+          <a:p>
+            <a:pPr>
+              <a:spcAft>
+                <a:spcPts val="1000"/>
+              </a:spcAft>
+              <a:defRPr sz="2200" i="1" b="1">
+                <a:solidFill>
+                  <a:srgbClr val="38BDF8"/>
+                </a:solidFill>
+              </a:defRPr>
+            </a:pPr>
+            <a:r>
+              <a:t>“Zero wait to leave, zero wait to return”</a:t>
+            </a:r>
+          </a:p>
+          <a:p>
+            <a:pPr>
+              <a:defRPr sz="1300">
+                <a:solidFill>
+                  <a:srgbClr val="CBD5E1"/>
+                </a:solidFill>
+              </a:defRPr>
+            </a:pPr>
+            <a:r>
+              <a:t>Autonomous AI-powered WFM Copilot that eliminates break approval delays, protects schedule adherence, and instantly guides agents back to the desk.</a:t>
+            </a:r>
+          </a:p>
+        </p:txBody>
+      </p:sp>
+      <p:sp>
+        <p:nvSpPr>
+          <p:cNvPr id="4" name="Rounded Rectangle 3"/>
           <p:cNvSpPr/>
           <p:nvPr/>
         </p:nvSpPr>
         <p:spPr>
           <a:xfrm>
-            <a:off x="731520" y="1280160"/>
-            <a:ext cx="5120640" cy="3931920"/>
+            <a:off x="8046720" y="1097280"/>
+            <a:ext cx="3291840" cy="3840480"/>
           </a:xfrm>
           <a:prstGeom prst="roundRect">
             <a:avLst/>
           </a:prstGeom>
           <a:solidFill>
-            <a:srgbClr val="FFFFFF"/>
+            <a:srgbClr val="0F172A"/>
           </a:solidFill>
-          <a:ln w="19050">
+          <a:ln w="25400">
             <a:solidFill>
-              <a:srgbClr val="E2E8F0"/>
+              <a:srgbClr val="2563EB"/>
             </a:solidFill>
           </a:ln>
         </p:spPr>
@@ -3251,6 +3258,30 @@
           </a:p>
         </p:txBody>
       </p:sp>
+      <p:pic>
+        <p:nvPicPr>
+          <p:cNvPr id="5" name="Picture 4" descr="icon.png"/>
+          <p:cNvPicPr>
+            <a:picLocks noChangeAspect="1"/>
+          </p:cNvPicPr>
+          <p:nvPr/>
+        </p:nvPicPr>
+        <p:blipFill>
+          <a:blip r:embed="rId2"/>
+          <a:stretch>
+            <a:fillRect/>
+          </a:stretch>
+        </p:blipFill>
+        <p:spPr>
+          <a:xfrm>
+            <a:off x="8503920" y="1463040"/>
+            <a:ext cx="2377440" cy="2377440"/>
+          </a:xfrm>
+          <a:prstGeom prst="rect">
+            <a:avLst/>
+          </a:prstGeom>
+        </p:spPr>
+      </p:pic>
       <p:sp>
         <p:nvSpPr>
           <p:cNvPr id="6" name="TextBox 5"/>
@@ -3259,8 +3290,8 @@
         </p:nvSpPr>
         <p:spPr>
           <a:xfrm>
-            <a:off x="914400" y="1444752"/>
-            <a:ext cx="4754880" cy="3602736"/>
+            <a:off x="8138160" y="4023360"/>
+            <a:ext cx="3108960" cy="822960"/>
           </a:xfrm>
           <a:prstGeom prst="rect">
             <a:avLst/>
@@ -3268,127 +3299,32 @@
           <a:noFill/>
         </p:spPr>
         <p:txBody>
-          <a:bodyPr wrap="square" anchor="t">
+          <a:bodyPr wrap="square">
             <a:spAutoFit/>
           </a:bodyPr>
           <a:lstStyle/>
           <a:p>
-            <a:pPr>
+            <a:pPr algn="ctr">
               <a:defRPr sz="1400" b="1">
                 <a:solidFill>
-                  <a:srgbClr val="1E3A8A"/>
-                </a:solidFill>
-              </a:defRPr>
-            </a:pPr>
-            <a:r>
-              <a:t>The Operational Challenge in Legacy Contact Centers</a:t>
-            </a:r>
-          </a:p>
-          <a:p>
-            <a:pPr>
-              <a:spcAft>
-                <a:spcPts val="800"/>
-              </a:spcAft>
-              <a:defRPr sz="1000" i="1">
-                <a:solidFill>
-                  <a:srgbClr val="64748B"/>
-                </a:solidFill>
-              </a:defRPr>
-            </a:pPr>
-            <a:r>
-              <a:t>Manual AUX States, Opaque Floor Drift &amp; Burnout Risk</a:t>
-            </a:r>
-          </a:p>
-          <a:p>
-            <a:pPr>
-              <a:spcAft>
-                <a:spcPts val="600"/>
-              </a:spcAft>
-              <a:defRPr b="1" sz="1000">
-                <a:solidFill>
-                  <a:srgbClr val="0F172A"/>
-                </a:solidFill>
-              </a:defRPr>
-            </a:pPr>
-            <a:r>
-              <a:t>• Discretionary AUX Blind Spots: </a:t>
-            </a:r>
-            <a:r>
-              <a:rPr b="0" sz="1000">
-                <a:solidFill>
-                  <a:srgbClr val="64748B"/>
-                </a:solidFill>
-              </a:rPr>
-              <a:t>Agents manually toggle break codes without real-time Erlang-C staffing checks, leading to severe intraday queue starvation.</a:t>
-            </a:r>
-          </a:p>
-          <a:p>
-            <a:pPr>
-              <a:spcAft>
-                <a:spcPts val="600"/>
-              </a:spcAft>
-              <a:defRPr b="1" sz="1000">
-                <a:solidFill>
-                  <a:srgbClr val="0F172A"/>
-                </a:solidFill>
-              </a:defRPr>
-            </a:pPr>
-            <a:r>
-              <a:t>• Sudden Inbound Queue Surges: </a:t>
-            </a:r>
-            <a:r>
-              <a:rPr b="0" sz="1000">
-                <a:solidFill>
-                  <a:srgbClr val="64748B"/>
-                </a:solidFill>
-              </a:rPr>
-              <a:t>Volume spikes (+300 calls) instantly drop SLAs from 85% to 34% while donor queues remain idle and underutilized.</a:t>
-            </a:r>
-          </a:p>
-          <a:p>
-            <a:pPr>
-              <a:spcAft>
-                <a:spcPts val="600"/>
-              </a:spcAft>
-              <a:defRPr b="1" sz="1000">
-                <a:solidFill>
-                  <a:srgbClr val="0F172A"/>
-                </a:solidFill>
-              </a:defRPr>
-            </a:pPr>
-            <a:r>
-              <a:t>• Post-Call Wrap-up (ACW) Latency: </a:t>
-            </a:r>
-            <a:r>
-              <a:rPr b="0" sz="1000">
-                <a:solidFill>
-                  <a:srgbClr val="64748B"/>
-                </a:solidFill>
-              </a:rPr>
-              <a:t>Agents spend 60-90s manually entering CRM wrap-up notes, degrading handle times and inflating operational cost.</a:t>
-            </a:r>
-          </a:p>
-          <a:p>
-            <a:pPr>
-              <a:spcAft>
-                <a:spcPts val="600"/>
-              </a:spcAft>
-              <a:defRPr b="1" sz="1000">
-                <a:solidFill>
-                  <a:srgbClr val="0F172A"/>
-                </a:solidFill>
-              </a:defRPr>
-            </a:pPr>
-            <a:r>
-              <a:t>• Regional Disaster Outages: </a:t>
-            </a:r>
-            <a:r>
-              <a:rPr b="0" sz="1000">
-                <a:solidFill>
-                  <a:srgbClr val="64748B"/>
-                </a:solidFill>
-              </a:rPr>
-              <a:t>Severe storms flood queues past 1,000 calls/min with no automated front-line deflection, paralyzing live agents.</a:t>
+                  <a:srgbClr val="FFFFFF"/>
+                </a:solidFill>
+              </a:defRPr>
+            </a:pPr>
+            <a:r>
+              <a:t>ZEL AI Companion</a:t>
+            </a:r>
+          </a:p>
+          <a:p>
+            <a:pPr algn="ctr">
+              <a:defRPr sz="1000">
+                <a:solidFill>
+                  <a:srgbClr val="94A3B8"/>
+                </a:solidFill>
+              </a:defRPr>
+            </a:pPr>
+            <a:r>
+              <a:t>Always-on desktop copilot for agents &amp; supervisors</a:t>
             </a:r>
           </a:p>
         </p:txBody>
@@ -3401,18 +3337,18 @@
         </p:nvSpPr>
         <p:spPr>
           <a:xfrm>
-            <a:off x="6217920" y="1280160"/>
-            <a:ext cx="5212080" cy="3931920"/>
+            <a:off x="822960" y="5120640"/>
+            <a:ext cx="3337560" cy="1280160"/>
           </a:xfrm>
           <a:prstGeom prst="roundRect">
             <a:avLst/>
           </a:prstGeom>
           <a:solidFill>
-            <a:srgbClr val="FFFFFF"/>
+            <a:srgbClr val="112240"/>
           </a:solidFill>
           <a:ln w="19050">
             <a:solidFill>
-              <a:srgbClr val="E2E8F0"/>
+              <a:srgbClr val="1E3A8A"/>
             </a:solidFill>
           </a:ln>
         </p:spPr>
@@ -3446,8 +3382,8 @@
         </p:nvSpPr>
         <p:spPr>
           <a:xfrm>
-            <a:off x="6400800" y="1444752"/>
-            <a:ext cx="4846320" cy="3602736"/>
+            <a:off x="960120" y="5212080"/>
+            <a:ext cx="3063240" cy="1097280"/>
           </a:xfrm>
           <a:prstGeom prst="rect">
             <a:avLst/>
@@ -3455,127 +3391,32 @@
           <a:noFill/>
         </p:spPr>
         <p:txBody>
-          <a:bodyPr wrap="square" anchor="t">
+          <a:bodyPr wrap="square">
             <a:spAutoFit/>
           </a:bodyPr>
           <a:lstStyle/>
           <a:p>
             <a:pPr>
-              <a:defRPr sz="1400" b="1">
-                <a:solidFill>
-                  <a:srgbClr val="1E3A8A"/>
-                </a:solidFill>
-              </a:defRPr>
-            </a:pPr>
-            <a:r>
-              <a:t>The Autonomous AI-Powered WFM Solution</a:t>
+              <a:defRPr sz="1100" b="1">
+                <a:solidFill>
+                  <a:srgbClr val="0EA5E9"/>
+                </a:solidFill>
+              </a:defRPr>
+            </a:pPr>
+            <a:r>
+              <a:t>⚡ Zero Wait to Leave</a:t>
             </a:r>
           </a:p>
           <a:p>
             <a:pPr>
-              <a:spcAft>
-                <a:spcPts val="800"/>
-              </a:spcAft>
-              <a:defRPr sz="1000" i="1">
-                <a:solidFill>
-                  <a:srgbClr val="64748B"/>
-                </a:solidFill>
-              </a:defRPr>
-            </a:pPr>
-            <a:r>
-              <a:t>Dual Agent &amp; Supervisor Intelligence Ecosystem</a:t>
-            </a:r>
-          </a:p>
-          <a:p>
-            <a:pPr>
-              <a:spcAft>
-                <a:spcPts val="600"/>
-              </a:spcAft>
-              <a:defRPr b="1" sz="1000">
-                <a:solidFill>
-                  <a:srgbClr val="0F172A"/>
-                </a:solidFill>
-              </a:defRPr>
-            </a:pPr>
-            <a:r>
-              <a:t>• AUXY Agent Desktop Copilot: </a:t>
-            </a:r>
-            <a:r>
-              <a:rPr b="0" sz="1000">
-                <a:solidFill>
-                  <a:srgbClr val="64748B"/>
-                </a:solidFill>
-              </a:rPr>
-              <a:t>Always-on-top Electron companion providing 1-click ACW call summarization, live speech tone guidance, and CTI status sync.</a:t>
-            </a:r>
-          </a:p>
-          <a:p>
-            <a:pPr>
-              <a:spcAft>
-                <a:spcPts val="600"/>
-              </a:spcAft>
-              <a:defRPr b="1" sz="1000">
-                <a:solidFill>
-                  <a:srgbClr val="0F172A"/>
-                </a:solidFill>
-              </a:defRPr>
-            </a:pPr>
-            <a:r>
-              <a:t>• Autonomous Break Gatekeeper: </a:t>
-            </a:r>
-            <a:r>
-              <a:rPr b="0" sz="1000">
-                <a:solidFill>
-                  <a:srgbClr val="64748B"/>
-                </a:solidFill>
-              </a:rPr>
-              <a:t>Real-time Erlang-C staffing capacity evaluation approving/throttling tea, bio, and lunch breaks instantly.</a:t>
-            </a:r>
-          </a:p>
-          <a:p>
-            <a:pPr>
-              <a:spcAft>
-                <a:spcPts val="600"/>
-              </a:spcAft>
-              <a:defRPr b="1" sz="1000">
-                <a:solidFill>
-                  <a:srgbClr val="0F172A"/>
-                </a:solidFill>
-              </a:defRPr>
-            </a:pPr>
-            <a:r>
-              <a:t>• Dynamic Cross-Skill Rebalance: </a:t>
-            </a:r>
-            <a:r>
-              <a:rPr b="0" sz="1000">
-                <a:solidFill>
-                  <a:srgbClr val="64748B"/>
-                </a:solidFill>
-              </a:rPr>
-              <a:t>Auto-detects queue load imbalances and reallocates certified cross-skilled agents in real-time, restoring SLAs to 88.5%.</a:t>
-            </a:r>
-          </a:p>
-          <a:p>
-            <a:pPr>
-              <a:spcAft>
-                <a:spcPts val="600"/>
-              </a:spcAft>
-              <a:defRPr b="1" sz="1000">
-                <a:solidFill>
-                  <a:srgbClr val="0F172A"/>
-                </a:solidFill>
-              </a:defRPr>
-            </a:pPr>
-            <a:r>
-              <a:t>• Storm Disaster Auto-Deflection: </a:t>
-            </a:r>
-            <a:r>
-              <a:rPr b="0" sz="1000">
-                <a:solidFill>
-                  <a:srgbClr val="64748B"/>
-                </a:solidFill>
-              </a:rPr>
-              <a:t>Automated front-end IVR speech deflection triggering at 1,000 calls/min, protecting agents during emergency outages.</a:t>
+              <a:defRPr sz="950">
+                <a:solidFill>
+                  <a:srgbClr val="E2E8F0"/>
+                </a:solidFill>
+              </a:defRPr>
+            </a:pPr>
+            <a:r>
+              <a:t>Microsecond Erlang-C capacity gating grants tea/bio breaks instantly without waiting for supervisor chat.</a:t>
             </a:r>
           </a:p>
         </p:txBody>
@@ -3588,18 +3429,18 @@
         </p:nvSpPr>
         <p:spPr>
           <a:xfrm>
-            <a:off x="731520" y="5440680"/>
-            <a:ext cx="10698480" cy="1051560"/>
+            <a:off x="4389120" y="5120640"/>
+            <a:ext cx="3337560" cy="1280160"/>
           </a:xfrm>
           <a:prstGeom prst="roundRect">
             <a:avLst/>
           </a:prstGeom>
           <a:solidFill>
-            <a:srgbClr val="EEF2FF"/>
+            <a:srgbClr val="112240"/>
           </a:solidFill>
-          <a:ln>
+          <a:ln w="19050">
             <a:solidFill>
-              <a:srgbClr val="2563EB"/>
+              <a:srgbClr val="1E3A8A"/>
             </a:solidFill>
           </a:ln>
         </p:spPr>
@@ -3618,30 +3459,148 @@
           </a:fontRef>
         </p:style>
         <p:txBody>
-          <a:bodyPr rtlCol="0" anchor="ctr" wrap="square"/>
-          <a:lstStyle/>
-          <a:p>
-            <a:pPr algn="ctr">
+          <a:bodyPr rtlCol="0" anchor="ctr"/>
+          <a:lstStyle/>
+          <a:p>
+            <a:pPr algn="ctr"/>
+          </a:p>
+        </p:txBody>
+      </p:sp>
+      <p:sp>
+        <p:nvSpPr>
+          <p:cNvPr id="10" name="TextBox 9"/>
+          <p:cNvSpPr txBox="1"/>
+          <p:nvPr/>
+        </p:nvSpPr>
+        <p:spPr>
+          <a:xfrm>
+            <a:off x="4526280" y="5212080"/>
+            <a:ext cx="3063240" cy="1097280"/>
+          </a:xfrm>
+          <a:prstGeom prst="rect">
+            <a:avLst/>
+          </a:prstGeom>
+          <a:noFill/>
+        </p:spPr>
+        <p:txBody>
+          <a:bodyPr wrap="square">
+            <a:spAutoFit/>
+          </a:bodyPr>
+          <a:lstStyle/>
+          <a:p>
+            <a:pPr>
               <a:defRPr sz="1100" b="1">
                 <a:solidFill>
-                  <a:srgbClr val="1E3A8A"/>
-                </a:solidFill>
-              </a:defRPr>
-            </a:pPr>
-            <a:r>
-              <a:t>CORE TRANSFORMATION PRINCIPLE: FROM PASSIVE LOGGING TO AUTONOMOUS QUEUE DEFENSE</a:t>
+                  <a:srgbClr val="0EA5E9"/>
+                </a:solidFill>
+              </a:defRPr>
+            </a:pPr>
+            <a:r>
+              <a:t>🔄 Zero Wait to Return</a:t>
             </a:r>
           </a:p>
           <a:p>
             <a:pPr>
               <a:defRPr sz="950">
                 <a:solidFill>
-                  <a:srgbClr val="0F172A"/>
-                </a:solidFill>
-              </a:defRPr>
-            </a:pPr>
-            <a:r>
-              <a:t>By pairing an always-on floating Agent Copilot with an intelligent Supervisor Telemetry Command Center, the platform replaces guesswork with microsecond Erlang-C mathematical balance, safeguarding SLAs while elevating agent well-being.</a:t>
+                  <a:srgbClr val="E2E8F0"/>
+                </a:solidFill>
+              </a:defRPr>
+            </a:pPr>
+            <a:r>
+              <a:t>Automated desktop voice recalls and countdown timers ensure effortless, prompt return to available state.</a:t>
+            </a:r>
+          </a:p>
+        </p:txBody>
+      </p:sp>
+      <p:sp>
+        <p:nvSpPr>
+          <p:cNvPr id="11" name="Rounded Rectangle 10"/>
+          <p:cNvSpPr/>
+          <p:nvPr/>
+        </p:nvSpPr>
+        <p:spPr>
+          <a:xfrm>
+            <a:off x="7955279" y="5120640"/>
+            <a:ext cx="3337560" cy="1280160"/>
+          </a:xfrm>
+          <a:prstGeom prst="roundRect">
+            <a:avLst/>
+          </a:prstGeom>
+          <a:solidFill>
+            <a:srgbClr val="112240"/>
+          </a:solidFill>
+          <a:ln w="19050">
+            <a:solidFill>
+              <a:srgbClr val="1E3A8A"/>
+            </a:solidFill>
+          </a:ln>
+        </p:spPr>
+        <p:style>
+          <a:lnRef idx="1">
+            <a:schemeClr val="accent1"/>
+          </a:lnRef>
+          <a:fillRef idx="3">
+            <a:schemeClr val="accent1"/>
+          </a:fillRef>
+          <a:effectRef idx="2">
+            <a:schemeClr val="accent1"/>
+          </a:effectRef>
+          <a:fontRef idx="minor">
+            <a:schemeClr val="lt1"/>
+          </a:fontRef>
+        </p:style>
+        <p:txBody>
+          <a:bodyPr rtlCol="0" anchor="ctr"/>
+          <a:lstStyle/>
+          <a:p>
+            <a:pPr algn="ctr"/>
+          </a:p>
+        </p:txBody>
+      </p:sp>
+      <p:sp>
+        <p:nvSpPr>
+          <p:cNvPr id="12" name="TextBox 11"/>
+          <p:cNvSpPr txBox="1"/>
+          <p:nvPr/>
+        </p:nvSpPr>
+        <p:spPr>
+          <a:xfrm>
+            <a:off x="8092439" y="5212080"/>
+            <a:ext cx="3063240" cy="1097280"/>
+          </a:xfrm>
+          <a:prstGeom prst="rect">
+            <a:avLst/>
+          </a:prstGeom>
+          <a:noFill/>
+        </p:spPr>
+        <p:txBody>
+          <a:bodyPr wrap="square">
+            <a:spAutoFit/>
+          </a:bodyPr>
+          <a:lstStyle/>
+          <a:p>
+            <a:pPr>
+              <a:defRPr sz="1100" b="1">
+                <a:solidFill>
+                  <a:srgbClr val="0EA5E9"/>
+                </a:solidFill>
+              </a:defRPr>
+            </a:pPr>
+            <a:r>
+              <a:t>🛡️ Instant Queue Protection</a:t>
+            </a:r>
+          </a:p>
+          <a:p>
+            <a:pPr>
+              <a:defRPr sz="950">
+                <a:solidFill>
+                  <a:srgbClr val="E2E8F0"/>
+                </a:solidFill>
+              </a:defRPr>
+            </a:pPr>
+            <a:r>
+              <a:t>Dynamic skill flex rebalances 300+ surge calls in under 3 minutes, safeguarding customer SLAs.</a:t>
             </a:r>
           </a:p>
         </p:txBody>
@@ -3717,8 +3676,8 @@
         </p:nvSpPr>
         <p:spPr>
           <a:xfrm>
-            <a:off x="731520" y="146304"/>
-            <a:ext cx="10515600" cy="274320"/>
+            <a:off x="731520" y="128016"/>
+            <a:ext cx="10515600" cy="868680"/>
           </a:xfrm>
           <a:prstGeom prst="rect">
             <a:avLst/>
@@ -3739,56 +3698,33 @@
               </a:defRPr>
             </a:pPr>
             <a:r>
-              <a:t>DUAL-PERSONA AGENT &amp; SUPERVISOR ARCHITECTURE</a:t>
-            </a:r>
-          </a:p>
-        </p:txBody>
-      </p:sp>
-      <p:sp>
-        <p:nvSpPr>
-          <p:cNvPr id="4" name="TextBox 3"/>
-          <p:cNvSpPr txBox="1"/>
-          <p:nvPr/>
-        </p:nvSpPr>
-        <p:spPr>
-          <a:xfrm>
-            <a:off x="731520" y="384048"/>
-            <a:ext cx="10515600" cy="548640"/>
-          </a:xfrm>
-          <a:prstGeom prst="rect">
-            <a:avLst/>
-          </a:prstGeom>
-          <a:noFill/>
-        </p:spPr>
-        <p:txBody>
-          <a:bodyPr wrap="square">
-            <a:spAutoFit/>
-          </a:bodyPr>
-          <a:lstStyle/>
+              <a:t>ZERO WAIT TO LEAVE, ZERO WAIT TO RETURN</a:t>
+            </a:r>
+          </a:p>
           <a:p>
             <a:pPr>
-              <a:defRPr sz="2200" b="1">
+              <a:defRPr sz="2100" b="1">
                 <a:solidFill>
                   <a:srgbClr val="FFFFFF"/>
                 </a:solidFill>
               </a:defRPr>
             </a:pPr>
             <a:r>
-              <a:t>Platform Capabilities &amp; Feature Matrix</a:t>
-            </a:r>
-          </a:p>
-        </p:txBody>
-      </p:sp>
-      <p:sp>
-        <p:nvSpPr>
-          <p:cNvPr id="5" name="Rounded Rectangle 4"/>
+              <a:t>How ZEL Works: The Frictionless Break &amp; Return Flow</a:t>
+            </a:r>
+          </a:p>
+        </p:txBody>
+      </p:sp>
+      <p:sp>
+        <p:nvSpPr>
+          <p:cNvPr id="4" name="Rounded Rectangle 3"/>
           <p:cNvSpPr/>
           <p:nvPr/>
         </p:nvSpPr>
         <p:spPr>
           <a:xfrm>
             <a:off x="731520" y="1280160"/>
-            <a:ext cx="5120640" cy="2468880"/>
+            <a:ext cx="2514600" cy="2926080"/>
           </a:xfrm>
           <a:prstGeom prst="roundRect">
             <a:avLst/>
@@ -3796,9 +3732,9 @@
           <a:solidFill>
             <a:srgbClr val="FFFFFF"/>
           </a:solidFill>
-          <a:ln w="19050">
+          <a:ln w="25400">
             <a:solidFill>
-              <a:srgbClr val="E2E8F0"/>
+              <a:srgbClr val="2563EB"/>
             </a:solidFill>
           </a:ln>
         </p:spPr>
@@ -3826,14 +3762,68 @@
       </p:sp>
       <p:sp>
         <p:nvSpPr>
+          <p:cNvPr id="5" name="Rounded Rectangle 4"/>
+          <p:cNvSpPr/>
+          <p:nvPr/>
+        </p:nvSpPr>
+        <p:spPr>
+          <a:xfrm>
+            <a:off x="868680" y="1417320"/>
+            <a:ext cx="2240280" cy="384048"/>
+          </a:xfrm>
+          <a:prstGeom prst="roundRect">
+            <a:avLst/>
+          </a:prstGeom>
+          <a:solidFill>
+            <a:srgbClr val="2563EB"/>
+          </a:solidFill>
+          <a:ln>
+            <a:solidFill>
+              <a:srgbClr val="2563EB"/>
+            </a:solidFill>
+          </a:ln>
+        </p:spPr>
+        <p:style>
+          <a:lnRef idx="1">
+            <a:schemeClr val="accent1"/>
+          </a:lnRef>
+          <a:fillRef idx="3">
+            <a:schemeClr val="accent1"/>
+          </a:fillRef>
+          <a:effectRef idx="2">
+            <a:schemeClr val="accent1"/>
+          </a:effectRef>
+          <a:fontRef idx="minor">
+            <a:schemeClr val="lt1"/>
+          </a:fontRef>
+        </p:style>
+        <p:txBody>
+          <a:bodyPr rtlCol="0" anchor="ctr"/>
+          <a:lstStyle/>
+          <a:p>
+            <a:pPr algn="ctr">
+              <a:defRPr sz="1100" b="1">
+                <a:solidFill>
+                  <a:srgbClr val="FFFFFF"/>
+                </a:solidFill>
+              </a:defRPr>
+            </a:pPr>
+            <a:r>
+              <a:t>Step 1: 1-Click Request</a:t>
+            </a:r>
+          </a:p>
+        </p:txBody>
+      </p:sp>
+      <p:sp>
+        <p:nvSpPr>
           <p:cNvPr id="6" name="TextBox 5"/>
           <p:cNvSpPr txBox="1"/>
           <p:nvPr/>
         </p:nvSpPr>
         <p:spPr>
           <a:xfrm>
-            <a:off x="914400" y="1444752"/>
-            <a:ext cx="4754880" cy="2139696"/>
+            <a:off x="868680" y="1874519"/>
+            <a:ext cx="2240280" cy="2194560"/>
           </a:xfrm>
           <a:prstGeom prst="rect">
             <a:avLst/>
@@ -3841,109 +3831,121 @@
           <a:noFill/>
         </p:spPr>
         <p:txBody>
-          <a:bodyPr wrap="square" anchor="t">
+          <a:bodyPr wrap="square">
             <a:spAutoFit/>
           </a:bodyPr>
           <a:lstStyle/>
-          <a:p>
-            <a:pPr>
-              <a:defRPr sz="1400" b="1">
-                <a:solidFill>
-                  <a:srgbClr val="1E3A8A"/>
-                </a:solidFill>
-              </a:defRPr>
-            </a:pPr>
-            <a:r>
-              <a:t>1. Agent AI Desktop Copilot (AUXY)</a:t>
-            </a:r>
-          </a:p>
           <a:p>
             <a:pPr>
               <a:spcAft>
                 <a:spcPts val="800"/>
               </a:spcAft>
-              <a:defRPr sz="1000" i="1">
-                <a:solidFill>
-                  <a:srgbClr val="64748B"/>
-                </a:solidFill>
-              </a:defRPr>
-            </a:pPr>
-            <a:r>
-              <a:t>Companion Widget for Front-Line Staff</a:t>
+              <a:defRPr sz="1000" b="1">
+                <a:solidFill>
+                  <a:srgbClr val="0F172A"/>
+                </a:solidFill>
+              </a:defRPr>
+            </a:pPr>
+            <a:r>
+              <a:t>Action:</a:t>
+            </a:r>
+            <a:br/>
+            <a:r>
+              <a:t>Agent selects Break in floating widget</a:t>
             </a:r>
           </a:p>
           <a:p>
             <a:pPr>
               <a:spcAft>
-                <a:spcPts val="300"/>
+                <a:spcPts val="800"/>
               </a:spcAft>
               <a:defRPr sz="950">
                 <a:solidFill>
-                  <a:srgbClr val="0F172A"/>
-                </a:solidFill>
-              </a:defRPr>
-            </a:pPr>
-            <a:r>
-              <a:t>✔ Instant ACW Summarizer: Auto-generates structured CRM wrap-up notes.</a:t>
+                  <a:srgbClr val="64748B"/>
+                </a:solidFill>
+              </a:defRPr>
+            </a:pPr>
+            <a:r>
+              <a:t>Feature:</a:t>
+            </a:r>
+            <a:br/>
+            <a:r>
+              <a:t>• Tea, Bio, Lunch, or System Issue</a:t>
             </a:r>
           </a:p>
           <a:p>
             <a:pPr>
-              <a:spcAft>
-                <a:spcPts val="300"/>
-              </a:spcAft>
-              <a:defRPr sz="950">
-                <a:solidFill>
-                  <a:srgbClr val="0F172A"/>
-                </a:solidFill>
-              </a:defRPr>
-            </a:pPr>
-            <a:r>
-              <a:t>✔ Live Speech Suggestions: Real-time objections handling and compliance prompts.</a:t>
-            </a:r>
-          </a:p>
-          <a:p>
-            <a:pPr>
-              <a:spcAft>
-                <a:spcPts val="300"/>
-              </a:spcAft>
-              <a:defRPr sz="950">
-                <a:solidFill>
-                  <a:srgbClr val="0F172A"/>
-                </a:solidFill>
-              </a:defRPr>
-            </a:pPr>
-            <a:r>
-              <a:t>✔ Discretionary Break Portal: Autonomous 15-minute Erlang-C capacity grant.</a:t>
-            </a:r>
-          </a:p>
-          <a:p>
-            <a:pPr>
-              <a:spcAft>
-                <a:spcPts val="300"/>
-              </a:spcAft>
-              <a:defRPr sz="950">
-                <a:solidFill>
-                  <a:srgbClr val="0F172A"/>
-                </a:solidFill>
-              </a:defRPr>
-            </a:pPr>
-            <a:r>
-              <a:t>✔ IT Hardware Issue Log (AUX-5): Direct Citrix/VPN/audio incident ticketing.</a:t>
-            </a:r>
-          </a:p>
-        </p:txBody>
-      </p:sp>
-      <p:sp>
-        <p:nvSpPr>
-          <p:cNvPr id="7" name="Rounded Rectangle 6"/>
+              <a:defRPr sz="950" b="1">
+                <a:solidFill>
+                  <a:srgbClr val="059669"/>
+                </a:solidFill>
+              </a:defRPr>
+            </a:pPr>
+            <a:r>
+              <a:t>Outcome:</a:t>
+            </a:r>
+            <a:br/>
+            <a:r>
+              <a:t>✔ Agent never leaves workspace</a:t>
+            </a:r>
+          </a:p>
+        </p:txBody>
+      </p:sp>
+      <p:sp>
+        <p:nvSpPr>
+          <p:cNvPr id="7" name="Chevron 6"/>
           <p:cNvSpPr/>
           <p:nvPr/>
         </p:nvSpPr>
         <p:spPr>
           <a:xfrm>
-            <a:off x="6217920" y="1280160"/>
-            <a:ext cx="5212080" cy="2468880"/>
+            <a:off x="3273552" y="2560320"/>
+            <a:ext cx="164592" cy="320040"/>
+          </a:xfrm>
+          <a:prstGeom prst="chevron">
+            <a:avLst/>
+          </a:prstGeom>
+          <a:solidFill>
+            <a:srgbClr val="2563EB"/>
+          </a:solidFill>
+          <a:ln>
+            <a:solidFill>
+              <a:srgbClr val="2563EB"/>
+            </a:solidFill>
+          </a:ln>
+        </p:spPr>
+        <p:style>
+          <a:lnRef idx="1">
+            <a:schemeClr val="accent1"/>
+          </a:lnRef>
+          <a:fillRef idx="3">
+            <a:schemeClr val="accent1"/>
+          </a:fillRef>
+          <a:effectRef idx="2">
+            <a:schemeClr val="accent1"/>
+          </a:effectRef>
+          <a:fontRef idx="minor">
+            <a:schemeClr val="lt1"/>
+          </a:fontRef>
+        </p:style>
+        <p:txBody>
+          <a:bodyPr rtlCol="0" anchor="ctr"/>
+          <a:lstStyle/>
+          <a:p>
+            <a:pPr algn="ctr"/>
+          </a:p>
+        </p:txBody>
+      </p:sp>
+      <p:sp>
+        <p:nvSpPr>
+          <p:cNvPr id="8" name="Rounded Rectangle 7"/>
+          <p:cNvSpPr/>
+          <p:nvPr/>
+        </p:nvSpPr>
+        <p:spPr>
+          <a:xfrm>
+            <a:off x="3429000" y="1280160"/>
+            <a:ext cx="2514600" cy="2926080"/>
           </a:xfrm>
           <a:prstGeom prst="roundRect">
             <a:avLst/>
@@ -3951,9 +3953,9 @@
           <a:solidFill>
             <a:srgbClr val="FFFFFF"/>
           </a:solidFill>
-          <a:ln w="19050">
+          <a:ln w="25400">
             <a:solidFill>
-              <a:srgbClr val="E2E8F0"/>
+              <a:srgbClr val="059669"/>
             </a:solidFill>
           </a:ln>
         </p:spPr>
@@ -3981,14 +3983,68 @@
       </p:sp>
       <p:sp>
         <p:nvSpPr>
-          <p:cNvPr id="8" name="TextBox 7"/>
+          <p:cNvPr id="9" name="Rounded Rectangle 8"/>
+          <p:cNvSpPr/>
+          <p:nvPr/>
+        </p:nvSpPr>
+        <p:spPr>
+          <a:xfrm>
+            <a:off x="3566160" y="1417320"/>
+            <a:ext cx="2240280" cy="384048"/>
+          </a:xfrm>
+          <a:prstGeom prst="roundRect">
+            <a:avLst/>
+          </a:prstGeom>
+          <a:solidFill>
+            <a:srgbClr val="059669"/>
+          </a:solidFill>
+          <a:ln>
+            <a:solidFill>
+              <a:srgbClr val="059669"/>
+            </a:solidFill>
+          </a:ln>
+        </p:spPr>
+        <p:style>
+          <a:lnRef idx="1">
+            <a:schemeClr val="accent1"/>
+          </a:lnRef>
+          <a:fillRef idx="3">
+            <a:schemeClr val="accent1"/>
+          </a:fillRef>
+          <a:effectRef idx="2">
+            <a:schemeClr val="accent1"/>
+          </a:effectRef>
+          <a:fontRef idx="minor">
+            <a:schemeClr val="lt1"/>
+          </a:fontRef>
+        </p:style>
+        <p:txBody>
+          <a:bodyPr rtlCol="0" anchor="ctr"/>
+          <a:lstStyle/>
+          <a:p>
+            <a:pPr algn="ctr">
+              <a:defRPr sz="1100" b="1">
+                <a:solidFill>
+                  <a:srgbClr val="FFFFFF"/>
+                </a:solidFill>
+              </a:defRPr>
+            </a:pPr>
+            <a:r>
+              <a:t>Step 2: Instant Gating</a:t>
+            </a:r>
+          </a:p>
+        </p:txBody>
+      </p:sp>
+      <p:sp>
+        <p:nvSpPr>
+          <p:cNvPr id="10" name="TextBox 9"/>
           <p:cNvSpPr txBox="1"/>
           <p:nvPr/>
         </p:nvSpPr>
         <p:spPr>
           <a:xfrm>
-            <a:off x="6400800" y="1444752"/>
-            <a:ext cx="4846320" cy="2139696"/>
+            <a:off x="3566160" y="1874519"/>
+            <a:ext cx="2240280" cy="2194560"/>
           </a:xfrm>
           <a:prstGeom prst="rect">
             <a:avLst/>
@@ -3996,109 +4052,121 @@
           <a:noFill/>
         </p:spPr>
         <p:txBody>
-          <a:bodyPr wrap="square" anchor="t">
+          <a:bodyPr wrap="square">
             <a:spAutoFit/>
           </a:bodyPr>
           <a:lstStyle/>
-          <a:p>
-            <a:pPr>
-              <a:defRPr sz="1400" b="1">
-                <a:solidFill>
-                  <a:srgbClr val="1E3A8A"/>
-                </a:solidFill>
-              </a:defRPr>
-            </a:pPr>
-            <a:r>
-              <a:t>2. Supervisor Floor Command Center</a:t>
-            </a:r>
-          </a:p>
           <a:p>
             <a:pPr>
               <a:spcAft>
                 <a:spcPts val="800"/>
               </a:spcAft>
-              <a:defRPr sz="1000" i="1">
-                <a:solidFill>
-                  <a:srgbClr val="64748B"/>
-                </a:solidFill>
-              </a:defRPr>
-            </a:pPr>
-            <a:r>
-              <a:t>Live Telemetry &amp; Team Governance</a:t>
+              <a:defRPr sz="1000" b="1">
+                <a:solidFill>
+                  <a:srgbClr val="0F172A"/>
+                </a:solidFill>
+              </a:defRPr>
+            </a:pPr>
+            <a:r>
+              <a:t>Action:</a:t>
+            </a:r>
+            <a:br/>
+            <a:r>
+              <a:t>Erlang-C math checks live floor queue</a:t>
             </a:r>
           </a:p>
           <a:p>
             <a:pPr>
               <a:spcAft>
-                <a:spcPts val="300"/>
+                <a:spcPts val="800"/>
               </a:spcAft>
               <a:defRPr sz="950">
                 <a:solidFill>
-                  <a:srgbClr val="0F172A"/>
-                </a:solidFill>
-              </a:defRPr>
-            </a:pPr>
-            <a:r>
-              <a:t>✔ Floor Telemetry Wallboard: Synchronized with NICE CXone MAX CTI engine.</a:t>
+                  <a:srgbClr val="64748B"/>
+                </a:solidFill>
+              </a:defRPr>
+            </a:pPr>
+            <a:r>
+              <a:t>Feature:</a:t>
+            </a:r>
+            <a:br/>
+            <a:r>
+              <a:t>• Capacity &gt; 80% = Instant 15m grant</a:t>
             </a:r>
           </a:p>
           <a:p>
             <a:pPr>
-              <a:spcAft>
-                <a:spcPts val="300"/>
-              </a:spcAft>
-              <a:defRPr sz="950">
-                <a:solidFill>
-                  <a:srgbClr val="0F172A"/>
-                </a:solidFill>
-              </a:defRPr>
-            </a:pPr>
-            <a:r>
-              <a:t>✔ Scoped Team Tagging: Specific agents routed to dedicated supervisors.</a:t>
-            </a:r>
-          </a:p>
-          <a:p>
-            <a:pPr>
-              <a:spcAft>
-                <a:spcPts val="300"/>
-              </a:spcAft>
-              <a:defRPr sz="950">
-                <a:solidFill>
-                  <a:srgbClr val="0F172A"/>
-                </a:solidFill>
-              </a:defRPr>
-            </a:pPr>
-            <a:r>
-              <a:t>✔ Automated Voice Bot Recall: Dispatches immediate synthesized call to desk.</a:t>
-            </a:r>
-          </a:p>
-          <a:p>
-            <a:pPr>
-              <a:spcAft>
-                <a:spcPts val="300"/>
-              </a:spcAft>
-              <a:defRPr sz="950">
-                <a:solidFill>
-                  <a:srgbClr val="0F172A"/>
-                </a:solidFill>
-              </a:defRPr>
-            </a:pPr>
-            <a:r>
-              <a:t>✔ Shift Adherence Governance: Policy guardrails for lunch and tea limits.</a:t>
-            </a:r>
-          </a:p>
-        </p:txBody>
-      </p:sp>
-      <p:sp>
-        <p:nvSpPr>
-          <p:cNvPr id="9" name="Rounded Rectangle 8"/>
+              <a:defRPr sz="950" b="1">
+                <a:solidFill>
+                  <a:srgbClr val="059669"/>
+                </a:solidFill>
+              </a:defRPr>
+            </a:pPr>
+            <a:r>
+              <a:t>Outcome:</a:t>
+            </a:r>
+            <a:br/>
+            <a:r>
+              <a:t>✔ Zero waiting for manual sign-off</a:t>
+            </a:r>
+          </a:p>
+        </p:txBody>
+      </p:sp>
+      <p:sp>
+        <p:nvSpPr>
+          <p:cNvPr id="11" name="Chevron 10"/>
           <p:cNvSpPr/>
           <p:nvPr/>
         </p:nvSpPr>
         <p:spPr>
           <a:xfrm>
-            <a:off x="731520" y="3977639"/>
-            <a:ext cx="5120640" cy="2468880"/>
+            <a:off x="5971032" y="2560320"/>
+            <a:ext cx="164592" cy="320040"/>
+          </a:xfrm>
+          <a:prstGeom prst="chevron">
+            <a:avLst/>
+          </a:prstGeom>
+          <a:solidFill>
+            <a:srgbClr val="2563EB"/>
+          </a:solidFill>
+          <a:ln>
+            <a:solidFill>
+              <a:srgbClr val="2563EB"/>
+            </a:solidFill>
+          </a:ln>
+        </p:spPr>
+        <p:style>
+          <a:lnRef idx="1">
+            <a:schemeClr val="accent1"/>
+          </a:lnRef>
+          <a:fillRef idx="3">
+            <a:schemeClr val="accent1"/>
+          </a:fillRef>
+          <a:effectRef idx="2">
+            <a:schemeClr val="accent1"/>
+          </a:effectRef>
+          <a:fontRef idx="minor">
+            <a:schemeClr val="lt1"/>
+          </a:fontRef>
+        </p:style>
+        <p:txBody>
+          <a:bodyPr rtlCol="0" anchor="ctr"/>
+          <a:lstStyle/>
+          <a:p>
+            <a:pPr algn="ctr"/>
+          </a:p>
+        </p:txBody>
+      </p:sp>
+      <p:sp>
+        <p:nvSpPr>
+          <p:cNvPr id="12" name="Rounded Rectangle 11"/>
+          <p:cNvSpPr/>
+          <p:nvPr/>
+        </p:nvSpPr>
+        <p:spPr>
+          <a:xfrm>
+            <a:off x="6126480" y="1280160"/>
+            <a:ext cx="2514600" cy="2926080"/>
           </a:xfrm>
           <a:prstGeom prst="roundRect">
             <a:avLst/>
@@ -4106,9 +4174,9 @@
           <a:solidFill>
             <a:srgbClr val="FFFFFF"/>
           </a:solidFill>
-          <a:ln w="19050">
+          <a:ln w="25400">
             <a:solidFill>
-              <a:srgbClr val="E2E8F0"/>
+              <a:srgbClr val="0EA5E9"/>
             </a:solidFill>
           </a:ln>
         </p:spPr>
@@ -4136,14 +4204,68 @@
       </p:sp>
       <p:sp>
         <p:nvSpPr>
-          <p:cNvPr id="10" name="TextBox 9"/>
+          <p:cNvPr id="13" name="Rounded Rectangle 12"/>
+          <p:cNvSpPr/>
+          <p:nvPr/>
+        </p:nvSpPr>
+        <p:spPr>
+          <a:xfrm>
+            <a:off x="6263640" y="1417320"/>
+            <a:ext cx="2240280" cy="384048"/>
+          </a:xfrm>
+          <a:prstGeom prst="roundRect">
+            <a:avLst/>
+          </a:prstGeom>
+          <a:solidFill>
+            <a:srgbClr val="0EA5E9"/>
+          </a:solidFill>
+          <a:ln>
+            <a:solidFill>
+              <a:srgbClr val="0EA5E9"/>
+            </a:solidFill>
+          </a:ln>
+        </p:spPr>
+        <p:style>
+          <a:lnRef idx="1">
+            <a:schemeClr val="accent1"/>
+          </a:lnRef>
+          <a:fillRef idx="3">
+            <a:schemeClr val="accent1"/>
+          </a:fillRef>
+          <a:effectRef idx="2">
+            <a:schemeClr val="accent1"/>
+          </a:effectRef>
+          <a:fontRef idx="minor">
+            <a:schemeClr val="lt1"/>
+          </a:fontRef>
+        </p:style>
+        <p:txBody>
+          <a:bodyPr rtlCol="0" anchor="ctr"/>
+          <a:lstStyle/>
+          <a:p>
+            <a:pPr algn="ctr">
+              <a:defRPr sz="1100" b="1">
+                <a:solidFill>
+                  <a:srgbClr val="FFFFFF"/>
+                </a:solidFill>
+              </a:defRPr>
+            </a:pPr>
+            <a:r>
+              <a:t>Step 3: Rest Interval</a:t>
+            </a:r>
+          </a:p>
+        </p:txBody>
+      </p:sp>
+      <p:sp>
+        <p:nvSpPr>
+          <p:cNvPr id="14" name="TextBox 13"/>
           <p:cNvSpPr txBox="1"/>
           <p:nvPr/>
         </p:nvSpPr>
         <p:spPr>
           <a:xfrm>
-            <a:off x="914400" y="4142231"/>
-            <a:ext cx="4754880" cy="2139696"/>
+            <a:off x="6263640" y="1874519"/>
+            <a:ext cx="2240280" cy="2194560"/>
           </a:xfrm>
           <a:prstGeom prst="rect">
             <a:avLst/>
@@ -4151,109 +4273,121 @@
           <a:noFill/>
         </p:spPr>
         <p:txBody>
-          <a:bodyPr wrap="square" anchor="t">
+          <a:bodyPr wrap="square">
             <a:spAutoFit/>
           </a:bodyPr>
           <a:lstStyle/>
-          <a:p>
-            <a:pPr>
-              <a:defRPr sz="1400" b="1">
-                <a:solidFill>
-                  <a:srgbClr val="1E3A8A"/>
-                </a:solidFill>
-              </a:defRPr>
-            </a:pPr>
-            <a:r>
-              <a:t>3. Dynamic WFM Skill Flex Engine</a:t>
-            </a:r>
-          </a:p>
           <a:p>
             <a:pPr>
               <a:spcAft>
                 <a:spcPts val="800"/>
               </a:spcAft>
-              <a:defRPr sz="1000" i="1">
-                <a:solidFill>
-                  <a:srgbClr val="64748B"/>
-                </a:solidFill>
-              </a:defRPr>
-            </a:pPr>
-            <a:r>
-              <a:t>Intraday Queue Balancing &amp; Surge Defense</a:t>
+              <a:defRPr sz="1000" b="1">
+                <a:solidFill>
+                  <a:srgbClr val="0F172A"/>
+                </a:solidFill>
+              </a:defRPr>
+            </a:pPr>
+            <a:r>
+              <a:t>Action:</a:t>
+            </a:r>
+            <a:br/>
+            <a:r>
+              <a:t>Widget tracks active rest interval</a:t>
             </a:r>
           </a:p>
           <a:p>
             <a:pPr>
               <a:spcAft>
-                <a:spcPts val="300"/>
+                <a:spcPts val="800"/>
               </a:spcAft>
               <a:defRPr sz="950">
                 <a:solidFill>
-                  <a:srgbClr val="0F172A"/>
-                </a:solidFill>
-              </a:defRPr>
-            </a:pPr>
-            <a:r>
-              <a:t>✔ 6 Telephony Queues: Billing, Support, Emergency, CS, Bilingual, Collections.</a:t>
+                  <a:srgbClr val="64748B"/>
+                </a:solidFill>
+              </a:defRPr>
+            </a:pPr>
+            <a:r>
+              <a:t>Feature:</a:t>
+            </a:r>
+            <a:br/>
+            <a:r>
+              <a:t>• Real-time countdown timer displayed</a:t>
             </a:r>
           </a:p>
           <a:p>
             <a:pPr>
-              <a:spcAft>
-                <a:spcPts val="300"/>
-              </a:spcAft>
-              <a:defRPr sz="950">
-                <a:solidFill>
-                  <a:srgbClr val="0F172A"/>
-                </a:solidFill>
-              </a:defRPr>
-            </a:pPr>
-            <a:r>
-              <a:t>✔ Surge Simulation: Simulates +318 calls spike (ASA 9m, SLA drop to 34.5%).</a:t>
-            </a:r>
-          </a:p>
-          <a:p>
-            <a:pPr>
-              <a:spcAft>
-                <a:spcPts val="300"/>
-              </a:spcAft>
-              <a:defRPr sz="950">
-                <a:solidFill>
-                  <a:srgbClr val="0F172A"/>
-                </a:solidFill>
-              </a:defRPr>
-            </a:pPr>
-            <a:r>
-              <a:t>✔ 1-Click Cross-Skilling: Flexes 3 idle CS agents to Billing in microsecond sync.</a:t>
-            </a:r>
-          </a:p>
-          <a:p>
-            <a:pPr>
-              <a:spcAft>
-                <a:spcPts val="300"/>
-              </a:spcAft>
-              <a:defRPr sz="950">
-                <a:solidFill>
-                  <a:srgbClr val="0F172A"/>
-                </a:solidFill>
-              </a:defRPr>
-            </a:pPr>
-            <a:r>
-              <a:t>✔ Volume Normalization: 1-click restore to base schedules when traffic clears.</a:t>
-            </a:r>
-          </a:p>
-        </p:txBody>
-      </p:sp>
-      <p:sp>
-        <p:nvSpPr>
-          <p:cNvPr id="11" name="Rounded Rectangle 10"/>
+              <a:defRPr sz="950" b="1">
+                <a:solidFill>
+                  <a:srgbClr val="059669"/>
+                </a:solidFill>
+              </a:defRPr>
+            </a:pPr>
+            <a:r>
+              <a:t>Outcome:</a:t>
+            </a:r>
+            <a:br/>
+            <a:r>
+              <a:t>✔ Fatigue mitigation &amp; compliance</a:t>
+            </a:r>
+          </a:p>
+        </p:txBody>
+      </p:sp>
+      <p:sp>
+        <p:nvSpPr>
+          <p:cNvPr id="15" name="Chevron 14"/>
           <p:cNvSpPr/>
           <p:nvPr/>
         </p:nvSpPr>
         <p:spPr>
           <a:xfrm>
-            <a:off x="6217920" y="3977639"/>
-            <a:ext cx="5212080" cy="2468880"/>
+            <a:off x="8668512" y="2560320"/>
+            <a:ext cx="164592" cy="320040"/>
+          </a:xfrm>
+          <a:prstGeom prst="chevron">
+            <a:avLst/>
+          </a:prstGeom>
+          <a:solidFill>
+            <a:srgbClr val="2563EB"/>
+          </a:solidFill>
+          <a:ln>
+            <a:solidFill>
+              <a:srgbClr val="2563EB"/>
+            </a:solidFill>
+          </a:ln>
+        </p:spPr>
+        <p:style>
+          <a:lnRef idx="1">
+            <a:schemeClr val="accent1"/>
+          </a:lnRef>
+          <a:fillRef idx="3">
+            <a:schemeClr val="accent1"/>
+          </a:fillRef>
+          <a:effectRef idx="2">
+            <a:schemeClr val="accent1"/>
+          </a:effectRef>
+          <a:fontRef idx="minor">
+            <a:schemeClr val="lt1"/>
+          </a:fontRef>
+        </p:style>
+        <p:txBody>
+          <a:bodyPr rtlCol="0" anchor="ctr"/>
+          <a:lstStyle/>
+          <a:p>
+            <a:pPr algn="ctr"/>
+          </a:p>
+        </p:txBody>
+      </p:sp>
+      <p:sp>
+        <p:nvSpPr>
+          <p:cNvPr id="16" name="Rounded Rectangle 15"/>
+          <p:cNvSpPr/>
+          <p:nvPr/>
+        </p:nvSpPr>
+        <p:spPr>
+          <a:xfrm>
+            <a:off x="8823960" y="1280160"/>
+            <a:ext cx="2514600" cy="2926080"/>
           </a:xfrm>
           <a:prstGeom prst="roundRect">
             <a:avLst/>
@@ -4261,9 +4395,9 @@
           <a:solidFill>
             <a:srgbClr val="FFFFFF"/>
           </a:solidFill>
-          <a:ln w="19050">
+          <a:ln w="25400">
             <a:solidFill>
-              <a:srgbClr val="E2E8F0"/>
+              <a:srgbClr val="1E3A8A"/>
             </a:solidFill>
           </a:ln>
         </p:spPr>
@@ -4291,14 +4425,68 @@
       </p:sp>
       <p:sp>
         <p:nvSpPr>
-          <p:cNvPr id="12" name="TextBox 11"/>
+          <p:cNvPr id="17" name="Rounded Rectangle 16"/>
+          <p:cNvSpPr/>
+          <p:nvPr/>
+        </p:nvSpPr>
+        <p:spPr>
+          <a:xfrm>
+            <a:off x="8961120" y="1417320"/>
+            <a:ext cx="2240280" cy="384048"/>
+          </a:xfrm>
+          <a:prstGeom prst="roundRect">
+            <a:avLst/>
+          </a:prstGeom>
+          <a:solidFill>
+            <a:srgbClr val="1E3A8A"/>
+          </a:solidFill>
+          <a:ln>
+            <a:solidFill>
+              <a:srgbClr val="1E3A8A"/>
+            </a:solidFill>
+          </a:ln>
+        </p:spPr>
+        <p:style>
+          <a:lnRef idx="1">
+            <a:schemeClr val="accent1"/>
+          </a:lnRef>
+          <a:fillRef idx="3">
+            <a:schemeClr val="accent1"/>
+          </a:fillRef>
+          <a:effectRef idx="2">
+            <a:schemeClr val="accent1"/>
+          </a:effectRef>
+          <a:fontRef idx="minor">
+            <a:schemeClr val="lt1"/>
+          </a:fontRef>
+        </p:style>
+        <p:txBody>
+          <a:bodyPr rtlCol="0" anchor="ctr"/>
+          <a:lstStyle/>
+          <a:p>
+            <a:pPr algn="ctr">
+              <a:defRPr sz="1100" b="1">
+                <a:solidFill>
+                  <a:srgbClr val="FFFFFF"/>
+                </a:solidFill>
+              </a:defRPr>
+            </a:pPr>
+            <a:r>
+              <a:t>Step 4: Prompt Return</a:t>
+            </a:r>
+          </a:p>
+        </p:txBody>
+      </p:sp>
+      <p:sp>
+        <p:nvSpPr>
+          <p:cNvPr id="18" name="TextBox 17"/>
           <p:cNvSpPr txBox="1"/>
           <p:nvPr/>
         </p:nvSpPr>
         <p:spPr>
           <a:xfrm>
-            <a:off x="6400800" y="4142231"/>
-            <a:ext cx="4846320" cy="2139696"/>
+            <a:off x="8961120" y="1874519"/>
+            <a:ext cx="2240280" cy="2194560"/>
           </a:xfrm>
           <a:prstGeom prst="rect">
             <a:avLst/>
@@ -4306,95 +4494,172 @@
           <a:noFill/>
         </p:spPr>
         <p:txBody>
-          <a:bodyPr wrap="square" anchor="t">
+          <a:bodyPr wrap="square">
             <a:spAutoFit/>
           </a:bodyPr>
           <a:lstStyle/>
-          <a:p>
-            <a:pPr>
-              <a:defRPr sz="1400" b="1">
-                <a:solidFill>
-                  <a:srgbClr val="1E3A8A"/>
-                </a:solidFill>
-              </a:defRPr>
-            </a:pPr>
-            <a:r>
-              <a:t>4. QA Speech Sentiment &amp; IVR Deflection</a:t>
-            </a:r>
-          </a:p>
           <a:p>
             <a:pPr>
               <a:spcAft>
                 <a:spcPts val="800"/>
               </a:spcAft>
-              <a:defRPr sz="1000" i="1">
-                <a:solidFill>
-                  <a:srgbClr val="64748B"/>
-                </a:solidFill>
-              </a:defRPr>
-            </a:pPr>
-            <a:r>
-              <a:t>Quality Auditing &amp; Disaster Resilience</a:t>
+              <a:defRPr sz="1000" b="1">
+                <a:solidFill>
+                  <a:srgbClr val="0F172A"/>
+                </a:solidFill>
+              </a:defRPr>
+            </a:pPr>
+            <a:r>
+              <a:t>Action:</a:t>
+            </a:r>
+            <a:br/>
+            <a:r>
+              <a:t>Smart alert &amp; voice bot prompt to desk</a:t>
             </a:r>
           </a:p>
           <a:p>
             <a:pPr>
               <a:spcAft>
-                <a:spcPts val="300"/>
+                <a:spcPts val="800"/>
               </a:spcAft>
               <a:defRPr sz="950">
                 <a:solidFill>
-                  <a:srgbClr val="0F172A"/>
-                </a:solidFill>
-              </a:defRPr>
-            </a:pPr>
-            <a:r>
-              <a:t>✔ Speech Sentiment Detection: Classifies Empathetic, Neutral, Rude, or Bad tone.</a:t>
-            </a:r>
-          </a:p>
+                  <a:srgbClr val="64748B"/>
+                </a:solidFill>
+              </a:defRPr>
+            </a:pPr>
+            <a:r>
+              <a:t>Feature:</a:t>
+            </a:r>
+            <a:br/>
+            <a:r>
+              <a:t>• 1-Click switch back to Available</a:t>
+            </a:r>
+          </a:p>
+          <a:p>
+            <a:pPr>
+              <a:defRPr sz="950" b="1">
+                <a:solidFill>
+                  <a:srgbClr val="059669"/>
+                </a:solidFill>
+              </a:defRPr>
+            </a:pPr>
+            <a:r>
+              <a:t>Outcome:</a:t>
+            </a:r>
+            <a:br/>
+            <a:r>
+              <a:t>✔ Zero wait to resume calls</a:t>
+            </a:r>
+          </a:p>
+        </p:txBody>
+      </p:sp>
+      <p:sp>
+        <p:nvSpPr>
+          <p:cNvPr id="19" name="Rounded Rectangle 18"/>
+          <p:cNvSpPr/>
+          <p:nvPr/>
+        </p:nvSpPr>
+        <p:spPr>
+          <a:xfrm>
+            <a:off x="731520" y="4389120"/>
+            <a:ext cx="10698480" cy="2103120"/>
+          </a:xfrm>
+          <a:prstGeom prst="roundRect">
+            <a:avLst/>
+          </a:prstGeom>
+          <a:solidFill>
+            <a:srgbClr val="F1F5F9"/>
+          </a:solidFill>
+          <a:ln>
+            <a:solidFill>
+              <a:srgbClr val="E2E8F0"/>
+            </a:solidFill>
+          </a:ln>
+        </p:spPr>
+        <p:style>
+          <a:lnRef idx="1">
+            <a:schemeClr val="accent1"/>
+          </a:lnRef>
+          <a:fillRef idx="3">
+            <a:schemeClr val="accent1"/>
+          </a:fillRef>
+          <a:effectRef idx="2">
+            <a:schemeClr val="accent1"/>
+          </a:effectRef>
+          <a:fontRef idx="minor">
+            <a:schemeClr val="lt1"/>
+          </a:fontRef>
+        </p:style>
+        <p:txBody>
+          <a:bodyPr rtlCol="0" anchor="ctr"/>
+          <a:lstStyle/>
+          <a:p>
+            <a:pPr algn="ctr"/>
+          </a:p>
+        </p:txBody>
+      </p:sp>
+      <p:sp>
+        <p:nvSpPr>
+          <p:cNvPr id="20" name="TextBox 19"/>
+          <p:cNvSpPr txBox="1"/>
+          <p:nvPr/>
+        </p:nvSpPr>
+        <p:spPr>
+          <a:xfrm>
+            <a:off x="914400" y="4480560"/>
+            <a:ext cx="10332720" cy="1920240"/>
+          </a:xfrm>
+          <a:prstGeom prst="rect">
+            <a:avLst/>
+          </a:prstGeom>
+          <a:noFill/>
+        </p:spPr>
+        <p:txBody>
+          <a:bodyPr wrap="square">
+            <a:spAutoFit/>
+          </a:bodyPr>
+          <a:lstStyle/>
           <a:p>
             <a:pPr>
               <a:spcAft>
-                <a:spcPts val="300"/>
+                <a:spcPts val="600"/>
+              </a:spcAft>
+              <a:defRPr sz="1100" b="1">
+                <a:solidFill>
+                  <a:srgbClr val="1E3A8A"/>
+                </a:solidFill>
+              </a:defRPr>
+            </a:pPr>
+            <a:r>
+              <a:t>TRADITIONAL BREAK PROCESS VS. ZEL AUTONOMOUS EXPERIENCE</a:t>
+            </a:r>
+          </a:p>
+          <a:p>
+            <a:pPr>
+              <a:spcAft>
+                <a:spcPts val="400"/>
               </a:spcAft>
               <a:defRPr sz="950">
                 <a:solidFill>
-                  <a:srgbClr val="0F172A"/>
-                </a:solidFill>
-              </a:defRPr>
-            </a:pPr>
-            <a:r>
-              <a:t>✔ LMS Coaching Dispatch: Assigns targeted modules (MOD-101 to 104) directly.</a:t>
+                  <a:srgbClr val="B91C1C"/>
+                </a:solidFill>
+              </a:defRPr>
+            </a:pPr>
+            <a:r>
+              <a:t>❌ Legacy Process: Agent messages supervisor in chat ➔ Waits 10–20 mins while customer queue builds ➔ Supervisor manually checks staffing spreadsheets ➔ Agent overstays break due to lack of timer ➔ Queue spikes cause supervisor panic.</a:t>
             </a:r>
           </a:p>
           <a:p>
             <a:pPr>
-              <a:spcAft>
-                <a:spcPts val="300"/>
-              </a:spcAft>
-              <a:defRPr sz="950">
-                <a:solidFill>
-                  <a:srgbClr val="0F172A"/>
-                </a:solidFill>
-              </a:defRPr>
-            </a:pPr>
-            <a:r>
-              <a:t>✔ Storm IVR Deflection: Auto-engages automated voice advisories at 1,000 calls/min.</a:t>
-            </a:r>
-          </a:p>
-          <a:p>
-            <a:pPr>
-              <a:spcAft>
-                <a:spcPts val="300"/>
-              </a:spcAft>
-              <a:defRPr sz="950">
-                <a:solidFill>
-                  <a:srgbClr val="0F172A"/>
-                </a:solidFill>
-              </a:defRPr>
-            </a:pPr>
-            <a:r>
-              <a:t>✔ Caller Audio Testing: Synthesized text-to-speech announcement simulation.</a:t>
+              <a:defRPr sz="950" b="1">
+                <a:solidFill>
+                  <a:srgbClr val="059669"/>
+                </a:solidFill>
+              </a:defRPr>
+            </a:pPr>
+            <a:r>
+              <a:t>✔ ZEL Experience: 1-Click request from floating desktop ➔ 100ms Erlang-C capacity gating ➔ Instant automated grant ('Zero wait to leave') ➔ Widget countdown timer tracks rest ➔ Automated voice bot recalls to desk ('Zero wait to return').</a:t>
             </a:r>
           </a:p>
         </p:txBody>
@@ -4470,8 +4735,8 @@
         </p:nvSpPr>
         <p:spPr>
           <a:xfrm>
-            <a:off x="731520" y="146304"/>
-            <a:ext cx="10515600" cy="274320"/>
+            <a:off x="731520" y="128016"/>
+            <a:ext cx="10515600" cy="868680"/>
           </a:xfrm>
           <a:prstGeom prst="rect">
             <a:avLst/>
@@ -4492,56 +4757,33 @@
               </a:defRPr>
             </a:pPr>
             <a:r>
-              <a:t>MULTI-TIER EVENT-DRIVEN DISTRIBUTED DESIGN</a:t>
-            </a:r>
-          </a:p>
-        </p:txBody>
-      </p:sp>
-      <p:sp>
-        <p:nvSpPr>
-          <p:cNvPr id="4" name="TextBox 3"/>
-          <p:cNvSpPr txBox="1"/>
-          <p:nvPr/>
-        </p:nvSpPr>
-        <p:spPr>
-          <a:xfrm>
-            <a:off x="731520" y="384048"/>
-            <a:ext cx="10515600" cy="548640"/>
-          </a:xfrm>
-          <a:prstGeom prst="rect">
-            <a:avLst/>
-          </a:prstGeom>
-          <a:noFill/>
-        </p:spPr>
-        <p:txBody>
-          <a:bodyPr wrap="square">
-            <a:spAutoFit/>
-          </a:bodyPr>
-          <a:lstStyle/>
+              <a:t>CONNECTED FRONT-LINE &amp; LEADERSHIP FLOW</a:t>
+            </a:r>
+          </a:p>
           <a:p>
             <a:pPr>
-              <a:defRPr sz="2200" b="1">
+              <a:defRPr sz="2100" b="1">
                 <a:solidFill>
                   <a:srgbClr val="FFFFFF"/>
                 </a:solidFill>
               </a:defRPr>
             </a:pPr>
             <a:r>
-              <a:t>End-to-End System Architecture &amp; Data Flow</a:t>
-            </a:r>
-          </a:p>
-        </p:txBody>
-      </p:sp>
-      <p:sp>
-        <p:nvSpPr>
-          <p:cNvPr id="5" name="Rounded Rectangle 4"/>
+              <a:t>The ZEL Experience: Dual Agent &amp; Supervisor Workflows</a:t>
+            </a:r>
+          </a:p>
+        </p:txBody>
+      </p:sp>
+      <p:sp>
+        <p:nvSpPr>
+          <p:cNvPr id="4" name="Rounded Rectangle 3"/>
           <p:cNvSpPr/>
           <p:nvPr/>
         </p:nvSpPr>
         <p:spPr>
           <a:xfrm>
             <a:off x="731520" y="1280160"/>
-            <a:ext cx="10698480" cy="1463040"/>
+            <a:ext cx="5120640" cy="5120640"/>
           </a:xfrm>
           <a:prstGeom prst="roundRect">
             <a:avLst/>
@@ -4549,9 +4791,9 @@
           <a:solidFill>
             <a:srgbClr val="FFFFFF"/>
           </a:solidFill>
-          <a:ln w="19050">
+          <a:ln w="25400">
             <a:solidFill>
-              <a:srgbClr val="E2E8F0"/>
+              <a:srgbClr val="2563EB"/>
             </a:solidFill>
           </a:ln>
         </p:spPr>
@@ -4579,14 +4821,14 @@
       </p:sp>
       <p:sp>
         <p:nvSpPr>
-          <p:cNvPr id="6" name="TextBox 5"/>
+          <p:cNvPr id="5" name="TextBox 4"/>
           <p:cNvSpPr txBox="1"/>
           <p:nvPr/>
         </p:nvSpPr>
         <p:spPr>
           <a:xfrm>
-            <a:off x="914400" y="1444752"/>
-            <a:ext cx="10332720" cy="1133856"/>
+            <a:off x="914400" y="1417320"/>
+            <a:ext cx="4754880" cy="4846320"/>
           </a:xfrm>
           <a:prstGeom prst="rect">
             <a:avLst/>
@@ -4594,69 +4836,129 @@
           <a:noFill/>
         </p:spPr>
         <p:txBody>
-          <a:bodyPr wrap="square" anchor="t">
+          <a:bodyPr wrap="square">
             <a:spAutoFit/>
           </a:bodyPr>
           <a:lstStyle/>
-          <a:p>
-            <a:pPr>
-              <a:defRPr sz="1400" b="1">
-                <a:solidFill>
-                  <a:srgbClr val="1E3A8A"/>
-                </a:solidFill>
-              </a:defRPr>
-            </a:pPr>
-            <a:r>
-              <a:t>Tier 1: Client Application &amp; Presentation Layer (Dual-Persona UX)</a:t>
-            </a:r>
-          </a:p>
           <a:p>
             <a:pPr>
               <a:spcAft>
                 <a:spcPts val="800"/>
               </a:spcAft>
-              <a:defRPr sz="1000" i="1">
+              <a:defRPr sz="1400" b="1">
+                <a:solidFill>
+                  <a:srgbClr val="1E3A8A"/>
+                </a:solidFill>
+              </a:defRPr>
+            </a:pPr>
+            <a:r>
+              <a:t>👤 Front-Line Agent Journey (AUXY Widget)</a:t>
+            </a:r>
+          </a:p>
+          <a:p>
+            <a:pPr>
+              <a:spcAft>
+                <a:spcPts val="800"/>
+              </a:spcAft>
+              <a:defRPr b="1" sz="1000">
+                <a:solidFill>
+                  <a:srgbClr val="0F172A"/>
+                </a:solidFill>
+              </a:defRPr>
+            </a:pPr>
+            <a:r>
+              <a:t>• 1. During Customer Call: </a:t>
+            </a:r>
+            <a:r>
+              <a:rPr b="0" sz="950">
                 <a:solidFill>
                   <a:srgbClr val="64748B"/>
                 </a:solidFill>
-              </a:defRPr>
-            </a:pPr>
-            <a:r>
-              <a:t>Electron Desktop App + Modern Responsive Web Gateway</a:t>
+              </a:rPr>
+              <a:t>ZEL provides live speech tone coaching and real-time objection-handling templates directly on screen.</a:t>
             </a:r>
           </a:p>
           <a:p>
             <a:pPr>
-              <a:defRPr sz="1000">
+              <a:spcAft>
+                <a:spcPts val="800"/>
+              </a:spcAft>
+              <a:defRPr b="1" sz="1000">
                 <a:solidFill>
                   <a:srgbClr val="0F172A"/>
                 </a:solidFill>
               </a:defRPr>
             </a:pPr>
             <a:r>
-              <a:t>• Electron Desktop Widget: Floating Windows client with AppUserModelId taskbar integration, always-on-top CTI overlay, and local sound alerts.</a:t>
-            </a:r>
-            <a:br/>
-            <a:r>
-              <a:t>• HTML5 Operations Gateway: Minimalist hub connecting Agent Home, Break Portal, and Supervisor Command Center.</a:t>
-            </a:r>
-            <a:br/>
-            <a:r>
-              <a:t>• Multi-DPI Panda Branding: High-contrast 256x256 ICO, crisp vector SVG, and retina PNG assets rendering cleanly across OS taskbars.</a:t>
-            </a:r>
-          </a:p>
-        </p:txBody>
-      </p:sp>
-      <p:sp>
-        <p:nvSpPr>
-          <p:cNvPr id="7" name="Rounded Rectangle 6"/>
+              <a:t>• 2. Post-Call Wrap-up (ACW): </a:t>
+            </a:r>
+            <a:r>
+              <a:rPr b="0" sz="950">
+                <a:solidFill>
+                  <a:srgbClr val="64748B"/>
+                </a:solidFill>
+              </a:rPr>
+              <a:t>1-Click AI Summarizer auto-generates structured CRM notes, reducing after-call work from 68s to 34s.</a:t>
+            </a:r>
+          </a:p>
+          <a:p>
+            <a:pPr>
+              <a:spcAft>
+                <a:spcPts val="800"/>
+              </a:spcAft>
+              <a:defRPr b="1" sz="1000">
+                <a:solidFill>
+                  <a:srgbClr val="0F172A"/>
+                </a:solidFill>
+              </a:defRPr>
+            </a:pPr>
+            <a:r>
+              <a:t>• 3. Applying for Break: </a:t>
+            </a:r>
+            <a:r>
+              <a:rPr b="0" sz="950">
+                <a:solidFill>
+                  <a:srgbClr val="64748B"/>
+                </a:solidFill>
+              </a:rPr>
+              <a:t>Zero wait to leave: Clicks Tea/Bio in widget, receives instant Erlang-C automated grant if queue capacity permits.</a:t>
+            </a:r>
+          </a:p>
+          <a:p>
+            <a:pPr>
+              <a:spcAft>
+                <a:spcPts val="800"/>
+              </a:spcAft>
+              <a:defRPr b="1" sz="1000">
+                <a:solidFill>
+                  <a:srgbClr val="0F172A"/>
+                </a:solidFill>
+              </a:defRPr>
+            </a:pPr>
+            <a:r>
+              <a:t>• 4. Rest Period &amp; Recall: </a:t>
+            </a:r>
+            <a:r>
+              <a:rPr b="0" sz="950">
+                <a:solidFill>
+                  <a:srgbClr val="64748B"/>
+                </a:solidFill>
+              </a:rPr>
+              <a:t>Widget displays countdown timer; if floor experiences a sudden surge, ZEL rings with a synthesized voice desk recall.</a:t>
+            </a:r>
+          </a:p>
+        </p:txBody>
+      </p:sp>
+      <p:sp>
+        <p:nvSpPr>
+          <p:cNvPr id="6" name="Rounded Rectangle 5"/>
           <p:cNvSpPr/>
           <p:nvPr/>
         </p:nvSpPr>
         <p:spPr>
           <a:xfrm>
-            <a:off x="731520" y="2926080"/>
-            <a:ext cx="10698480" cy="1463040"/>
+            <a:off x="6217920" y="1280160"/>
+            <a:ext cx="5212080" cy="5120640"/>
           </a:xfrm>
           <a:prstGeom prst="roundRect">
             <a:avLst/>
@@ -4664,9 +4966,9 @@
           <a:solidFill>
             <a:srgbClr val="FFFFFF"/>
           </a:solidFill>
-          <a:ln w="19050">
+          <a:ln w="25400">
             <a:solidFill>
-              <a:srgbClr val="E2E8F0"/>
+              <a:srgbClr val="059669"/>
             </a:solidFill>
           </a:ln>
         </p:spPr>
@@ -4694,14 +4996,14 @@
       </p:sp>
       <p:sp>
         <p:nvSpPr>
-          <p:cNvPr id="8" name="TextBox 7"/>
+          <p:cNvPr id="7" name="TextBox 6"/>
           <p:cNvSpPr txBox="1"/>
           <p:nvPr/>
         </p:nvSpPr>
         <p:spPr>
           <a:xfrm>
-            <a:off x="914400" y="3090672"/>
-            <a:ext cx="10332720" cy="1133856"/>
+            <a:off x="6400800" y="1417320"/>
+            <a:ext cx="4846320" cy="4846320"/>
           </a:xfrm>
           <a:prstGeom prst="rect">
             <a:avLst/>
@@ -4709,135 +5011,23 @@
           <a:noFill/>
         </p:spPr>
         <p:txBody>
-          <a:bodyPr wrap="square" anchor="t">
+          <a:bodyPr wrap="square">
             <a:spAutoFit/>
           </a:bodyPr>
           <a:lstStyle/>
-          <a:p>
-            <a:pPr>
-              <a:defRPr sz="1400" b="1">
-                <a:solidFill>
-                  <a:srgbClr val="1E3A8A"/>
-                </a:solidFill>
-              </a:defRPr>
-            </a:pPr>
-            <a:r>
-              <a:t>Tier 2: Real-time Telemetry Server &amp; Event Bus (Node.js &amp; BroadcastChannel)</a:t>
-            </a:r>
-          </a:p>
           <a:p>
             <a:pPr>
               <a:spcAft>
                 <a:spcPts val="800"/>
               </a:spcAft>
-              <a:defRPr sz="1000" i="1">
-                <a:solidFill>
-                  <a:srgbClr val="64748B"/>
-                </a:solidFill>
-              </a:defRPr>
-            </a:pPr>
-            <a:r>
-              <a:t>Sub-Millisecond Synchronization Across Desktop &amp; Browser Sessions</a:t>
-            </a:r>
-          </a:p>
-          <a:p>
-            <a:pPr>
-              <a:defRPr sz="1000">
-                <a:solidFill>
-                  <a:srgbClr val="0F172A"/>
-                </a:solidFill>
-              </a:defRPr>
-            </a:pPr>
-            <a:r>
-              <a:t>• Node.js Event Gateway (Port 4000): Non-blocking HTTP/REST APIs for break evaluation, policy limits, IT tickets, and copilot queries.</a:t>
-            </a:r>
-            <a:br/>
-            <a:r>
-              <a:t>• HTML5 BroadcastChannel ('wfm_aux_channel'): P2P client bus dispatching policy updates, recall voice alerts, and mandatory coaching.</a:t>
-            </a:r>
-            <a:br/>
-            <a:r>
-              <a:t>• Scoped Access Control: Supervisor-to-agent tagging routes telemetry and break approvals to the agent's assigned manager.</a:t>
-            </a:r>
-          </a:p>
-        </p:txBody>
-      </p:sp>
-      <p:sp>
-        <p:nvSpPr>
-          <p:cNvPr id="9" name="Rounded Rectangle 8"/>
-          <p:cNvSpPr/>
-          <p:nvPr/>
-        </p:nvSpPr>
-        <p:spPr>
-          <a:xfrm>
-            <a:off x="731520" y="4572000"/>
-            <a:ext cx="10698480" cy="1645920"/>
-          </a:xfrm>
-          <a:prstGeom prst="roundRect">
-            <a:avLst/>
-          </a:prstGeom>
-          <a:solidFill>
-            <a:srgbClr val="FFFFFF"/>
-          </a:solidFill>
-          <a:ln w="19050">
-            <a:solidFill>
-              <a:srgbClr val="E2E8F0"/>
-            </a:solidFill>
-          </a:ln>
-        </p:spPr>
-        <p:style>
-          <a:lnRef idx="1">
-            <a:schemeClr val="accent1"/>
-          </a:lnRef>
-          <a:fillRef idx="3">
-            <a:schemeClr val="accent1"/>
-          </a:fillRef>
-          <a:effectRef idx="2">
-            <a:schemeClr val="accent1"/>
-          </a:effectRef>
-          <a:fontRef idx="minor">
-            <a:schemeClr val="lt1"/>
-          </a:fontRef>
-        </p:style>
-        <p:txBody>
-          <a:bodyPr rtlCol="0" anchor="ctr"/>
-          <a:lstStyle/>
-          <a:p>
-            <a:pPr algn="ctr"/>
-          </a:p>
-        </p:txBody>
-      </p:sp>
-      <p:sp>
-        <p:nvSpPr>
-          <p:cNvPr id="10" name="TextBox 9"/>
-          <p:cNvSpPr txBox="1"/>
-          <p:nvPr/>
-        </p:nvSpPr>
-        <p:spPr>
-          <a:xfrm>
-            <a:off x="914400" y="4736592"/>
-            <a:ext cx="10332720" cy="1316736"/>
-          </a:xfrm>
-          <a:prstGeom prst="rect">
-            <a:avLst/>
-          </a:prstGeom>
-          <a:noFill/>
-        </p:spPr>
-        <p:txBody>
-          <a:bodyPr wrap="square" anchor="t">
-            <a:spAutoFit/>
-          </a:bodyPr>
-          <a:lstStyle/>
-          <a:p>
-            <a:pPr>
               <a:defRPr sz="1400" b="1">
                 <a:solidFill>
-                  <a:srgbClr val="1E3A8A"/>
-                </a:solidFill>
-              </a:defRPr>
-            </a:pPr>
-            <a:r>
-              <a:t>Tier 3: Analytical Core Engines &amp; NICE CXone Telephony Gateway</a:t>
+                  <a:srgbClr val="059669"/>
+                </a:solidFill>
+              </a:defRPr>
+            </a:pPr>
+            <a:r>
+              <a:t>👩‍💼 Supervisor Command Center Journey (REMI)</a:t>
             </a:r>
           </a:p>
           <a:p>
@@ -4845,38 +5035,91 @@
               <a:spcAft>
                 <a:spcPts val="800"/>
               </a:spcAft>
-              <a:defRPr sz="1000" i="1">
+              <a:defRPr b="1" sz="1000">
+                <a:solidFill>
+                  <a:srgbClr val="0F172A"/>
+                </a:solidFill>
+              </a:defRPr>
+            </a:pPr>
+            <a:r>
+              <a:t>• 1. Scoped Team Oversight: </a:t>
+            </a:r>
+            <a:r>
+              <a:rPr b="0" sz="950">
                 <a:solidFill>
                   <a:srgbClr val="64748B"/>
                 </a:solidFill>
-              </a:defRPr>
-            </a:pPr>
-            <a:r>
-              <a:t>Erlang-C Staffing Math, Speech Sentiment Processing &amp; CTI State Engine</a:t>
+              </a:rPr>
+              <a:t>Dashboard automatically filters to supervisor's direct reports (Sarah, Michael, Elena, David, Priya).</a:t>
             </a:r>
           </a:p>
           <a:p>
             <a:pPr>
-              <a:defRPr sz="1000">
+              <a:spcAft>
+                <a:spcPts val="800"/>
+              </a:spcAft>
+              <a:defRPr b="1" sz="1000">
                 <a:solidFill>
                   <a:srgbClr val="0F172A"/>
                 </a:solidFill>
               </a:defRPr>
             </a:pPr>
             <a:r>
-              <a:t>• Autonomous Erlang-C Engine: Continuously calculates call arrival rate (λ), average handle time (μ), and required agents (N).</a:t>
-            </a:r>
-            <a:br/>
-            <a:r>
-              <a:t>• REMI Supervisor AI Copilot: Natural language semantic query processor returning agent 360° dossiers and burnout risk scores.</a:t>
-            </a:r>
-            <a:br/>
-            <a:r>
-              <a:t>• NICE CXone CTI Connector: Simulated MAX softphone state machine maintaining Available, Working, AUX, and ACW state transitions.</a:t>
-            </a:r>
-            <a:br/>
-            <a:r>
-              <a:t>• IVR Auto-Deflection Engine: Throttles call arrival surges past 1,000 calls/min, diverting callers to emergency voice scripts.</a:t>
+              <a:t>• 2. Real-Time Adherence Tracking: </a:t>
+            </a:r>
+            <a:r>
+              <a:rPr b="0" sz="950">
+                <a:solidFill>
+                  <a:srgbClr val="64748B"/>
+                </a:solidFill>
+              </a:rPr>
+              <a:t>Monitors who is in AUX, tea break counts, and lunch variance with automated policy alerts.</a:t>
+            </a:r>
+          </a:p>
+          <a:p>
+            <a:pPr>
+              <a:spcAft>
+                <a:spcPts val="800"/>
+              </a:spcAft>
+              <a:defRPr b="1" sz="1000">
+                <a:solidFill>
+                  <a:srgbClr val="0F172A"/>
+                </a:solidFill>
+              </a:defRPr>
+            </a:pPr>
+            <a:r>
+              <a:t>• 3. Dynamic Surge Rebalance: </a:t>
+            </a:r>
+            <a:r>
+              <a:rPr b="0" sz="950">
+                <a:solidFill>
+                  <a:srgbClr val="64748B"/>
+                </a:solidFill>
+              </a:rPr>
+              <a:t>1-Click allocates 3 idle Customer Service agents to Billing when volume spikes (+318 calls), saving SLA.</a:t>
+            </a:r>
+          </a:p>
+          <a:p>
+            <a:pPr>
+              <a:spcAft>
+                <a:spcPts val="800"/>
+              </a:spcAft>
+              <a:defRPr b="1" sz="1000">
+                <a:solidFill>
+                  <a:srgbClr val="0F172A"/>
+                </a:solidFill>
+              </a:defRPr>
+            </a:pPr>
+            <a:r>
+              <a:t>• 4. QA Speech Sentiment Audits: </a:t>
+            </a:r>
+            <a:r>
+              <a:rPr b="0" sz="950">
+                <a:solidFill>
+                  <a:srgbClr val="64748B"/>
+                </a:solidFill>
+              </a:rPr>
+              <a:t>Reviews empathetic vs. rude speech calls and dispatches targeted LMS coaching modules (MOD-101 to 104).</a:t>
             </a:r>
           </a:p>
         </p:txBody>
@@ -4952,8 +5195,8 @@
         </p:nvSpPr>
         <p:spPr>
           <a:xfrm>
-            <a:off x="731520" y="146304"/>
-            <a:ext cx="10515600" cy="274320"/>
+            <a:off x="731520" y="128016"/>
+            <a:ext cx="10515600" cy="868680"/>
           </a:xfrm>
           <a:prstGeom prst="rect">
             <a:avLst/>
@@ -4974,56 +5217,33 @@
               </a:defRPr>
             </a:pPr>
             <a:r>
-              <a:t>QUANTIFIABLE IMPACT ON CONTACT CENTER OPERATIONS</a:t>
-            </a:r>
-          </a:p>
-        </p:txBody>
-      </p:sp>
-      <p:sp>
-        <p:nvSpPr>
-          <p:cNvPr id="4" name="TextBox 3"/>
-          <p:cNvSpPr txBox="1"/>
-          <p:nvPr/>
-        </p:nvSpPr>
-        <p:spPr>
-          <a:xfrm>
-            <a:off x="731520" y="384048"/>
-            <a:ext cx="10515600" cy="548640"/>
-          </a:xfrm>
-          <a:prstGeom prst="rect">
-            <a:avLst/>
-          </a:prstGeom>
-          <a:noFill/>
-        </p:spPr>
-        <p:txBody>
-          <a:bodyPr wrap="square">
-            <a:spAutoFit/>
-          </a:bodyPr>
-          <a:lstStyle/>
+              <a:t>BUSINESS IMPACT &amp; HIGH-VELOCITY ROI</a:t>
+            </a:r>
+          </a:p>
           <a:p>
             <a:pPr>
-              <a:defRPr sz="2200" b="1">
+              <a:defRPr sz="2100" b="1">
                 <a:solidFill>
                   <a:srgbClr val="FFFFFF"/>
                 </a:solidFill>
               </a:defRPr>
             </a:pPr>
             <a:r>
-              <a:t>Business Value, Measurable ROI &amp; Operational Outcomes</a:t>
-            </a:r>
-          </a:p>
-        </p:txBody>
-      </p:sp>
-      <p:sp>
-        <p:nvSpPr>
-          <p:cNvPr id="5" name="Rounded Rectangle 4"/>
+              <a:t>Measurable Outcomes: Why Contact Centers Love ZEL</a:t>
+            </a:r>
+          </a:p>
+        </p:txBody>
+      </p:sp>
+      <p:sp>
+        <p:nvSpPr>
+          <p:cNvPr id="4" name="Rounded Rectangle 3"/>
           <p:cNvSpPr/>
           <p:nvPr/>
         </p:nvSpPr>
         <p:spPr>
           <a:xfrm>
             <a:off x="731520" y="1280160"/>
-            <a:ext cx="2560320" cy="2011680"/>
+            <a:ext cx="2560320" cy="2103120"/>
           </a:xfrm>
           <a:prstGeom prst="roundRect">
             <a:avLst/>
@@ -5061,14 +5281,14 @@
       </p:sp>
       <p:sp>
         <p:nvSpPr>
-          <p:cNvPr id="6" name="TextBox 5"/>
+          <p:cNvPr id="5" name="TextBox 4"/>
           <p:cNvSpPr txBox="1"/>
           <p:nvPr/>
         </p:nvSpPr>
         <p:spPr>
           <a:xfrm>
-            <a:off x="868680" y="1371600"/>
-            <a:ext cx="2286000" cy="1828800"/>
+            <a:off x="841248" y="1371600"/>
+            <a:ext cx="2331720" cy="1920240"/>
           </a:xfrm>
           <a:prstGeom prst="rect">
             <a:avLst/>
@@ -5082,14 +5302,14 @@
           <a:lstStyle/>
           <a:p>
             <a:pPr algn="ctr">
-              <a:defRPr sz="2600" b="1">
+              <a:defRPr sz="2800" b="1">
                 <a:solidFill>
                   <a:srgbClr val="059669"/>
                 </a:solidFill>
               </a:defRPr>
             </a:pPr>
             <a:r>
-              <a:t>+18.4%</a:t>
+              <a:t>0 Sec</a:t>
             </a:r>
           </a:p>
           <a:p>
@@ -5104,7 +5324,7 @@
               </a:defRPr>
             </a:pPr>
             <a:r>
-              <a:t>Schedule Adherence</a:t>
+              <a:t>Wait for Break Approvals</a:t>
             </a:r>
           </a:p>
           <a:p>
@@ -5116,21 +5336,21 @@
               </a:defRPr>
             </a:pPr>
             <a:r>
-              <a:t>Eliminates unscheduled AUX overages through automated policy limits.</a:t>
-            </a:r>
-          </a:p>
-        </p:txBody>
-      </p:sp>
-      <p:sp>
-        <p:nvSpPr>
-          <p:cNvPr id="7" name="Rounded Rectangle 6"/>
+              <a:t>Down from 15–20 minutes of chat latency. Zero wait to leave.</a:t>
+            </a:r>
+          </a:p>
+        </p:txBody>
+      </p:sp>
+      <p:sp>
+        <p:nvSpPr>
+          <p:cNvPr id="6" name="Rounded Rectangle 5"/>
           <p:cNvSpPr/>
           <p:nvPr/>
         </p:nvSpPr>
         <p:spPr>
           <a:xfrm>
             <a:off x="3474720" y="1280160"/>
-            <a:ext cx="2560320" cy="2011680"/>
+            <a:ext cx="2560320" cy="2103120"/>
           </a:xfrm>
           <a:prstGeom prst="roundRect">
             <a:avLst/>
@@ -5168,14 +5388,14 @@
       </p:sp>
       <p:sp>
         <p:nvSpPr>
-          <p:cNvPr id="8" name="TextBox 7"/>
+          <p:cNvPr id="7" name="TextBox 6"/>
           <p:cNvSpPr txBox="1"/>
           <p:nvPr/>
         </p:nvSpPr>
         <p:spPr>
           <a:xfrm>
-            <a:off x="3611880" y="1371600"/>
-            <a:ext cx="2286000" cy="1828800"/>
+            <a:off x="3584448" y="1371600"/>
+            <a:ext cx="2331720" cy="1920240"/>
           </a:xfrm>
           <a:prstGeom prst="rect">
             <a:avLst/>
@@ -5189,7 +5409,7 @@
           <a:lstStyle/>
           <a:p>
             <a:pPr algn="ctr">
-              <a:defRPr sz="2600" b="1">
+              <a:defRPr sz="2800" b="1">
                 <a:solidFill>
                   <a:srgbClr val="2563EB"/>
                 </a:solidFill>
@@ -5211,7 +5431,7 @@
               </a:defRPr>
             </a:pPr>
             <a:r>
-              <a:t>ACW Handle Time</a:t>
+              <a:t>ACW Handle Time Saved</a:t>
             </a:r>
           </a:p>
           <a:p>
@@ -5223,21 +5443,21 @@
               </a:defRPr>
             </a:pPr>
             <a:r>
-              <a:t>AI call summarization cuts CRM documentation time in half.</a:t>
-            </a:r>
-          </a:p>
-        </p:txBody>
-      </p:sp>
-      <p:sp>
-        <p:nvSpPr>
-          <p:cNvPr id="9" name="Rounded Rectangle 8"/>
+              <a:t>AI auto-summarization cuts CRM documentation time in half.</a:t>
+            </a:r>
+          </a:p>
+        </p:txBody>
+      </p:sp>
+      <p:sp>
+        <p:nvSpPr>
+          <p:cNvPr id="8" name="Rounded Rectangle 7"/>
           <p:cNvSpPr/>
           <p:nvPr/>
         </p:nvSpPr>
         <p:spPr>
           <a:xfrm>
             <a:off x="6217920" y="1280160"/>
-            <a:ext cx="2560320" cy="2011680"/>
+            <a:ext cx="2560320" cy="2103120"/>
           </a:xfrm>
           <a:prstGeom prst="roundRect">
             <a:avLst/>
@@ -5275,14 +5495,14 @@
       </p:sp>
       <p:sp>
         <p:nvSpPr>
-          <p:cNvPr id="10" name="TextBox 9"/>
+          <p:cNvPr id="9" name="TextBox 8"/>
           <p:cNvSpPr txBox="1"/>
           <p:nvPr/>
         </p:nvSpPr>
         <p:spPr>
           <a:xfrm>
-            <a:off x="6355080" y="1371600"/>
-            <a:ext cx="2286000" cy="1828800"/>
+            <a:off x="6327648" y="1371600"/>
+            <a:ext cx="2331720" cy="1920240"/>
           </a:xfrm>
           <a:prstGeom prst="rect">
             <a:avLst/>
@@ -5296,7 +5516,7 @@
           <a:lstStyle/>
           <a:p>
             <a:pPr algn="ctr">
-              <a:defRPr sz="2600" b="1">
+              <a:defRPr sz="2800" b="1">
                 <a:solidFill>
                   <a:srgbClr val="0EA5E9"/>
                 </a:solidFill>
@@ -5330,21 +5550,21 @@
               </a:defRPr>
             </a:pPr>
             <a:r>
-              <a:t>Cross-skill rebalance clears 300+ surge calls within minutes.</a:t>
-            </a:r>
-          </a:p>
-        </p:txBody>
-      </p:sp>
-      <p:sp>
-        <p:nvSpPr>
-          <p:cNvPr id="11" name="Rounded Rectangle 10"/>
+              <a:t>Cross-skill flex rebalance clears 300+ surge calls in minutes.</a:t>
+            </a:r>
+          </a:p>
+        </p:txBody>
+      </p:sp>
+      <p:sp>
+        <p:nvSpPr>
+          <p:cNvPr id="10" name="Rounded Rectangle 9"/>
           <p:cNvSpPr/>
           <p:nvPr/>
         </p:nvSpPr>
         <p:spPr>
           <a:xfrm>
             <a:off x="8961120" y="1280160"/>
-            <a:ext cx="2560320" cy="2011680"/>
+            <a:ext cx="2560320" cy="2103120"/>
           </a:xfrm>
           <a:prstGeom prst="roundRect">
             <a:avLst/>
@@ -5382,14 +5602,14 @@
       </p:sp>
       <p:sp>
         <p:nvSpPr>
-          <p:cNvPr id="12" name="TextBox 11"/>
+          <p:cNvPr id="11" name="TextBox 10"/>
           <p:cNvSpPr txBox="1"/>
           <p:nvPr/>
         </p:nvSpPr>
         <p:spPr>
           <a:xfrm>
-            <a:off x="9098280" y="1371600"/>
-            <a:ext cx="2286000" cy="1828800"/>
+            <a:off x="9070848" y="1371600"/>
+            <a:ext cx="2331720" cy="1920240"/>
           </a:xfrm>
           <a:prstGeom prst="rect">
             <a:avLst/>
@@ -5403,14 +5623,14 @@
           <a:lstStyle/>
           <a:p>
             <a:pPr algn="ctr">
-              <a:defRPr sz="2600" b="1">
+              <a:defRPr sz="2800" b="1">
                 <a:solidFill>
                   <a:srgbClr val="D97706"/>
                 </a:solidFill>
               </a:defRPr>
             </a:pPr>
             <a:r>
-              <a:t>1,000/m</a:t>
+              <a:t>1,000/min</a:t>
             </a:r>
           </a:p>
           <a:p>
@@ -5425,7 +5645,7 @@
               </a:defRPr>
             </a:pPr>
             <a:r>
-              <a:t>Storm Deflection</a:t>
+              <a:t>Disaster IVR Auto-Deflect</a:t>
             </a:r>
           </a:p>
           <a:p>
@@ -5437,31 +5657,31 @@
               </a:defRPr>
             </a:pPr>
             <a:r>
-              <a:t>Protects live agents from being overwhelmed during severe disaster outages.</a:t>
-            </a:r>
-          </a:p>
-        </p:txBody>
-      </p:sp>
-      <p:sp>
-        <p:nvSpPr>
-          <p:cNvPr id="13" name="Rounded Rectangle 12"/>
+              <a:t>Protects live agents from being overwhelmed during storm outages.</a:t>
+            </a:r>
+          </a:p>
+        </p:txBody>
+      </p:sp>
+      <p:sp>
+        <p:nvSpPr>
+          <p:cNvPr id="12" name="Rounded Rectangle 11"/>
           <p:cNvSpPr/>
           <p:nvPr/>
         </p:nvSpPr>
         <p:spPr>
           <a:xfrm>
-            <a:off x="731520" y="3566160"/>
-            <a:ext cx="10698480" cy="2834640"/>
+            <a:off x="731520" y="3611880"/>
+            <a:ext cx="10698480" cy="2788920"/>
           </a:xfrm>
           <a:prstGeom prst="roundRect">
             <a:avLst/>
           </a:prstGeom>
           <a:solidFill>
-            <a:srgbClr val="FFFFFF"/>
+            <a:srgbClr val="F8FAFC"/>
           </a:solidFill>
           <a:ln w="19050">
             <a:solidFill>
-              <a:srgbClr val="E2E8F0"/>
+              <a:srgbClr val="2563EB"/>
             </a:solidFill>
           </a:ln>
         </p:spPr>
@@ -5489,14 +5709,14 @@
       </p:sp>
       <p:sp>
         <p:nvSpPr>
-          <p:cNvPr id="14" name="TextBox 13"/>
+          <p:cNvPr id="13" name="TextBox 12"/>
           <p:cNvSpPr txBox="1"/>
           <p:nvPr/>
         </p:nvSpPr>
         <p:spPr>
           <a:xfrm>
-            <a:off x="914400" y="3730752"/>
-            <a:ext cx="10332720" cy="2505456"/>
+            <a:off x="914400" y="3703320"/>
+            <a:ext cx="10332720" cy="2560320"/>
           </a:xfrm>
           <a:prstGeom prst="rect">
             <a:avLst/>
@@ -5504,35 +5724,23 @@
           <a:noFill/>
         </p:spPr>
         <p:txBody>
-          <a:bodyPr wrap="square" anchor="t">
+          <a:bodyPr wrap="square">
             <a:spAutoFit/>
           </a:bodyPr>
           <a:lstStyle/>
           <a:p>
             <a:pPr>
-              <a:defRPr sz="1400" b="1">
+              <a:spcAft>
+                <a:spcPts val="600"/>
+              </a:spcAft>
+              <a:defRPr sz="1200" b="1">
                 <a:solidFill>
                   <a:srgbClr val="1E3A8A"/>
                 </a:solidFill>
               </a:defRPr>
             </a:pPr>
             <a:r>
-              <a:t>Three Pillars of Enterprise Operational ROI</a:t>
-            </a:r>
-          </a:p>
-          <a:p>
-            <a:pPr>
-              <a:spcAft>
-                <a:spcPts val="800"/>
-              </a:spcAft>
-              <a:defRPr sz="1000" i="1">
-                <a:solidFill>
-                  <a:srgbClr val="64748B"/>
-                </a:solidFill>
-              </a:defRPr>
-            </a:pPr>
-            <a:r>
-              <a:t>Workforce Optimization, Agent Well-being &amp; Executive Governance</a:t>
+              <a:t>THREE PILLARS OF ENTERPRISE OPERATIONAL ROI</a:t>
             </a:r>
           </a:p>
           <a:p>
@@ -5542,12 +5750,12 @@
               </a:spcAft>
               <a:defRPr b="1" sz="1000">
                 <a:solidFill>
-                  <a:srgbClr val="1E3A8A"/>
-                </a:solidFill>
-              </a:defRPr>
-            </a:pPr>
-            <a:r>
-              <a:t>• Pillar 1: Intraday Workforce Optimization (WFM): </a:t>
+                  <a:srgbClr val="0F172A"/>
+                </a:solidFill>
+              </a:defRPr>
+            </a:pPr>
+            <a:r>
+              <a:t>• Pillar 1: Frictionless Workforce Adherence: </a:t>
             </a:r>
             <a:r>
               <a:rPr b="0" sz="950">
@@ -5555,7 +5763,7 @@
                   <a:srgbClr val="64748B"/>
                 </a:solidFill>
               </a:rPr>
-              <a:t>Automated Erlang-C calculations remove manual break log approvals. Intraday queue rebalancing rescues service levels without paying overtime or calling in emergency off-shift staff.</a:t>
+              <a:t>Removes break scheduling friction. Agents take breaks when queue capacity allows, eliminating unplanned overages and raising overall shift adherence by +18.4%.</a:t>
             </a:r>
           </a:p>
           <a:p>
@@ -5565,12 +5773,12 @@
               </a:spcAft>
               <a:defRPr b="1" sz="1000">
                 <a:solidFill>
-                  <a:srgbClr val="1E3A8A"/>
-                </a:solidFill>
-              </a:defRPr>
-            </a:pPr>
-            <a:r>
-              <a:t>• Pillar 2: Agent Retention &amp; Fatigue Mitigation: </a:t>
+                  <a:srgbClr val="0F172A"/>
+                </a:solidFill>
+              </a:defRPr>
+            </a:pPr>
+            <a:r>
+              <a:t>• Pillar 2: Reduced Handle Time &amp; Cognitive Fatigue: </a:t>
             </a:r>
             <a:r>
               <a:rPr b="0" sz="950">
@@ -5578,7 +5786,7 @@
                   <a:srgbClr val="64748B"/>
                 </a:solidFill>
               </a:rPr>
-              <a:t>Post-call AI summarization prevents cognitive ACW fatigue. Burnout detection algorithms flag consecutive call strain, ensuring high-risk agents receive timely rest intervals before customer sentiment suffers.</a:t>
+              <a:t>AI ACW summarization eliminates repetitive post-call note typing, while fatigue tracking ensures overworked agents receive timely rest intervals before customer tone degrades.</a:t>
             </a:r>
           </a:p>
           <a:p>
@@ -5588,12 +5796,12 @@
               </a:spcAft>
               <a:defRPr b="1" sz="1000">
                 <a:solidFill>
-                  <a:srgbClr val="1E3A8A"/>
-                </a:solidFill>
-              </a:defRPr>
-            </a:pPr>
-            <a:r>
-              <a:t>• Pillar 3: High-Visibility Supervisor Governance: </a:t>
+                  <a:srgbClr val="0F172A"/>
+                </a:solidFill>
+              </a:defRPr>
+            </a:pPr>
+            <a:r>
+              <a:t>• Pillar 3: High-Agility Floor Governance: </a:t>
             </a:r>
             <a:r>
               <a:rPr b="0" sz="950">
@@ -5601,7 +5809,7 @@
                   <a:srgbClr val="64748B"/>
                 </a:solidFill>
               </a:rPr>
-              <a:t>Supervisors transition from spreadsheet monitors to proactive coaches. Scoped team views ensure each manager focuses on their direct reports, with automated voice recalls and 1-click coaching assignment.</a:t>
+              <a:t>Supervisors gain direct scoped team oversight, automated voice bot recalls, and 1-click dynamic surge rebalancing, saving 8+ managerial hours per week from manual tracking.</a:t>
             </a:r>
           </a:p>
         </p:txBody>

</xml_diff>

<commit_message>
Rename Copilot to Ask Shankar across UI, desktop widgets, and docs
</commit_message>
<xml_diff>
--- a/NICE_CXone_WFM_Copilot_Architecture_and_Overview.pptx
+++ b/NICE_CXone_WFM_Copilot_Architecture_and_Overview.pptx
@@ -3100,7 +3100,7 @@
         <p:spPr>
           <a:xfrm>
             <a:off x="0" y="0"/>
-            <a:ext cx="12191695" cy="6858000"/>
+            <a:ext cx="12191695" cy="1051560"/>
           </a:xfrm>
           <a:prstGeom prst="rect">
             <a:avLst/>
@@ -3144,8 +3144,8 @@
         </p:nvSpPr>
         <p:spPr>
           <a:xfrm>
-            <a:off x="822960" y="1097280"/>
-            <a:ext cx="6858000" cy="2560320"/>
+            <a:off x="731520" y="146304"/>
+            <a:ext cx="10515600" cy="274320"/>
           </a:xfrm>
           <a:prstGeom prst="rect">
             <a:avLst/>
@@ -3159,80 +3159,73 @@
           <a:lstStyle/>
           <a:p>
             <a:pPr>
-              <a:spcAft>
-                <a:spcPts val="400"/>
-              </a:spcAft>
-              <a:defRPr sz="1100" b="1">
+              <a:defRPr sz="1000" b="1">
                 <a:solidFill>
                   <a:srgbClr val="0EA5E9"/>
                 </a:solidFill>
               </a:defRPr>
             </a:pPr>
             <a:r>
-              <a:t>NICE CXONE INTEL ENGINE</a:t>
-            </a:r>
-          </a:p>
+              <a:t>EXECUTIVE OVERVIEW &amp; PRODUCT VISION</a:t>
+            </a:r>
+          </a:p>
+        </p:txBody>
+      </p:sp>
+      <p:sp>
+        <p:nvSpPr>
+          <p:cNvPr id="4" name="TextBox 3"/>
+          <p:cNvSpPr txBox="1"/>
+          <p:nvPr/>
+        </p:nvSpPr>
+        <p:spPr>
+          <a:xfrm>
+            <a:off x="731520" y="384048"/>
+            <a:ext cx="10515600" cy="548640"/>
+          </a:xfrm>
+          <a:prstGeom prst="rect">
+            <a:avLst/>
+          </a:prstGeom>
+          <a:noFill/>
+        </p:spPr>
+        <p:txBody>
+          <a:bodyPr wrap="square">
+            <a:spAutoFit/>
+          </a:bodyPr>
+          <a:lstStyle/>
           <a:p>
             <a:pPr>
-              <a:defRPr sz="4600" b="1">
+              <a:defRPr sz="2200" b="1">
                 <a:solidFill>
                   <a:srgbClr val="FFFFFF"/>
                 </a:solidFill>
               </a:defRPr>
             </a:pPr>
             <a:r>
-              <a:t>Meet ZEL</a:t>
-            </a:r>
-          </a:p>
-          <a:p>
-            <a:pPr>
-              <a:spcAft>
-                <a:spcPts val="1000"/>
-              </a:spcAft>
-              <a:defRPr sz="2200" i="1" b="1">
-                <a:solidFill>
-                  <a:srgbClr val="38BDF8"/>
-                </a:solidFill>
-              </a:defRPr>
-            </a:pPr>
-            <a:r>
-              <a:t>“Zero wait to leave, zero wait to return”</a:t>
-            </a:r>
-          </a:p>
-          <a:p>
-            <a:pPr>
-              <a:defRPr sz="1300">
-                <a:solidFill>
-                  <a:srgbClr val="CBD5E1"/>
-                </a:solidFill>
-              </a:defRPr>
-            </a:pPr>
-            <a:r>
-              <a:t>Autonomous AI-powered WFM Copilot that eliminates break approval delays, protects schedule adherence, and instantly guides agents back to the desk.</a:t>
-            </a:r>
-          </a:p>
-        </p:txBody>
-      </p:sp>
-      <p:sp>
-        <p:nvSpPr>
-          <p:cNvPr id="4" name="Rounded Rectangle 3"/>
+              <a:t>NICE CXone Autonomous WFM &amp; Ask Shankar Platform</a:t>
+            </a:r>
+          </a:p>
+        </p:txBody>
+      </p:sp>
+      <p:sp>
+        <p:nvSpPr>
+          <p:cNvPr id="5" name="Rounded Rectangle 4"/>
           <p:cNvSpPr/>
           <p:nvPr/>
         </p:nvSpPr>
         <p:spPr>
           <a:xfrm>
-            <a:off x="8046720" y="1097280"/>
-            <a:ext cx="3291840" cy="3840480"/>
+            <a:off x="731520" y="1280160"/>
+            <a:ext cx="5120640" cy="3931920"/>
           </a:xfrm>
           <a:prstGeom prst="roundRect">
             <a:avLst/>
           </a:prstGeom>
           <a:solidFill>
-            <a:srgbClr val="0F172A"/>
+            <a:srgbClr val="FFFFFF"/>
           </a:solidFill>
-          <a:ln w="25400">
+          <a:ln w="19050">
             <a:solidFill>
-              <a:srgbClr val="2563EB"/>
+              <a:srgbClr val="E2E8F0"/>
             </a:solidFill>
           </a:ln>
         </p:spPr>
@@ -3258,30 +3251,6 @@
           </a:p>
         </p:txBody>
       </p:sp>
-      <p:pic>
-        <p:nvPicPr>
-          <p:cNvPr id="5" name="Picture 4" descr="icon.png"/>
-          <p:cNvPicPr>
-            <a:picLocks noChangeAspect="1"/>
-          </p:cNvPicPr>
-          <p:nvPr/>
-        </p:nvPicPr>
-        <p:blipFill>
-          <a:blip r:embed="rId2"/>
-          <a:stretch>
-            <a:fillRect/>
-          </a:stretch>
-        </p:blipFill>
-        <p:spPr>
-          <a:xfrm>
-            <a:off x="8503920" y="1463040"/>
-            <a:ext cx="2377440" cy="2377440"/>
-          </a:xfrm>
-          <a:prstGeom prst="rect">
-            <a:avLst/>
-          </a:prstGeom>
-        </p:spPr>
-      </p:pic>
       <p:sp>
         <p:nvSpPr>
           <p:cNvPr id="6" name="TextBox 5"/>
@@ -3290,8 +3259,8 @@
         </p:nvSpPr>
         <p:spPr>
           <a:xfrm>
-            <a:off x="8138160" y="4023360"/>
-            <a:ext cx="3108960" cy="822960"/>
+            <a:off x="914400" y="1444752"/>
+            <a:ext cx="4754880" cy="3602736"/>
           </a:xfrm>
           <a:prstGeom prst="rect">
             <a:avLst/>
@@ -3299,32 +3268,127 @@
           <a:noFill/>
         </p:spPr>
         <p:txBody>
-          <a:bodyPr wrap="square">
+          <a:bodyPr wrap="square" anchor="t">
             <a:spAutoFit/>
           </a:bodyPr>
           <a:lstStyle/>
           <a:p>
-            <a:pPr algn="ctr">
+            <a:pPr>
               <a:defRPr sz="1400" b="1">
                 <a:solidFill>
-                  <a:srgbClr val="FFFFFF"/>
-                </a:solidFill>
-              </a:defRPr>
-            </a:pPr>
-            <a:r>
-              <a:t>ZEL AI Companion</a:t>
-            </a:r>
-          </a:p>
-          <a:p>
-            <a:pPr algn="ctr">
-              <a:defRPr sz="1000">
-                <a:solidFill>
-                  <a:srgbClr val="94A3B8"/>
-                </a:solidFill>
-              </a:defRPr>
-            </a:pPr>
-            <a:r>
-              <a:t>Always-on desktop copilot for agents &amp; supervisors</a:t>
+                  <a:srgbClr val="1E3A8A"/>
+                </a:solidFill>
+              </a:defRPr>
+            </a:pPr>
+            <a:r>
+              <a:t>The Operational Challenge in Legacy Contact Centers</a:t>
+            </a:r>
+          </a:p>
+          <a:p>
+            <a:pPr>
+              <a:spcAft>
+                <a:spcPts val="800"/>
+              </a:spcAft>
+              <a:defRPr sz="1000" i="1">
+                <a:solidFill>
+                  <a:srgbClr val="64748B"/>
+                </a:solidFill>
+              </a:defRPr>
+            </a:pPr>
+            <a:r>
+              <a:t>Manual AUX States, Opaque Floor Drift &amp; Burnout Risk</a:t>
+            </a:r>
+          </a:p>
+          <a:p>
+            <a:pPr>
+              <a:spcAft>
+                <a:spcPts val="600"/>
+              </a:spcAft>
+              <a:defRPr b="1" sz="1000">
+                <a:solidFill>
+                  <a:srgbClr val="0F172A"/>
+                </a:solidFill>
+              </a:defRPr>
+            </a:pPr>
+            <a:r>
+              <a:t>• Discretionary AUX Blind Spots: </a:t>
+            </a:r>
+            <a:r>
+              <a:rPr b="0" sz="1000">
+                <a:solidFill>
+                  <a:srgbClr val="64748B"/>
+                </a:solidFill>
+              </a:rPr>
+              <a:t>Agents manually toggle break codes without real-time Erlang-C staffing checks, leading to severe intraday queue starvation.</a:t>
+            </a:r>
+          </a:p>
+          <a:p>
+            <a:pPr>
+              <a:spcAft>
+                <a:spcPts val="600"/>
+              </a:spcAft>
+              <a:defRPr b="1" sz="1000">
+                <a:solidFill>
+                  <a:srgbClr val="0F172A"/>
+                </a:solidFill>
+              </a:defRPr>
+            </a:pPr>
+            <a:r>
+              <a:t>• Sudden Inbound Queue Surges: </a:t>
+            </a:r>
+            <a:r>
+              <a:rPr b="0" sz="1000">
+                <a:solidFill>
+                  <a:srgbClr val="64748B"/>
+                </a:solidFill>
+              </a:rPr>
+              <a:t>Volume spikes (+300 calls) instantly drop SLAs from 85% to 34% while donor queues remain idle and underutilized.</a:t>
+            </a:r>
+          </a:p>
+          <a:p>
+            <a:pPr>
+              <a:spcAft>
+                <a:spcPts val="600"/>
+              </a:spcAft>
+              <a:defRPr b="1" sz="1000">
+                <a:solidFill>
+                  <a:srgbClr val="0F172A"/>
+                </a:solidFill>
+              </a:defRPr>
+            </a:pPr>
+            <a:r>
+              <a:t>• Post-Call Wrap-up (ACW) Latency: </a:t>
+            </a:r>
+            <a:r>
+              <a:rPr b="0" sz="1000">
+                <a:solidFill>
+                  <a:srgbClr val="64748B"/>
+                </a:solidFill>
+              </a:rPr>
+              <a:t>Agents spend 60-90s manually entering CRM wrap-up notes, degrading handle times and inflating operational cost.</a:t>
+            </a:r>
+          </a:p>
+          <a:p>
+            <a:pPr>
+              <a:spcAft>
+                <a:spcPts val="600"/>
+              </a:spcAft>
+              <a:defRPr b="1" sz="1000">
+                <a:solidFill>
+                  <a:srgbClr val="0F172A"/>
+                </a:solidFill>
+              </a:defRPr>
+            </a:pPr>
+            <a:r>
+              <a:t>• Regional Disaster Outages: </a:t>
+            </a:r>
+            <a:r>
+              <a:rPr b="0" sz="1000">
+                <a:solidFill>
+                  <a:srgbClr val="64748B"/>
+                </a:solidFill>
+              </a:rPr>
+              <a:t>Severe storms flood queues past 1,000 calls/min with no automated front-line deflection, paralyzing live agents.</a:t>
             </a:r>
           </a:p>
         </p:txBody>
@@ -3337,18 +3401,18 @@
         </p:nvSpPr>
         <p:spPr>
           <a:xfrm>
-            <a:off x="822960" y="5120640"/>
-            <a:ext cx="3337560" cy="1280160"/>
+            <a:off x="6217920" y="1280160"/>
+            <a:ext cx="5212080" cy="3931920"/>
           </a:xfrm>
           <a:prstGeom prst="roundRect">
             <a:avLst/>
           </a:prstGeom>
           <a:solidFill>
-            <a:srgbClr val="112240"/>
+            <a:srgbClr val="FFFFFF"/>
           </a:solidFill>
           <a:ln w="19050">
             <a:solidFill>
-              <a:srgbClr val="1E3A8A"/>
+              <a:srgbClr val="E2E8F0"/>
             </a:solidFill>
           </a:ln>
         </p:spPr>
@@ -3382,8 +3446,8 @@
         </p:nvSpPr>
         <p:spPr>
           <a:xfrm>
-            <a:off x="960120" y="5212080"/>
-            <a:ext cx="3063240" cy="1097280"/>
+            <a:off x="6400800" y="1444752"/>
+            <a:ext cx="4846320" cy="3602736"/>
           </a:xfrm>
           <a:prstGeom prst="rect">
             <a:avLst/>
@@ -3391,32 +3455,127 @@
           <a:noFill/>
         </p:spPr>
         <p:txBody>
-          <a:bodyPr wrap="square">
+          <a:bodyPr wrap="square" anchor="t">
             <a:spAutoFit/>
           </a:bodyPr>
           <a:lstStyle/>
           <a:p>
             <a:pPr>
-              <a:defRPr sz="1100" b="1">
-                <a:solidFill>
-                  <a:srgbClr val="0EA5E9"/>
-                </a:solidFill>
-              </a:defRPr>
-            </a:pPr>
-            <a:r>
-              <a:t>⚡ Zero Wait to Leave</a:t>
+              <a:defRPr sz="1400" b="1">
+                <a:solidFill>
+                  <a:srgbClr val="1E3A8A"/>
+                </a:solidFill>
+              </a:defRPr>
+            </a:pPr>
+            <a:r>
+              <a:t>The Autonomous AI-Powered WFM Solution</a:t>
             </a:r>
           </a:p>
           <a:p>
             <a:pPr>
-              <a:defRPr sz="950">
-                <a:solidFill>
-                  <a:srgbClr val="E2E8F0"/>
-                </a:solidFill>
-              </a:defRPr>
-            </a:pPr>
-            <a:r>
-              <a:t>Microsecond Erlang-C capacity gating grants tea/bio breaks instantly without waiting for supervisor chat.</a:t>
+              <a:spcAft>
+                <a:spcPts val="800"/>
+              </a:spcAft>
+              <a:defRPr sz="1000" i="1">
+                <a:solidFill>
+                  <a:srgbClr val="64748B"/>
+                </a:solidFill>
+              </a:defRPr>
+            </a:pPr>
+            <a:r>
+              <a:t>Dual Agent &amp; Supervisor Intelligence Ecosystem</a:t>
+            </a:r>
+          </a:p>
+          <a:p>
+            <a:pPr>
+              <a:spcAft>
+                <a:spcPts val="600"/>
+              </a:spcAft>
+              <a:defRPr b="1" sz="1000">
+                <a:solidFill>
+                  <a:srgbClr val="0F172A"/>
+                </a:solidFill>
+              </a:defRPr>
+            </a:pPr>
+            <a:r>
+              <a:t>• ZEL Ask Shankar Desktop Assistant: </a:t>
+            </a:r>
+            <a:r>
+              <a:rPr b="0" sz="1000">
+                <a:solidFill>
+                  <a:srgbClr val="64748B"/>
+                </a:solidFill>
+              </a:rPr>
+              <a:t>Always-on-top Electron companion providing 1-click ACW call summarization, live speech tone guidance, and CTI status sync.</a:t>
+            </a:r>
+          </a:p>
+          <a:p>
+            <a:pPr>
+              <a:spcAft>
+                <a:spcPts val="600"/>
+              </a:spcAft>
+              <a:defRPr b="1" sz="1000">
+                <a:solidFill>
+                  <a:srgbClr val="0F172A"/>
+                </a:solidFill>
+              </a:defRPr>
+            </a:pPr>
+            <a:r>
+              <a:t>• Autonomous Break Gatekeeper: </a:t>
+            </a:r>
+            <a:r>
+              <a:rPr b="0" sz="1000">
+                <a:solidFill>
+                  <a:srgbClr val="64748B"/>
+                </a:solidFill>
+              </a:rPr>
+              <a:t>Real-time Erlang-C staffing capacity evaluation approving/throttling tea, bio, and lunch breaks instantly.</a:t>
+            </a:r>
+          </a:p>
+          <a:p>
+            <a:pPr>
+              <a:spcAft>
+                <a:spcPts val="600"/>
+              </a:spcAft>
+              <a:defRPr b="1" sz="1000">
+                <a:solidFill>
+                  <a:srgbClr val="0F172A"/>
+                </a:solidFill>
+              </a:defRPr>
+            </a:pPr>
+            <a:r>
+              <a:t>• Dynamic Cross-Skill Rebalance: </a:t>
+            </a:r>
+            <a:r>
+              <a:rPr b="0" sz="1000">
+                <a:solidFill>
+                  <a:srgbClr val="64748B"/>
+                </a:solidFill>
+              </a:rPr>
+              <a:t>Auto-detects queue load imbalances and reallocates certified cross-skilled agents in real-time, restoring SLAs to 88.5%.</a:t>
+            </a:r>
+          </a:p>
+          <a:p>
+            <a:pPr>
+              <a:spcAft>
+                <a:spcPts val="600"/>
+              </a:spcAft>
+              <a:defRPr b="1" sz="1000">
+                <a:solidFill>
+                  <a:srgbClr val="0F172A"/>
+                </a:solidFill>
+              </a:defRPr>
+            </a:pPr>
+            <a:r>
+              <a:t>• Storm Disaster Auto-Deflection: </a:t>
+            </a:r>
+            <a:r>
+              <a:rPr b="0" sz="1000">
+                <a:solidFill>
+                  <a:srgbClr val="64748B"/>
+                </a:solidFill>
+              </a:rPr>
+              <a:t>Automated front-end IVR speech deflection triggering at 1,000 calls/min, protecting agents during emergency outages.</a:t>
             </a:r>
           </a:p>
         </p:txBody>
@@ -3429,18 +3588,18 @@
         </p:nvSpPr>
         <p:spPr>
           <a:xfrm>
-            <a:off x="4389120" y="5120640"/>
-            <a:ext cx="3337560" cy="1280160"/>
+            <a:off x="731520" y="5440680"/>
+            <a:ext cx="10698480" cy="1051560"/>
           </a:xfrm>
           <a:prstGeom prst="roundRect">
             <a:avLst/>
           </a:prstGeom>
           <a:solidFill>
-            <a:srgbClr val="112240"/>
+            <a:srgbClr val="EEF2FF"/>
           </a:solidFill>
-          <a:ln w="19050">
+          <a:ln>
             <a:solidFill>
-              <a:srgbClr val="1E3A8A"/>
+              <a:srgbClr val="2563EB"/>
             </a:solidFill>
           </a:ln>
         </p:spPr>
@@ -3459,148 +3618,30 @@
           </a:fontRef>
         </p:style>
         <p:txBody>
-          <a:bodyPr rtlCol="0" anchor="ctr"/>
-          <a:lstStyle/>
-          <a:p>
-            <a:pPr algn="ctr"/>
-          </a:p>
-        </p:txBody>
-      </p:sp>
-      <p:sp>
-        <p:nvSpPr>
-          <p:cNvPr id="10" name="TextBox 9"/>
-          <p:cNvSpPr txBox="1"/>
-          <p:nvPr/>
-        </p:nvSpPr>
-        <p:spPr>
-          <a:xfrm>
-            <a:off x="4526280" y="5212080"/>
-            <a:ext cx="3063240" cy="1097280"/>
-          </a:xfrm>
-          <a:prstGeom prst="rect">
-            <a:avLst/>
-          </a:prstGeom>
-          <a:noFill/>
-        </p:spPr>
-        <p:txBody>
-          <a:bodyPr wrap="square">
-            <a:spAutoFit/>
-          </a:bodyPr>
-          <a:lstStyle/>
-          <a:p>
-            <a:pPr>
+          <a:bodyPr rtlCol="0" anchor="ctr" wrap="square"/>
+          <a:lstStyle/>
+          <a:p>
+            <a:pPr algn="ctr">
               <a:defRPr sz="1100" b="1">
                 <a:solidFill>
-                  <a:srgbClr val="0EA5E9"/>
-                </a:solidFill>
-              </a:defRPr>
-            </a:pPr>
-            <a:r>
-              <a:t>🔄 Zero Wait to Return</a:t>
+                  <a:srgbClr val="1E3A8A"/>
+                </a:solidFill>
+              </a:defRPr>
+            </a:pPr>
+            <a:r>
+              <a:t>CORE TRANSFORMATION PRINCIPLE: FROM PASSIVE LOGGING TO AUTONOMOUS QUEUE DEFENSE</a:t>
             </a:r>
           </a:p>
           <a:p>
             <a:pPr>
               <a:defRPr sz="950">
                 <a:solidFill>
-                  <a:srgbClr val="E2E8F0"/>
-                </a:solidFill>
-              </a:defRPr>
-            </a:pPr>
-            <a:r>
-              <a:t>Automated desktop voice recalls and countdown timers ensure effortless, prompt return to available state.</a:t>
-            </a:r>
-          </a:p>
-        </p:txBody>
-      </p:sp>
-      <p:sp>
-        <p:nvSpPr>
-          <p:cNvPr id="11" name="Rounded Rectangle 10"/>
-          <p:cNvSpPr/>
-          <p:nvPr/>
-        </p:nvSpPr>
-        <p:spPr>
-          <a:xfrm>
-            <a:off x="7955279" y="5120640"/>
-            <a:ext cx="3337560" cy="1280160"/>
-          </a:xfrm>
-          <a:prstGeom prst="roundRect">
-            <a:avLst/>
-          </a:prstGeom>
-          <a:solidFill>
-            <a:srgbClr val="112240"/>
-          </a:solidFill>
-          <a:ln w="19050">
-            <a:solidFill>
-              <a:srgbClr val="1E3A8A"/>
-            </a:solidFill>
-          </a:ln>
-        </p:spPr>
-        <p:style>
-          <a:lnRef idx="1">
-            <a:schemeClr val="accent1"/>
-          </a:lnRef>
-          <a:fillRef idx="3">
-            <a:schemeClr val="accent1"/>
-          </a:fillRef>
-          <a:effectRef idx="2">
-            <a:schemeClr val="accent1"/>
-          </a:effectRef>
-          <a:fontRef idx="minor">
-            <a:schemeClr val="lt1"/>
-          </a:fontRef>
-        </p:style>
-        <p:txBody>
-          <a:bodyPr rtlCol="0" anchor="ctr"/>
-          <a:lstStyle/>
-          <a:p>
-            <a:pPr algn="ctr"/>
-          </a:p>
-        </p:txBody>
-      </p:sp>
-      <p:sp>
-        <p:nvSpPr>
-          <p:cNvPr id="12" name="TextBox 11"/>
-          <p:cNvSpPr txBox="1"/>
-          <p:nvPr/>
-        </p:nvSpPr>
-        <p:spPr>
-          <a:xfrm>
-            <a:off x="8092439" y="5212080"/>
-            <a:ext cx="3063240" cy="1097280"/>
-          </a:xfrm>
-          <a:prstGeom prst="rect">
-            <a:avLst/>
-          </a:prstGeom>
-          <a:noFill/>
-        </p:spPr>
-        <p:txBody>
-          <a:bodyPr wrap="square">
-            <a:spAutoFit/>
-          </a:bodyPr>
-          <a:lstStyle/>
-          <a:p>
-            <a:pPr>
-              <a:defRPr sz="1100" b="1">
-                <a:solidFill>
-                  <a:srgbClr val="0EA5E9"/>
-                </a:solidFill>
-              </a:defRPr>
-            </a:pPr>
-            <a:r>
-              <a:t>🛡️ Instant Queue Protection</a:t>
-            </a:r>
-          </a:p>
-          <a:p>
-            <a:pPr>
-              <a:defRPr sz="950">
-                <a:solidFill>
-                  <a:srgbClr val="E2E8F0"/>
-                </a:solidFill>
-              </a:defRPr>
-            </a:pPr>
-            <a:r>
-              <a:t>Dynamic skill flex rebalances 300+ surge calls in under 3 minutes, safeguarding customer SLAs.</a:t>
+                  <a:srgbClr val="0F172A"/>
+                </a:solidFill>
+              </a:defRPr>
+            </a:pPr>
+            <a:r>
+              <a:t>By pairing an always-on floating Ask Shankar with an intelligent Supervisor Telemetry Command Center, the platform replaces guesswork with microsecond Erlang-C mathematical balance, safeguarding SLAs while elevating agent well-being.</a:t>
             </a:r>
           </a:p>
         </p:txBody>
@@ -3676,8 +3717,8 @@
         </p:nvSpPr>
         <p:spPr>
           <a:xfrm>
-            <a:off x="731520" y="128016"/>
-            <a:ext cx="10515600" cy="868680"/>
+            <a:off x="731520" y="146304"/>
+            <a:ext cx="10515600" cy="274320"/>
           </a:xfrm>
           <a:prstGeom prst="rect">
             <a:avLst/>
@@ -3698,33 +3739,56 @@
               </a:defRPr>
             </a:pPr>
             <a:r>
-              <a:t>ZERO WAIT TO LEAVE, ZERO WAIT TO RETURN</a:t>
-            </a:r>
-          </a:p>
+              <a:t>DUAL-PERSONA AGENT &amp; SUPERVISOR ARCHITECTURE</a:t>
+            </a:r>
+          </a:p>
+        </p:txBody>
+      </p:sp>
+      <p:sp>
+        <p:nvSpPr>
+          <p:cNvPr id="4" name="TextBox 3"/>
+          <p:cNvSpPr txBox="1"/>
+          <p:nvPr/>
+        </p:nvSpPr>
+        <p:spPr>
+          <a:xfrm>
+            <a:off x="731520" y="384048"/>
+            <a:ext cx="10515600" cy="548640"/>
+          </a:xfrm>
+          <a:prstGeom prst="rect">
+            <a:avLst/>
+          </a:prstGeom>
+          <a:noFill/>
+        </p:spPr>
+        <p:txBody>
+          <a:bodyPr wrap="square">
+            <a:spAutoFit/>
+          </a:bodyPr>
+          <a:lstStyle/>
           <a:p>
             <a:pPr>
-              <a:defRPr sz="2100" b="1">
+              <a:defRPr sz="2200" b="1">
                 <a:solidFill>
                   <a:srgbClr val="FFFFFF"/>
                 </a:solidFill>
               </a:defRPr>
             </a:pPr>
             <a:r>
-              <a:t>How ZEL Works: The Frictionless Break &amp; Return Flow</a:t>
-            </a:r>
-          </a:p>
-        </p:txBody>
-      </p:sp>
-      <p:sp>
-        <p:nvSpPr>
-          <p:cNvPr id="4" name="Rounded Rectangle 3"/>
+              <a:t>Platform Capabilities &amp; Feature Matrix</a:t>
+            </a:r>
+          </a:p>
+        </p:txBody>
+      </p:sp>
+      <p:sp>
+        <p:nvSpPr>
+          <p:cNvPr id="5" name="Rounded Rectangle 4"/>
           <p:cNvSpPr/>
           <p:nvPr/>
         </p:nvSpPr>
         <p:spPr>
           <a:xfrm>
             <a:off x="731520" y="1280160"/>
-            <a:ext cx="2514600" cy="2926080"/>
+            <a:ext cx="5120640" cy="2468880"/>
           </a:xfrm>
           <a:prstGeom prst="roundRect">
             <a:avLst/>
@@ -3732,9 +3796,9 @@
           <a:solidFill>
             <a:srgbClr val="FFFFFF"/>
           </a:solidFill>
-          <a:ln w="25400">
+          <a:ln w="19050">
             <a:solidFill>
-              <a:srgbClr val="2563EB"/>
+              <a:srgbClr val="E2E8F0"/>
             </a:solidFill>
           </a:ln>
         </p:spPr>
@@ -3762,24 +3826,134 @@
       </p:sp>
       <p:sp>
         <p:nvSpPr>
-          <p:cNvPr id="5" name="Rounded Rectangle 4"/>
+          <p:cNvPr id="6" name="TextBox 5"/>
+          <p:cNvSpPr txBox="1"/>
+          <p:nvPr/>
+        </p:nvSpPr>
+        <p:spPr>
+          <a:xfrm>
+            <a:off x="914400" y="1444752"/>
+            <a:ext cx="4754880" cy="2139696"/>
+          </a:xfrm>
+          <a:prstGeom prst="rect">
+            <a:avLst/>
+          </a:prstGeom>
+          <a:noFill/>
+        </p:spPr>
+        <p:txBody>
+          <a:bodyPr wrap="square" anchor="t">
+            <a:spAutoFit/>
+          </a:bodyPr>
+          <a:lstStyle/>
+          <a:p>
+            <a:pPr>
+              <a:defRPr sz="1400" b="1">
+                <a:solidFill>
+                  <a:srgbClr val="1E3A8A"/>
+                </a:solidFill>
+              </a:defRPr>
+            </a:pPr>
+            <a:r>
+              <a:t>1. Agent Desktop Assistant (Ask Shankar)</a:t>
+            </a:r>
+          </a:p>
+          <a:p>
+            <a:pPr>
+              <a:spcAft>
+                <a:spcPts val="800"/>
+              </a:spcAft>
+              <a:defRPr sz="1000" i="1">
+                <a:solidFill>
+                  <a:srgbClr val="64748B"/>
+                </a:solidFill>
+              </a:defRPr>
+            </a:pPr>
+            <a:r>
+              <a:t>Companion Widget for Front-Line Staff</a:t>
+            </a:r>
+          </a:p>
+          <a:p>
+            <a:pPr>
+              <a:spcAft>
+                <a:spcPts val="300"/>
+              </a:spcAft>
+              <a:defRPr sz="950">
+                <a:solidFill>
+                  <a:srgbClr val="0F172A"/>
+                </a:solidFill>
+              </a:defRPr>
+            </a:pPr>
+            <a:r>
+              <a:t>✔ Instant ACW Summarizer: Auto-generates structured CRM wrap-up notes.</a:t>
+            </a:r>
+          </a:p>
+          <a:p>
+            <a:pPr>
+              <a:spcAft>
+                <a:spcPts val="300"/>
+              </a:spcAft>
+              <a:defRPr sz="950">
+                <a:solidFill>
+                  <a:srgbClr val="0F172A"/>
+                </a:solidFill>
+              </a:defRPr>
+            </a:pPr>
+            <a:r>
+              <a:t>✔ Live Speech Suggestions: Real-time objections handling and compliance prompts.</a:t>
+            </a:r>
+          </a:p>
+          <a:p>
+            <a:pPr>
+              <a:spcAft>
+                <a:spcPts val="300"/>
+              </a:spcAft>
+              <a:defRPr sz="950">
+                <a:solidFill>
+                  <a:srgbClr val="0F172A"/>
+                </a:solidFill>
+              </a:defRPr>
+            </a:pPr>
+            <a:r>
+              <a:t>✔ Discretionary Break Portal: Autonomous 15-minute Erlang-C capacity grant.</a:t>
+            </a:r>
+          </a:p>
+          <a:p>
+            <a:pPr>
+              <a:spcAft>
+                <a:spcPts val="300"/>
+              </a:spcAft>
+              <a:defRPr sz="950">
+                <a:solidFill>
+                  <a:srgbClr val="0F172A"/>
+                </a:solidFill>
+              </a:defRPr>
+            </a:pPr>
+            <a:r>
+              <a:t>✔ IT Hardware Issue Log (AUX-5): Direct Citrix/VPN/audio incident ticketing.</a:t>
+            </a:r>
+          </a:p>
+        </p:txBody>
+      </p:sp>
+      <p:sp>
+        <p:nvSpPr>
+          <p:cNvPr id="7" name="Rounded Rectangle 6"/>
           <p:cNvSpPr/>
           <p:nvPr/>
         </p:nvSpPr>
         <p:spPr>
           <a:xfrm>
-            <a:off x="868680" y="1417320"/>
-            <a:ext cx="2240280" cy="384048"/>
+            <a:off x="6217920" y="1280160"/>
+            <a:ext cx="5212080" cy="2468880"/>
           </a:xfrm>
           <a:prstGeom prst="roundRect">
             <a:avLst/>
           </a:prstGeom>
           <a:solidFill>
-            <a:srgbClr val="2563EB"/>
+            <a:srgbClr val="FFFFFF"/>
           </a:solidFill>
-          <a:ln>
+          <a:ln w="19050">
             <a:solidFill>
-              <a:srgbClr val="2563EB"/>
+              <a:srgbClr val="E2E8F0"/>
             </a:solidFill>
           </a:ln>
         </p:spPr>
@@ -3801,29 +3975,20 @@
           <a:bodyPr rtlCol="0" anchor="ctr"/>
           <a:lstStyle/>
           <a:p>
-            <a:pPr algn="ctr">
-              <a:defRPr sz="1100" b="1">
-                <a:solidFill>
-                  <a:srgbClr val="FFFFFF"/>
-                </a:solidFill>
-              </a:defRPr>
-            </a:pPr>
-            <a:r>
-              <a:t>Step 1: 1-Click Request</a:t>
-            </a:r>
-          </a:p>
-        </p:txBody>
-      </p:sp>
-      <p:sp>
-        <p:nvSpPr>
-          <p:cNvPr id="6" name="TextBox 5"/>
+            <a:pPr algn="ctr"/>
+          </a:p>
+        </p:txBody>
+      </p:sp>
+      <p:sp>
+        <p:nvSpPr>
+          <p:cNvPr id="8" name="TextBox 7"/>
           <p:cNvSpPr txBox="1"/>
           <p:nvPr/>
         </p:nvSpPr>
         <p:spPr>
           <a:xfrm>
-            <a:off x="868680" y="1874519"/>
-            <a:ext cx="2240280" cy="2194560"/>
+            <a:off x="6400800" y="1444752"/>
+            <a:ext cx="4846320" cy="2139696"/>
           </a:xfrm>
           <a:prstGeom prst="rect">
             <a:avLst/>
@@ -3831,86 +3996,119 @@
           <a:noFill/>
         </p:spPr>
         <p:txBody>
-          <a:bodyPr wrap="square">
+          <a:bodyPr wrap="square" anchor="t">
             <a:spAutoFit/>
           </a:bodyPr>
           <a:lstStyle/>
+          <a:p>
+            <a:pPr>
+              <a:defRPr sz="1400" b="1">
+                <a:solidFill>
+                  <a:srgbClr val="1E3A8A"/>
+                </a:solidFill>
+              </a:defRPr>
+            </a:pPr>
+            <a:r>
+              <a:t>2. Supervisor Floor Command Center</a:t>
+            </a:r>
+          </a:p>
           <a:p>
             <a:pPr>
               <a:spcAft>
                 <a:spcPts val="800"/>
               </a:spcAft>
-              <a:defRPr sz="1000" b="1">
-                <a:solidFill>
-                  <a:srgbClr val="0F172A"/>
-                </a:solidFill>
-              </a:defRPr>
-            </a:pPr>
-            <a:r>
-              <a:t>Action:</a:t>
-            </a:r>
-            <a:br/>
-            <a:r>
-              <a:t>Agent selects Break in floating widget</a:t>
+              <a:defRPr sz="1000" i="1">
+                <a:solidFill>
+                  <a:srgbClr val="64748B"/>
+                </a:solidFill>
+              </a:defRPr>
+            </a:pPr>
+            <a:r>
+              <a:t>Live Telemetry &amp; Team Governance</a:t>
             </a:r>
           </a:p>
           <a:p>
             <a:pPr>
               <a:spcAft>
-                <a:spcPts val="800"/>
+                <a:spcPts val="300"/>
               </a:spcAft>
               <a:defRPr sz="950">
                 <a:solidFill>
-                  <a:srgbClr val="64748B"/>
-                </a:solidFill>
-              </a:defRPr>
-            </a:pPr>
-            <a:r>
-              <a:t>Feature:</a:t>
-            </a:r>
-            <a:br/>
-            <a:r>
-              <a:t>• Tea, Bio, Lunch, or System Issue</a:t>
+                  <a:srgbClr val="0F172A"/>
+                </a:solidFill>
+              </a:defRPr>
+            </a:pPr>
+            <a:r>
+              <a:t>✔ Floor Telemetry Wallboard: Synchronized with NICE CXone MAX CTI engine.</a:t>
             </a:r>
           </a:p>
           <a:p>
             <a:pPr>
-              <a:defRPr sz="950" b="1">
-                <a:solidFill>
-                  <a:srgbClr val="059669"/>
-                </a:solidFill>
-              </a:defRPr>
-            </a:pPr>
-            <a:r>
-              <a:t>Outcome:</a:t>
-            </a:r>
-            <a:br/>
-            <a:r>
-              <a:t>✔ Agent never leaves workspace</a:t>
-            </a:r>
-          </a:p>
-        </p:txBody>
-      </p:sp>
-      <p:sp>
-        <p:nvSpPr>
-          <p:cNvPr id="7" name="Chevron 6"/>
+              <a:spcAft>
+                <a:spcPts val="300"/>
+              </a:spcAft>
+              <a:defRPr sz="950">
+                <a:solidFill>
+                  <a:srgbClr val="0F172A"/>
+                </a:solidFill>
+              </a:defRPr>
+            </a:pPr>
+            <a:r>
+              <a:t>✔ Scoped Team Tagging: Specific agents routed to dedicated supervisors.</a:t>
+            </a:r>
+          </a:p>
+          <a:p>
+            <a:pPr>
+              <a:spcAft>
+                <a:spcPts val="300"/>
+              </a:spcAft>
+              <a:defRPr sz="950">
+                <a:solidFill>
+                  <a:srgbClr val="0F172A"/>
+                </a:solidFill>
+              </a:defRPr>
+            </a:pPr>
+            <a:r>
+              <a:t>✔ Automated Voice Bot Recall: Dispatches immediate synthesized call to desk.</a:t>
+            </a:r>
+          </a:p>
+          <a:p>
+            <a:pPr>
+              <a:spcAft>
+                <a:spcPts val="300"/>
+              </a:spcAft>
+              <a:defRPr sz="950">
+                <a:solidFill>
+                  <a:srgbClr val="0F172A"/>
+                </a:solidFill>
+              </a:defRPr>
+            </a:pPr>
+            <a:r>
+              <a:t>✔ Shift Adherence Governance: Policy guardrails for lunch and tea limits.</a:t>
+            </a:r>
+          </a:p>
+        </p:txBody>
+      </p:sp>
+      <p:sp>
+        <p:nvSpPr>
+          <p:cNvPr id="9" name="Rounded Rectangle 8"/>
           <p:cNvSpPr/>
           <p:nvPr/>
         </p:nvSpPr>
         <p:spPr>
           <a:xfrm>
-            <a:off x="3273552" y="2560320"/>
-            <a:ext cx="164592" cy="320040"/>
-          </a:xfrm>
-          <a:prstGeom prst="chevron">
+            <a:off x="731520" y="3977639"/>
+            <a:ext cx="5120640" cy="2468880"/>
+          </a:xfrm>
+          <a:prstGeom prst="roundRect">
             <a:avLst/>
           </a:prstGeom>
           <a:solidFill>
-            <a:srgbClr val="2563EB"/>
+            <a:srgbClr val="FFFFFF"/>
           </a:solidFill>
-          <a:ln>
+          <a:ln w="19050">
             <a:solidFill>
-              <a:srgbClr val="2563EB"/>
+              <a:srgbClr val="E2E8F0"/>
             </a:solidFill>
           </a:ln>
         </p:spPr>
@@ -3938,14 +4136,124 @@
       </p:sp>
       <p:sp>
         <p:nvSpPr>
-          <p:cNvPr id="8" name="Rounded Rectangle 7"/>
+          <p:cNvPr id="10" name="TextBox 9"/>
+          <p:cNvSpPr txBox="1"/>
+          <p:nvPr/>
+        </p:nvSpPr>
+        <p:spPr>
+          <a:xfrm>
+            <a:off x="914400" y="4142231"/>
+            <a:ext cx="4754880" cy="2139696"/>
+          </a:xfrm>
+          <a:prstGeom prst="rect">
+            <a:avLst/>
+          </a:prstGeom>
+          <a:noFill/>
+        </p:spPr>
+        <p:txBody>
+          <a:bodyPr wrap="square" anchor="t">
+            <a:spAutoFit/>
+          </a:bodyPr>
+          <a:lstStyle/>
+          <a:p>
+            <a:pPr>
+              <a:defRPr sz="1400" b="1">
+                <a:solidFill>
+                  <a:srgbClr val="1E3A8A"/>
+                </a:solidFill>
+              </a:defRPr>
+            </a:pPr>
+            <a:r>
+              <a:t>3. Dynamic WFM Skill Flex Engine</a:t>
+            </a:r>
+          </a:p>
+          <a:p>
+            <a:pPr>
+              <a:spcAft>
+                <a:spcPts val="800"/>
+              </a:spcAft>
+              <a:defRPr sz="1000" i="1">
+                <a:solidFill>
+                  <a:srgbClr val="64748B"/>
+                </a:solidFill>
+              </a:defRPr>
+            </a:pPr>
+            <a:r>
+              <a:t>Intraday Queue Balancing &amp; Surge Defense</a:t>
+            </a:r>
+          </a:p>
+          <a:p>
+            <a:pPr>
+              <a:spcAft>
+                <a:spcPts val="300"/>
+              </a:spcAft>
+              <a:defRPr sz="950">
+                <a:solidFill>
+                  <a:srgbClr val="0F172A"/>
+                </a:solidFill>
+              </a:defRPr>
+            </a:pPr>
+            <a:r>
+              <a:t>✔ 6 Telephony Queues: Billing, Support, Emergency, CS, Bilingual, Collections.</a:t>
+            </a:r>
+          </a:p>
+          <a:p>
+            <a:pPr>
+              <a:spcAft>
+                <a:spcPts val="300"/>
+              </a:spcAft>
+              <a:defRPr sz="950">
+                <a:solidFill>
+                  <a:srgbClr val="0F172A"/>
+                </a:solidFill>
+              </a:defRPr>
+            </a:pPr>
+            <a:r>
+              <a:t>✔ Surge Simulation: Simulates +318 calls spike (ASA 9m, SLA drop to 34.5%).</a:t>
+            </a:r>
+          </a:p>
+          <a:p>
+            <a:pPr>
+              <a:spcAft>
+                <a:spcPts val="300"/>
+              </a:spcAft>
+              <a:defRPr sz="950">
+                <a:solidFill>
+                  <a:srgbClr val="0F172A"/>
+                </a:solidFill>
+              </a:defRPr>
+            </a:pPr>
+            <a:r>
+              <a:t>✔ 1-Click Cross-Skilling: Flexes 3 idle CS agents to Billing in microsecond sync.</a:t>
+            </a:r>
+          </a:p>
+          <a:p>
+            <a:pPr>
+              <a:spcAft>
+                <a:spcPts val="300"/>
+              </a:spcAft>
+              <a:defRPr sz="950">
+                <a:solidFill>
+                  <a:srgbClr val="0F172A"/>
+                </a:solidFill>
+              </a:defRPr>
+            </a:pPr>
+            <a:r>
+              <a:t>✔ Volume Normalization: 1-click restore to base schedules when traffic clears.</a:t>
+            </a:r>
+          </a:p>
+        </p:txBody>
+      </p:sp>
+      <p:sp>
+        <p:nvSpPr>
+          <p:cNvPr id="11" name="Rounded Rectangle 10"/>
           <p:cNvSpPr/>
           <p:nvPr/>
         </p:nvSpPr>
         <p:spPr>
           <a:xfrm>
-            <a:off x="3429000" y="1280160"/>
-            <a:ext cx="2514600" cy="2926080"/>
+            <a:off x="6217920" y="3977639"/>
+            <a:ext cx="5212080" cy="2468880"/>
           </a:xfrm>
           <a:prstGeom prst="roundRect">
             <a:avLst/>
@@ -3953,9 +4261,9 @@
           <a:solidFill>
             <a:srgbClr val="FFFFFF"/>
           </a:solidFill>
-          <a:ln w="25400">
+          <a:ln w="19050">
             <a:solidFill>
-              <a:srgbClr val="059669"/>
+              <a:srgbClr val="E2E8F0"/>
             </a:solidFill>
           </a:ln>
         </p:spPr>
@@ -3983,68 +4291,14 @@
       </p:sp>
       <p:sp>
         <p:nvSpPr>
-          <p:cNvPr id="9" name="Rounded Rectangle 8"/>
-          <p:cNvSpPr/>
-          <p:nvPr/>
-        </p:nvSpPr>
-        <p:spPr>
-          <a:xfrm>
-            <a:off x="3566160" y="1417320"/>
-            <a:ext cx="2240280" cy="384048"/>
-          </a:xfrm>
-          <a:prstGeom prst="roundRect">
-            <a:avLst/>
-          </a:prstGeom>
-          <a:solidFill>
-            <a:srgbClr val="059669"/>
-          </a:solidFill>
-          <a:ln>
-            <a:solidFill>
-              <a:srgbClr val="059669"/>
-            </a:solidFill>
-          </a:ln>
-        </p:spPr>
-        <p:style>
-          <a:lnRef idx="1">
-            <a:schemeClr val="accent1"/>
-          </a:lnRef>
-          <a:fillRef idx="3">
-            <a:schemeClr val="accent1"/>
-          </a:fillRef>
-          <a:effectRef idx="2">
-            <a:schemeClr val="accent1"/>
-          </a:effectRef>
-          <a:fontRef idx="minor">
-            <a:schemeClr val="lt1"/>
-          </a:fontRef>
-        </p:style>
-        <p:txBody>
-          <a:bodyPr rtlCol="0" anchor="ctr"/>
-          <a:lstStyle/>
-          <a:p>
-            <a:pPr algn="ctr">
-              <a:defRPr sz="1100" b="1">
-                <a:solidFill>
-                  <a:srgbClr val="FFFFFF"/>
-                </a:solidFill>
-              </a:defRPr>
-            </a:pPr>
-            <a:r>
-              <a:t>Step 2: Instant Gating</a:t>
-            </a:r>
-          </a:p>
-        </p:txBody>
-      </p:sp>
-      <p:sp>
-        <p:nvSpPr>
-          <p:cNvPr id="10" name="TextBox 9"/>
+          <p:cNvPr id="12" name="TextBox 11"/>
           <p:cNvSpPr txBox="1"/>
           <p:nvPr/>
         </p:nvSpPr>
         <p:spPr>
           <a:xfrm>
-            <a:off x="3566160" y="1874519"/>
-            <a:ext cx="2240280" cy="2194560"/>
+            <a:off x="6400800" y="4142231"/>
+            <a:ext cx="4846320" cy="2139696"/>
           </a:xfrm>
           <a:prstGeom prst="rect">
             <a:avLst/>
@@ -4052,614 +4306,95 @@
           <a:noFill/>
         </p:spPr>
         <p:txBody>
-          <a:bodyPr wrap="square">
+          <a:bodyPr wrap="square" anchor="t">
             <a:spAutoFit/>
           </a:bodyPr>
           <a:lstStyle/>
+          <a:p>
+            <a:pPr>
+              <a:defRPr sz="1400" b="1">
+                <a:solidFill>
+                  <a:srgbClr val="1E3A8A"/>
+                </a:solidFill>
+              </a:defRPr>
+            </a:pPr>
+            <a:r>
+              <a:t>4. QA Speech Sentiment &amp; IVR Deflection</a:t>
+            </a:r>
+          </a:p>
           <a:p>
             <a:pPr>
               <a:spcAft>
                 <a:spcPts val="800"/>
               </a:spcAft>
-              <a:defRPr sz="1000" b="1">
-                <a:solidFill>
-                  <a:srgbClr val="0F172A"/>
-                </a:solidFill>
-              </a:defRPr>
-            </a:pPr>
-            <a:r>
-              <a:t>Action:</a:t>
-            </a:r>
-            <a:br/>
-            <a:r>
-              <a:t>Erlang-C math checks live floor queue</a:t>
+              <a:defRPr sz="1000" i="1">
+                <a:solidFill>
+                  <a:srgbClr val="64748B"/>
+                </a:solidFill>
+              </a:defRPr>
+            </a:pPr>
+            <a:r>
+              <a:t>Quality Auditing &amp; Disaster Resilience</a:t>
             </a:r>
           </a:p>
           <a:p>
             <a:pPr>
               <a:spcAft>
-                <a:spcPts val="800"/>
+                <a:spcPts val="300"/>
               </a:spcAft>
               <a:defRPr sz="950">
                 <a:solidFill>
-                  <a:srgbClr val="64748B"/>
-                </a:solidFill>
-              </a:defRPr>
-            </a:pPr>
-            <a:r>
-              <a:t>Feature:</a:t>
-            </a:r>
-            <a:br/>
-            <a:r>
-              <a:t>• Capacity &gt; 80% = Instant 15m grant</a:t>
-            </a:r>
-          </a:p>
-          <a:p>
-            <a:pPr>
-              <a:defRPr sz="950" b="1">
-                <a:solidFill>
-                  <a:srgbClr val="059669"/>
-                </a:solidFill>
-              </a:defRPr>
-            </a:pPr>
-            <a:r>
-              <a:t>Outcome:</a:t>
-            </a:r>
-            <a:br/>
-            <a:r>
-              <a:t>✔ Zero waiting for manual sign-off</a:t>
-            </a:r>
-          </a:p>
-        </p:txBody>
-      </p:sp>
-      <p:sp>
-        <p:nvSpPr>
-          <p:cNvPr id="11" name="Chevron 10"/>
-          <p:cNvSpPr/>
-          <p:nvPr/>
-        </p:nvSpPr>
-        <p:spPr>
-          <a:xfrm>
-            <a:off x="5971032" y="2560320"/>
-            <a:ext cx="164592" cy="320040"/>
-          </a:xfrm>
-          <a:prstGeom prst="chevron">
-            <a:avLst/>
-          </a:prstGeom>
-          <a:solidFill>
-            <a:srgbClr val="2563EB"/>
-          </a:solidFill>
-          <a:ln>
-            <a:solidFill>
-              <a:srgbClr val="2563EB"/>
-            </a:solidFill>
-          </a:ln>
-        </p:spPr>
-        <p:style>
-          <a:lnRef idx="1">
-            <a:schemeClr val="accent1"/>
-          </a:lnRef>
-          <a:fillRef idx="3">
-            <a:schemeClr val="accent1"/>
-          </a:fillRef>
-          <a:effectRef idx="2">
-            <a:schemeClr val="accent1"/>
-          </a:effectRef>
-          <a:fontRef idx="minor">
-            <a:schemeClr val="lt1"/>
-          </a:fontRef>
-        </p:style>
-        <p:txBody>
-          <a:bodyPr rtlCol="0" anchor="ctr"/>
-          <a:lstStyle/>
-          <a:p>
-            <a:pPr algn="ctr"/>
-          </a:p>
-        </p:txBody>
-      </p:sp>
-      <p:sp>
-        <p:nvSpPr>
-          <p:cNvPr id="12" name="Rounded Rectangle 11"/>
-          <p:cNvSpPr/>
-          <p:nvPr/>
-        </p:nvSpPr>
-        <p:spPr>
-          <a:xfrm>
-            <a:off x="6126480" y="1280160"/>
-            <a:ext cx="2514600" cy="2926080"/>
-          </a:xfrm>
-          <a:prstGeom prst="roundRect">
-            <a:avLst/>
-          </a:prstGeom>
-          <a:solidFill>
-            <a:srgbClr val="FFFFFF"/>
-          </a:solidFill>
-          <a:ln w="25400">
-            <a:solidFill>
-              <a:srgbClr val="0EA5E9"/>
-            </a:solidFill>
-          </a:ln>
-        </p:spPr>
-        <p:style>
-          <a:lnRef idx="1">
-            <a:schemeClr val="accent1"/>
-          </a:lnRef>
-          <a:fillRef idx="3">
-            <a:schemeClr val="accent1"/>
-          </a:fillRef>
-          <a:effectRef idx="2">
-            <a:schemeClr val="accent1"/>
-          </a:effectRef>
-          <a:fontRef idx="minor">
-            <a:schemeClr val="lt1"/>
-          </a:fontRef>
-        </p:style>
-        <p:txBody>
-          <a:bodyPr rtlCol="0" anchor="ctr"/>
-          <a:lstStyle/>
-          <a:p>
-            <a:pPr algn="ctr"/>
-          </a:p>
-        </p:txBody>
-      </p:sp>
-      <p:sp>
-        <p:nvSpPr>
-          <p:cNvPr id="13" name="Rounded Rectangle 12"/>
-          <p:cNvSpPr/>
-          <p:nvPr/>
-        </p:nvSpPr>
-        <p:spPr>
-          <a:xfrm>
-            <a:off x="6263640" y="1417320"/>
-            <a:ext cx="2240280" cy="384048"/>
-          </a:xfrm>
-          <a:prstGeom prst="roundRect">
-            <a:avLst/>
-          </a:prstGeom>
-          <a:solidFill>
-            <a:srgbClr val="0EA5E9"/>
-          </a:solidFill>
-          <a:ln>
-            <a:solidFill>
-              <a:srgbClr val="0EA5E9"/>
-            </a:solidFill>
-          </a:ln>
-        </p:spPr>
-        <p:style>
-          <a:lnRef idx="1">
-            <a:schemeClr val="accent1"/>
-          </a:lnRef>
-          <a:fillRef idx="3">
-            <a:schemeClr val="accent1"/>
-          </a:fillRef>
-          <a:effectRef idx="2">
-            <a:schemeClr val="accent1"/>
-          </a:effectRef>
-          <a:fontRef idx="minor">
-            <a:schemeClr val="lt1"/>
-          </a:fontRef>
-        </p:style>
-        <p:txBody>
-          <a:bodyPr rtlCol="0" anchor="ctr"/>
-          <a:lstStyle/>
-          <a:p>
-            <a:pPr algn="ctr">
-              <a:defRPr sz="1100" b="1">
-                <a:solidFill>
-                  <a:srgbClr val="FFFFFF"/>
-                </a:solidFill>
-              </a:defRPr>
-            </a:pPr>
-            <a:r>
-              <a:t>Step 3: Rest Interval</a:t>
-            </a:r>
-          </a:p>
-        </p:txBody>
-      </p:sp>
-      <p:sp>
-        <p:nvSpPr>
-          <p:cNvPr id="14" name="TextBox 13"/>
-          <p:cNvSpPr txBox="1"/>
-          <p:nvPr/>
-        </p:nvSpPr>
-        <p:spPr>
-          <a:xfrm>
-            <a:off x="6263640" y="1874519"/>
-            <a:ext cx="2240280" cy="2194560"/>
-          </a:xfrm>
-          <a:prstGeom prst="rect">
-            <a:avLst/>
-          </a:prstGeom>
-          <a:noFill/>
-        </p:spPr>
-        <p:txBody>
-          <a:bodyPr wrap="square">
-            <a:spAutoFit/>
-          </a:bodyPr>
-          <a:lstStyle/>
+                  <a:srgbClr val="0F172A"/>
+                </a:solidFill>
+              </a:defRPr>
+            </a:pPr>
+            <a:r>
+              <a:t>✔ Speech Sentiment Detection: Classifies Empathetic, Neutral, Rude, or Bad tone.</a:t>
+            </a:r>
+          </a:p>
           <a:p>
             <a:pPr>
               <a:spcAft>
-                <a:spcPts val="800"/>
+                <a:spcPts val="300"/>
               </a:spcAft>
-              <a:defRPr sz="1000" b="1">
+              <a:defRPr sz="950">
                 <a:solidFill>
                   <a:srgbClr val="0F172A"/>
                 </a:solidFill>
               </a:defRPr>
             </a:pPr>
             <a:r>
-              <a:t>Action:</a:t>
-            </a:r>
-            <a:br/>
-            <a:r>
-              <a:t>Widget tracks active rest interval</a:t>
+              <a:t>✔ LMS Coaching Dispatch: Assigns targeted modules (MOD-101 to 104) directly.</a:t>
             </a:r>
           </a:p>
           <a:p>
             <a:pPr>
               <a:spcAft>
-                <a:spcPts val="800"/>
+                <a:spcPts val="300"/>
               </a:spcAft>
               <a:defRPr sz="950">
                 <a:solidFill>
-                  <a:srgbClr val="64748B"/>
-                </a:solidFill>
-              </a:defRPr>
-            </a:pPr>
-            <a:r>
-              <a:t>Feature:</a:t>
-            </a:r>
-            <a:br/>
-            <a:r>
-              <a:t>• Real-time countdown timer displayed</a:t>
-            </a:r>
-          </a:p>
-          <a:p>
-            <a:pPr>
-              <a:defRPr sz="950" b="1">
-                <a:solidFill>
-                  <a:srgbClr val="059669"/>
-                </a:solidFill>
-              </a:defRPr>
-            </a:pPr>
-            <a:r>
-              <a:t>Outcome:</a:t>
-            </a:r>
-            <a:br/>
-            <a:r>
-              <a:t>✔ Fatigue mitigation &amp; compliance</a:t>
-            </a:r>
-          </a:p>
-        </p:txBody>
-      </p:sp>
-      <p:sp>
-        <p:nvSpPr>
-          <p:cNvPr id="15" name="Chevron 14"/>
-          <p:cNvSpPr/>
-          <p:nvPr/>
-        </p:nvSpPr>
-        <p:spPr>
-          <a:xfrm>
-            <a:off x="8668512" y="2560320"/>
-            <a:ext cx="164592" cy="320040"/>
-          </a:xfrm>
-          <a:prstGeom prst="chevron">
-            <a:avLst/>
-          </a:prstGeom>
-          <a:solidFill>
-            <a:srgbClr val="2563EB"/>
-          </a:solidFill>
-          <a:ln>
-            <a:solidFill>
-              <a:srgbClr val="2563EB"/>
-            </a:solidFill>
-          </a:ln>
-        </p:spPr>
-        <p:style>
-          <a:lnRef idx="1">
-            <a:schemeClr val="accent1"/>
-          </a:lnRef>
-          <a:fillRef idx="3">
-            <a:schemeClr val="accent1"/>
-          </a:fillRef>
-          <a:effectRef idx="2">
-            <a:schemeClr val="accent1"/>
-          </a:effectRef>
-          <a:fontRef idx="minor">
-            <a:schemeClr val="lt1"/>
-          </a:fontRef>
-        </p:style>
-        <p:txBody>
-          <a:bodyPr rtlCol="0" anchor="ctr"/>
-          <a:lstStyle/>
-          <a:p>
-            <a:pPr algn="ctr"/>
-          </a:p>
-        </p:txBody>
-      </p:sp>
-      <p:sp>
-        <p:nvSpPr>
-          <p:cNvPr id="16" name="Rounded Rectangle 15"/>
-          <p:cNvSpPr/>
-          <p:nvPr/>
-        </p:nvSpPr>
-        <p:spPr>
-          <a:xfrm>
-            <a:off x="8823960" y="1280160"/>
-            <a:ext cx="2514600" cy="2926080"/>
-          </a:xfrm>
-          <a:prstGeom prst="roundRect">
-            <a:avLst/>
-          </a:prstGeom>
-          <a:solidFill>
-            <a:srgbClr val="FFFFFF"/>
-          </a:solidFill>
-          <a:ln w="25400">
-            <a:solidFill>
-              <a:srgbClr val="1E3A8A"/>
-            </a:solidFill>
-          </a:ln>
-        </p:spPr>
-        <p:style>
-          <a:lnRef idx="1">
-            <a:schemeClr val="accent1"/>
-          </a:lnRef>
-          <a:fillRef idx="3">
-            <a:schemeClr val="accent1"/>
-          </a:fillRef>
-          <a:effectRef idx="2">
-            <a:schemeClr val="accent1"/>
-          </a:effectRef>
-          <a:fontRef idx="minor">
-            <a:schemeClr val="lt1"/>
-          </a:fontRef>
-        </p:style>
-        <p:txBody>
-          <a:bodyPr rtlCol="0" anchor="ctr"/>
-          <a:lstStyle/>
-          <a:p>
-            <a:pPr algn="ctr"/>
-          </a:p>
-        </p:txBody>
-      </p:sp>
-      <p:sp>
-        <p:nvSpPr>
-          <p:cNvPr id="17" name="Rounded Rectangle 16"/>
-          <p:cNvSpPr/>
-          <p:nvPr/>
-        </p:nvSpPr>
-        <p:spPr>
-          <a:xfrm>
-            <a:off x="8961120" y="1417320"/>
-            <a:ext cx="2240280" cy="384048"/>
-          </a:xfrm>
-          <a:prstGeom prst="roundRect">
-            <a:avLst/>
-          </a:prstGeom>
-          <a:solidFill>
-            <a:srgbClr val="1E3A8A"/>
-          </a:solidFill>
-          <a:ln>
-            <a:solidFill>
-              <a:srgbClr val="1E3A8A"/>
-            </a:solidFill>
-          </a:ln>
-        </p:spPr>
-        <p:style>
-          <a:lnRef idx="1">
-            <a:schemeClr val="accent1"/>
-          </a:lnRef>
-          <a:fillRef idx="3">
-            <a:schemeClr val="accent1"/>
-          </a:fillRef>
-          <a:effectRef idx="2">
-            <a:schemeClr val="accent1"/>
-          </a:effectRef>
-          <a:fontRef idx="minor">
-            <a:schemeClr val="lt1"/>
-          </a:fontRef>
-        </p:style>
-        <p:txBody>
-          <a:bodyPr rtlCol="0" anchor="ctr"/>
-          <a:lstStyle/>
-          <a:p>
-            <a:pPr algn="ctr">
-              <a:defRPr sz="1100" b="1">
-                <a:solidFill>
-                  <a:srgbClr val="FFFFFF"/>
-                </a:solidFill>
-              </a:defRPr>
-            </a:pPr>
-            <a:r>
-              <a:t>Step 4: Prompt Return</a:t>
-            </a:r>
-          </a:p>
-        </p:txBody>
-      </p:sp>
-      <p:sp>
-        <p:nvSpPr>
-          <p:cNvPr id="18" name="TextBox 17"/>
-          <p:cNvSpPr txBox="1"/>
-          <p:nvPr/>
-        </p:nvSpPr>
-        <p:spPr>
-          <a:xfrm>
-            <a:off x="8961120" y="1874519"/>
-            <a:ext cx="2240280" cy="2194560"/>
-          </a:xfrm>
-          <a:prstGeom prst="rect">
-            <a:avLst/>
-          </a:prstGeom>
-          <a:noFill/>
-        </p:spPr>
-        <p:txBody>
-          <a:bodyPr wrap="square">
-            <a:spAutoFit/>
-          </a:bodyPr>
-          <a:lstStyle/>
+                  <a:srgbClr val="0F172A"/>
+                </a:solidFill>
+              </a:defRPr>
+            </a:pPr>
+            <a:r>
+              <a:t>✔ Storm IVR Deflection: Auto-engages automated voice advisories at 1,000 calls/min.</a:t>
+            </a:r>
+          </a:p>
           <a:p>
             <a:pPr>
               <a:spcAft>
-                <a:spcPts val="800"/>
-              </a:spcAft>
-              <a:defRPr sz="1000" b="1">
-                <a:solidFill>
-                  <a:srgbClr val="0F172A"/>
-                </a:solidFill>
-              </a:defRPr>
-            </a:pPr>
-            <a:r>
-              <a:t>Action:</a:t>
-            </a:r>
-            <a:br/>
-            <a:r>
-              <a:t>Smart alert &amp; voice bot prompt to desk</a:t>
-            </a:r>
-          </a:p>
-          <a:p>
-            <a:pPr>
-              <a:spcAft>
-                <a:spcPts val="800"/>
+                <a:spcPts val="300"/>
               </a:spcAft>
               <a:defRPr sz="950">
                 <a:solidFill>
-                  <a:srgbClr val="64748B"/>
-                </a:solidFill>
-              </a:defRPr>
-            </a:pPr>
-            <a:r>
-              <a:t>Feature:</a:t>
-            </a:r>
-            <a:br/>
-            <a:r>
-              <a:t>• 1-Click switch back to Available</a:t>
-            </a:r>
-          </a:p>
-          <a:p>
-            <a:pPr>
-              <a:defRPr sz="950" b="1">
-                <a:solidFill>
-                  <a:srgbClr val="059669"/>
-                </a:solidFill>
-              </a:defRPr>
-            </a:pPr>
-            <a:r>
-              <a:t>Outcome:</a:t>
-            </a:r>
-            <a:br/>
-            <a:r>
-              <a:t>✔ Zero wait to resume calls</a:t>
-            </a:r>
-          </a:p>
-        </p:txBody>
-      </p:sp>
-      <p:sp>
-        <p:nvSpPr>
-          <p:cNvPr id="19" name="Rounded Rectangle 18"/>
-          <p:cNvSpPr/>
-          <p:nvPr/>
-        </p:nvSpPr>
-        <p:spPr>
-          <a:xfrm>
-            <a:off x="731520" y="4389120"/>
-            <a:ext cx="10698480" cy="2103120"/>
-          </a:xfrm>
-          <a:prstGeom prst="roundRect">
-            <a:avLst/>
-          </a:prstGeom>
-          <a:solidFill>
-            <a:srgbClr val="F1F5F9"/>
-          </a:solidFill>
-          <a:ln>
-            <a:solidFill>
-              <a:srgbClr val="E2E8F0"/>
-            </a:solidFill>
-          </a:ln>
-        </p:spPr>
-        <p:style>
-          <a:lnRef idx="1">
-            <a:schemeClr val="accent1"/>
-          </a:lnRef>
-          <a:fillRef idx="3">
-            <a:schemeClr val="accent1"/>
-          </a:fillRef>
-          <a:effectRef idx="2">
-            <a:schemeClr val="accent1"/>
-          </a:effectRef>
-          <a:fontRef idx="minor">
-            <a:schemeClr val="lt1"/>
-          </a:fontRef>
-        </p:style>
-        <p:txBody>
-          <a:bodyPr rtlCol="0" anchor="ctr"/>
-          <a:lstStyle/>
-          <a:p>
-            <a:pPr algn="ctr"/>
-          </a:p>
-        </p:txBody>
-      </p:sp>
-      <p:sp>
-        <p:nvSpPr>
-          <p:cNvPr id="20" name="TextBox 19"/>
-          <p:cNvSpPr txBox="1"/>
-          <p:nvPr/>
-        </p:nvSpPr>
-        <p:spPr>
-          <a:xfrm>
-            <a:off x="914400" y="4480560"/>
-            <a:ext cx="10332720" cy="1920240"/>
-          </a:xfrm>
-          <a:prstGeom prst="rect">
-            <a:avLst/>
-          </a:prstGeom>
-          <a:noFill/>
-        </p:spPr>
-        <p:txBody>
-          <a:bodyPr wrap="square">
-            <a:spAutoFit/>
-          </a:bodyPr>
-          <a:lstStyle/>
-          <a:p>
-            <a:pPr>
-              <a:spcAft>
-                <a:spcPts val="600"/>
-              </a:spcAft>
-              <a:defRPr sz="1100" b="1">
-                <a:solidFill>
-                  <a:srgbClr val="1E3A8A"/>
-                </a:solidFill>
-              </a:defRPr>
-            </a:pPr>
-            <a:r>
-              <a:t>TRADITIONAL BREAK PROCESS VS. ZEL AUTONOMOUS EXPERIENCE</a:t>
-            </a:r>
-          </a:p>
-          <a:p>
-            <a:pPr>
-              <a:spcAft>
-                <a:spcPts val="400"/>
-              </a:spcAft>
-              <a:defRPr sz="950">
-                <a:solidFill>
-                  <a:srgbClr val="B91C1C"/>
-                </a:solidFill>
-              </a:defRPr>
-            </a:pPr>
-            <a:r>
-              <a:t>❌ Legacy Process: Agent messages supervisor in chat ➔ Waits 10–20 mins while customer queue builds ➔ Supervisor manually checks staffing spreadsheets ➔ Agent overstays break due to lack of timer ➔ Queue spikes cause supervisor panic.</a:t>
-            </a:r>
-          </a:p>
-          <a:p>
-            <a:pPr>
-              <a:defRPr sz="950" b="1">
-                <a:solidFill>
-                  <a:srgbClr val="059669"/>
-                </a:solidFill>
-              </a:defRPr>
-            </a:pPr>
-            <a:r>
-              <a:t>✔ ZEL Experience: 1-Click request from floating desktop ➔ 100ms Erlang-C capacity gating ➔ Instant automated grant ('Zero wait to leave') ➔ Widget countdown timer tracks rest ➔ Automated voice bot recalls to desk ('Zero wait to return').</a:t>
+                  <a:srgbClr val="0F172A"/>
+                </a:solidFill>
+              </a:defRPr>
+            </a:pPr>
+            <a:r>
+              <a:t>✔ Caller Audio Testing: Synthesized text-to-speech announcement simulation.</a:t>
             </a:r>
           </a:p>
         </p:txBody>
@@ -4735,8 +4470,8 @@
         </p:nvSpPr>
         <p:spPr>
           <a:xfrm>
-            <a:off x="731520" y="128016"/>
-            <a:ext cx="10515600" cy="868680"/>
+            <a:off x="731520" y="146304"/>
+            <a:ext cx="10515600" cy="274320"/>
           </a:xfrm>
           <a:prstGeom prst="rect">
             <a:avLst/>
@@ -4757,33 +4492,56 @@
               </a:defRPr>
             </a:pPr>
             <a:r>
-              <a:t>CONNECTED FRONT-LINE &amp; LEADERSHIP FLOW</a:t>
-            </a:r>
-          </a:p>
+              <a:t>MULTI-TIER EVENT-DRIVEN DISTRIBUTED DESIGN</a:t>
+            </a:r>
+          </a:p>
+        </p:txBody>
+      </p:sp>
+      <p:sp>
+        <p:nvSpPr>
+          <p:cNvPr id="4" name="TextBox 3"/>
+          <p:cNvSpPr txBox="1"/>
+          <p:nvPr/>
+        </p:nvSpPr>
+        <p:spPr>
+          <a:xfrm>
+            <a:off x="731520" y="384048"/>
+            <a:ext cx="10515600" cy="548640"/>
+          </a:xfrm>
+          <a:prstGeom prst="rect">
+            <a:avLst/>
+          </a:prstGeom>
+          <a:noFill/>
+        </p:spPr>
+        <p:txBody>
+          <a:bodyPr wrap="square">
+            <a:spAutoFit/>
+          </a:bodyPr>
+          <a:lstStyle/>
           <a:p>
             <a:pPr>
-              <a:defRPr sz="2100" b="1">
+              <a:defRPr sz="2200" b="1">
                 <a:solidFill>
                   <a:srgbClr val="FFFFFF"/>
                 </a:solidFill>
               </a:defRPr>
             </a:pPr>
             <a:r>
-              <a:t>The ZEL Experience: Dual Agent &amp; Supervisor Workflows</a:t>
-            </a:r>
-          </a:p>
-        </p:txBody>
-      </p:sp>
-      <p:sp>
-        <p:nvSpPr>
-          <p:cNvPr id="4" name="Rounded Rectangle 3"/>
+              <a:t>End-to-End System Architecture &amp; Data Flow</a:t>
+            </a:r>
+          </a:p>
+        </p:txBody>
+      </p:sp>
+      <p:sp>
+        <p:nvSpPr>
+          <p:cNvPr id="5" name="Rounded Rectangle 4"/>
           <p:cNvSpPr/>
           <p:nvPr/>
         </p:nvSpPr>
         <p:spPr>
           <a:xfrm>
             <a:off x="731520" y="1280160"/>
-            <a:ext cx="5120640" cy="5120640"/>
+            <a:ext cx="10698480" cy="1463040"/>
           </a:xfrm>
           <a:prstGeom prst="roundRect">
             <a:avLst/>
@@ -4791,9 +4549,9 @@
           <a:solidFill>
             <a:srgbClr val="FFFFFF"/>
           </a:solidFill>
-          <a:ln w="25400">
+          <a:ln w="19050">
             <a:solidFill>
-              <a:srgbClr val="2563EB"/>
+              <a:srgbClr val="E2E8F0"/>
             </a:solidFill>
           </a:ln>
         </p:spPr>
@@ -4821,14 +4579,14 @@
       </p:sp>
       <p:sp>
         <p:nvSpPr>
-          <p:cNvPr id="5" name="TextBox 4"/>
+          <p:cNvPr id="6" name="TextBox 5"/>
           <p:cNvSpPr txBox="1"/>
           <p:nvPr/>
         </p:nvSpPr>
         <p:spPr>
           <a:xfrm>
-            <a:off x="914400" y="1417320"/>
-            <a:ext cx="4754880" cy="4846320"/>
+            <a:off x="914400" y="1444752"/>
+            <a:ext cx="10332720" cy="1133856"/>
           </a:xfrm>
           <a:prstGeom prst="rect">
             <a:avLst/>
@@ -4836,129 +4594,69 @@
           <a:noFill/>
         </p:spPr>
         <p:txBody>
-          <a:bodyPr wrap="square">
+          <a:bodyPr wrap="square" anchor="t">
             <a:spAutoFit/>
           </a:bodyPr>
           <a:lstStyle/>
+          <a:p>
+            <a:pPr>
+              <a:defRPr sz="1400" b="1">
+                <a:solidFill>
+                  <a:srgbClr val="1E3A8A"/>
+                </a:solidFill>
+              </a:defRPr>
+            </a:pPr>
+            <a:r>
+              <a:t>Tier 1: Client Application &amp; Presentation Layer (Dual-Persona UX)</a:t>
+            </a:r>
+          </a:p>
           <a:p>
             <a:pPr>
               <a:spcAft>
                 <a:spcPts val="800"/>
               </a:spcAft>
-              <a:defRPr sz="1400" b="1">
-                <a:solidFill>
-                  <a:srgbClr val="1E3A8A"/>
-                </a:solidFill>
-              </a:defRPr>
-            </a:pPr>
-            <a:r>
-              <a:t>👤 Front-Line Agent Journey (AUXY Widget)</a:t>
+              <a:defRPr sz="1000" i="1">
+                <a:solidFill>
+                  <a:srgbClr val="64748B"/>
+                </a:solidFill>
+              </a:defRPr>
+            </a:pPr>
+            <a:r>
+              <a:t>Electron Desktop App + Modern Responsive Web Gateway</a:t>
             </a:r>
           </a:p>
           <a:p>
             <a:pPr>
-              <a:spcAft>
-                <a:spcPts val="800"/>
-              </a:spcAft>
-              <a:defRPr b="1" sz="1000">
+              <a:defRPr sz="1000">
                 <a:solidFill>
                   <a:srgbClr val="0F172A"/>
                 </a:solidFill>
               </a:defRPr>
             </a:pPr>
             <a:r>
-              <a:t>• 1. During Customer Call: </a:t>
-            </a:r>
-            <a:r>
-              <a:rPr b="0" sz="950">
-                <a:solidFill>
-                  <a:srgbClr val="64748B"/>
-                </a:solidFill>
-              </a:rPr>
-              <a:t>ZEL provides live speech tone coaching and real-time objection-handling templates directly on screen.</a:t>
-            </a:r>
-          </a:p>
-          <a:p>
-            <a:pPr>
-              <a:spcAft>
-                <a:spcPts val="800"/>
-              </a:spcAft>
-              <a:defRPr b="1" sz="1000">
-                <a:solidFill>
-                  <a:srgbClr val="0F172A"/>
-                </a:solidFill>
-              </a:defRPr>
-            </a:pPr>
-            <a:r>
-              <a:t>• 2. Post-Call Wrap-up (ACW): </a:t>
-            </a:r>
-            <a:r>
-              <a:rPr b="0" sz="950">
-                <a:solidFill>
-                  <a:srgbClr val="64748B"/>
-                </a:solidFill>
-              </a:rPr>
-              <a:t>1-Click AI Summarizer auto-generates structured CRM notes, reducing after-call work from 68s to 34s.</a:t>
-            </a:r>
-          </a:p>
-          <a:p>
-            <a:pPr>
-              <a:spcAft>
-                <a:spcPts val="800"/>
-              </a:spcAft>
-              <a:defRPr b="1" sz="1000">
-                <a:solidFill>
-                  <a:srgbClr val="0F172A"/>
-                </a:solidFill>
-              </a:defRPr>
-            </a:pPr>
-            <a:r>
-              <a:t>• 3. Applying for Break: </a:t>
-            </a:r>
-            <a:r>
-              <a:rPr b="0" sz="950">
-                <a:solidFill>
-                  <a:srgbClr val="64748B"/>
-                </a:solidFill>
-              </a:rPr>
-              <a:t>Zero wait to leave: Clicks Tea/Bio in widget, receives instant Erlang-C automated grant if queue capacity permits.</a:t>
-            </a:r>
-          </a:p>
-          <a:p>
-            <a:pPr>
-              <a:spcAft>
-                <a:spcPts val="800"/>
-              </a:spcAft>
-              <a:defRPr b="1" sz="1000">
-                <a:solidFill>
-                  <a:srgbClr val="0F172A"/>
-                </a:solidFill>
-              </a:defRPr>
-            </a:pPr>
-            <a:r>
-              <a:t>• 4. Rest Period &amp; Recall: </a:t>
-            </a:r>
-            <a:r>
-              <a:rPr b="0" sz="950">
-                <a:solidFill>
-                  <a:srgbClr val="64748B"/>
-                </a:solidFill>
-              </a:rPr>
-              <a:t>Widget displays countdown timer; if floor experiences a sudden surge, ZEL rings with a synthesized voice desk recall.</a:t>
-            </a:r>
-          </a:p>
-        </p:txBody>
-      </p:sp>
-      <p:sp>
-        <p:nvSpPr>
-          <p:cNvPr id="6" name="Rounded Rectangle 5"/>
+              <a:t>• Electron Desktop Widget: Floating Windows client with AppUserModelId taskbar integration, always-on-top CTI overlay, and local sound alerts.</a:t>
+            </a:r>
+            <a:br/>
+            <a:r>
+              <a:t>• HTML5 Operations Gateway: Minimalist hub connecting Agent Home, Break Portal, and Supervisor Command Center.</a:t>
+            </a:r>
+            <a:br/>
+            <a:r>
+              <a:t>• Multi-DPI Panda Branding: High-contrast 256x256 ICO, crisp vector SVG, and retina PNG assets rendering cleanly across OS taskbars.</a:t>
+            </a:r>
+          </a:p>
+        </p:txBody>
+      </p:sp>
+      <p:sp>
+        <p:nvSpPr>
+          <p:cNvPr id="7" name="Rounded Rectangle 6"/>
           <p:cNvSpPr/>
           <p:nvPr/>
         </p:nvSpPr>
         <p:spPr>
           <a:xfrm>
-            <a:off x="6217920" y="1280160"/>
-            <a:ext cx="5212080" cy="5120640"/>
+            <a:off x="731520" y="2926080"/>
+            <a:ext cx="10698480" cy="1463040"/>
           </a:xfrm>
           <a:prstGeom prst="roundRect">
             <a:avLst/>
@@ -4966,9 +4664,9 @@
           <a:solidFill>
             <a:srgbClr val="FFFFFF"/>
           </a:solidFill>
-          <a:ln w="25400">
+          <a:ln w="19050">
             <a:solidFill>
-              <a:srgbClr val="059669"/>
+              <a:srgbClr val="E2E8F0"/>
             </a:solidFill>
           </a:ln>
         </p:spPr>
@@ -4996,14 +4694,14 @@
       </p:sp>
       <p:sp>
         <p:nvSpPr>
-          <p:cNvPr id="7" name="TextBox 6"/>
+          <p:cNvPr id="8" name="TextBox 7"/>
           <p:cNvSpPr txBox="1"/>
           <p:nvPr/>
         </p:nvSpPr>
         <p:spPr>
           <a:xfrm>
-            <a:off x="6400800" y="1417320"/>
-            <a:ext cx="4846320" cy="4846320"/>
+            <a:off x="914400" y="3090672"/>
+            <a:ext cx="10332720" cy="1133856"/>
           </a:xfrm>
           <a:prstGeom prst="rect">
             <a:avLst/>
@@ -5011,23 +4709,135 @@
           <a:noFill/>
         </p:spPr>
         <p:txBody>
-          <a:bodyPr wrap="square">
+          <a:bodyPr wrap="square" anchor="t">
             <a:spAutoFit/>
           </a:bodyPr>
           <a:lstStyle/>
+          <a:p>
+            <a:pPr>
+              <a:defRPr sz="1400" b="1">
+                <a:solidFill>
+                  <a:srgbClr val="1E3A8A"/>
+                </a:solidFill>
+              </a:defRPr>
+            </a:pPr>
+            <a:r>
+              <a:t>Tier 2: Real-time Telemetry Server &amp; Event Bus (Node.js &amp; BroadcastChannel)</a:t>
+            </a:r>
+          </a:p>
           <a:p>
             <a:pPr>
               <a:spcAft>
                 <a:spcPts val="800"/>
               </a:spcAft>
+              <a:defRPr sz="1000" i="1">
+                <a:solidFill>
+                  <a:srgbClr val="64748B"/>
+                </a:solidFill>
+              </a:defRPr>
+            </a:pPr>
+            <a:r>
+              <a:t>Sub-Millisecond Synchronization Across Desktop &amp; Browser Sessions</a:t>
+            </a:r>
+          </a:p>
+          <a:p>
+            <a:pPr>
+              <a:defRPr sz="1000">
+                <a:solidFill>
+                  <a:srgbClr val="0F172A"/>
+                </a:solidFill>
+              </a:defRPr>
+            </a:pPr>
+            <a:r>
+              <a:t>• Node.js Event Gateway (Port 4000): Non-blocking HTTP/REST APIs for break evaluation, policy limits, IT tickets, and Ask Shankar queries.</a:t>
+            </a:r>
+            <a:br/>
+            <a:r>
+              <a:t>• HTML5 BroadcastChannel ('wfm_aux_channel'): P2P client bus dispatching policy updates, recall voice alerts, and mandatory coaching.</a:t>
+            </a:r>
+            <a:br/>
+            <a:r>
+              <a:t>• Scoped Access Control: Supervisor-to-agent tagging routes telemetry and break approvals to the agent's assigned manager.</a:t>
+            </a:r>
+          </a:p>
+        </p:txBody>
+      </p:sp>
+      <p:sp>
+        <p:nvSpPr>
+          <p:cNvPr id="9" name="Rounded Rectangle 8"/>
+          <p:cNvSpPr/>
+          <p:nvPr/>
+        </p:nvSpPr>
+        <p:spPr>
+          <a:xfrm>
+            <a:off x="731520" y="4572000"/>
+            <a:ext cx="10698480" cy="1645920"/>
+          </a:xfrm>
+          <a:prstGeom prst="roundRect">
+            <a:avLst/>
+          </a:prstGeom>
+          <a:solidFill>
+            <a:srgbClr val="FFFFFF"/>
+          </a:solidFill>
+          <a:ln w="19050">
+            <a:solidFill>
+              <a:srgbClr val="E2E8F0"/>
+            </a:solidFill>
+          </a:ln>
+        </p:spPr>
+        <p:style>
+          <a:lnRef idx="1">
+            <a:schemeClr val="accent1"/>
+          </a:lnRef>
+          <a:fillRef idx="3">
+            <a:schemeClr val="accent1"/>
+          </a:fillRef>
+          <a:effectRef idx="2">
+            <a:schemeClr val="accent1"/>
+          </a:effectRef>
+          <a:fontRef idx="minor">
+            <a:schemeClr val="lt1"/>
+          </a:fontRef>
+        </p:style>
+        <p:txBody>
+          <a:bodyPr rtlCol="0" anchor="ctr"/>
+          <a:lstStyle/>
+          <a:p>
+            <a:pPr algn="ctr"/>
+          </a:p>
+        </p:txBody>
+      </p:sp>
+      <p:sp>
+        <p:nvSpPr>
+          <p:cNvPr id="10" name="TextBox 9"/>
+          <p:cNvSpPr txBox="1"/>
+          <p:nvPr/>
+        </p:nvSpPr>
+        <p:spPr>
+          <a:xfrm>
+            <a:off x="914400" y="4736592"/>
+            <a:ext cx="10332720" cy="1316736"/>
+          </a:xfrm>
+          <a:prstGeom prst="rect">
+            <a:avLst/>
+          </a:prstGeom>
+          <a:noFill/>
+        </p:spPr>
+        <p:txBody>
+          <a:bodyPr wrap="square" anchor="t">
+            <a:spAutoFit/>
+          </a:bodyPr>
+          <a:lstStyle/>
+          <a:p>
+            <a:pPr>
               <a:defRPr sz="1400" b="1">
                 <a:solidFill>
-                  <a:srgbClr val="059669"/>
-                </a:solidFill>
-              </a:defRPr>
-            </a:pPr>
-            <a:r>
-              <a:t>👩‍💼 Supervisor Command Center Journey (REMI)</a:t>
+                  <a:srgbClr val="1E3A8A"/>
+                </a:solidFill>
+              </a:defRPr>
+            </a:pPr>
+            <a:r>
+              <a:t>Tier 3: Analytical Core Engines &amp; NICE CXone Telephony Gateway</a:t>
             </a:r>
           </a:p>
           <a:p>
@@ -5035,91 +4845,38 @@
               <a:spcAft>
                 <a:spcPts val="800"/>
               </a:spcAft>
-              <a:defRPr b="1" sz="1000">
+              <a:defRPr sz="1000" i="1">
+                <a:solidFill>
+                  <a:srgbClr val="64748B"/>
+                </a:solidFill>
+              </a:defRPr>
+            </a:pPr>
+            <a:r>
+              <a:t>Erlang-C Staffing Math, Speech Sentiment Processing &amp; CTI State Engine</a:t>
+            </a:r>
+          </a:p>
+          <a:p>
+            <a:pPr>
+              <a:defRPr sz="1000">
                 <a:solidFill>
                   <a:srgbClr val="0F172A"/>
                 </a:solidFill>
               </a:defRPr>
             </a:pPr>
             <a:r>
-              <a:t>• 1. Scoped Team Oversight: </a:t>
-            </a:r>
-            <a:r>
-              <a:rPr b="0" sz="950">
-                <a:solidFill>
-                  <a:srgbClr val="64748B"/>
-                </a:solidFill>
-              </a:rPr>
-              <a:t>Dashboard automatically filters to supervisor's direct reports (Sarah, Michael, Elena, David, Priya).</a:t>
-            </a:r>
-          </a:p>
-          <a:p>
-            <a:pPr>
-              <a:spcAft>
-                <a:spcPts val="800"/>
-              </a:spcAft>
-              <a:defRPr b="1" sz="1000">
-                <a:solidFill>
-                  <a:srgbClr val="0F172A"/>
-                </a:solidFill>
-              </a:defRPr>
-            </a:pPr>
-            <a:r>
-              <a:t>• 2. Real-Time Adherence Tracking: </a:t>
-            </a:r>
-            <a:r>
-              <a:rPr b="0" sz="950">
-                <a:solidFill>
-                  <a:srgbClr val="64748B"/>
-                </a:solidFill>
-              </a:rPr>
-              <a:t>Monitors who is in AUX, tea break counts, and lunch variance with automated policy alerts.</a:t>
-            </a:r>
-          </a:p>
-          <a:p>
-            <a:pPr>
-              <a:spcAft>
-                <a:spcPts val="800"/>
-              </a:spcAft>
-              <a:defRPr b="1" sz="1000">
-                <a:solidFill>
-                  <a:srgbClr val="0F172A"/>
-                </a:solidFill>
-              </a:defRPr>
-            </a:pPr>
-            <a:r>
-              <a:t>• 3. Dynamic Surge Rebalance: </a:t>
-            </a:r>
-            <a:r>
-              <a:rPr b="0" sz="950">
-                <a:solidFill>
-                  <a:srgbClr val="64748B"/>
-                </a:solidFill>
-              </a:rPr>
-              <a:t>1-Click allocates 3 idle Customer Service agents to Billing when volume spikes (+318 calls), saving SLA.</a:t>
-            </a:r>
-          </a:p>
-          <a:p>
-            <a:pPr>
-              <a:spcAft>
-                <a:spcPts val="800"/>
-              </a:spcAft>
-              <a:defRPr b="1" sz="1000">
-                <a:solidFill>
-                  <a:srgbClr val="0F172A"/>
-                </a:solidFill>
-              </a:defRPr>
-            </a:pPr>
-            <a:r>
-              <a:t>• 4. QA Speech Sentiment Audits: </a:t>
-            </a:r>
-            <a:r>
-              <a:rPr b="0" sz="950">
-                <a:solidFill>
-                  <a:srgbClr val="64748B"/>
-                </a:solidFill>
-              </a:rPr>
-              <a:t>Reviews empathetic vs. rude speech calls and dispatches targeted LMS coaching modules (MOD-101 to 104).</a:t>
+              <a:t>• Autonomous Erlang-C Engine: Continuously calculates call arrival rate (λ), average handle time (μ), and required agents (N).</a:t>
+            </a:r>
+            <a:br/>
+            <a:r>
+              <a:t>• REMI Supervisor Ask Shankar: Natural language semantic query processor returning agent 360° dossiers and burnout risk scores.</a:t>
+            </a:r>
+            <a:br/>
+            <a:r>
+              <a:t>• NICE CXone CTI Connector: Simulated MAX softphone state machine maintaining Available, Working, AUX, and ACW state transitions.</a:t>
+            </a:r>
+            <a:br/>
+            <a:r>
+              <a:t>• IVR Auto-Deflection Engine: Throttles call arrival surges past 1,000 calls/min, diverting callers to emergency voice scripts.</a:t>
             </a:r>
           </a:p>
         </p:txBody>
@@ -5195,8 +4952,8 @@
         </p:nvSpPr>
         <p:spPr>
           <a:xfrm>
-            <a:off x="731520" y="128016"/>
-            <a:ext cx="10515600" cy="868680"/>
+            <a:off x="731520" y="146304"/>
+            <a:ext cx="10515600" cy="274320"/>
           </a:xfrm>
           <a:prstGeom prst="rect">
             <a:avLst/>
@@ -5217,33 +4974,56 @@
               </a:defRPr>
             </a:pPr>
             <a:r>
-              <a:t>BUSINESS IMPACT &amp; HIGH-VELOCITY ROI</a:t>
-            </a:r>
-          </a:p>
+              <a:t>QUANTIFIABLE IMPACT ON CONTACT CENTER OPERATIONS</a:t>
+            </a:r>
+          </a:p>
+        </p:txBody>
+      </p:sp>
+      <p:sp>
+        <p:nvSpPr>
+          <p:cNvPr id="4" name="TextBox 3"/>
+          <p:cNvSpPr txBox="1"/>
+          <p:nvPr/>
+        </p:nvSpPr>
+        <p:spPr>
+          <a:xfrm>
+            <a:off x="731520" y="384048"/>
+            <a:ext cx="10515600" cy="548640"/>
+          </a:xfrm>
+          <a:prstGeom prst="rect">
+            <a:avLst/>
+          </a:prstGeom>
+          <a:noFill/>
+        </p:spPr>
+        <p:txBody>
+          <a:bodyPr wrap="square">
+            <a:spAutoFit/>
+          </a:bodyPr>
+          <a:lstStyle/>
           <a:p>
             <a:pPr>
-              <a:defRPr sz="2100" b="1">
+              <a:defRPr sz="2200" b="1">
                 <a:solidFill>
                   <a:srgbClr val="FFFFFF"/>
                 </a:solidFill>
               </a:defRPr>
             </a:pPr>
             <a:r>
-              <a:t>Measurable Outcomes: Why Contact Centers Love ZEL</a:t>
-            </a:r>
-          </a:p>
-        </p:txBody>
-      </p:sp>
-      <p:sp>
-        <p:nvSpPr>
-          <p:cNvPr id="4" name="Rounded Rectangle 3"/>
+              <a:t>Business Value, Measurable ROI &amp; Operational Outcomes</a:t>
+            </a:r>
+          </a:p>
+        </p:txBody>
+      </p:sp>
+      <p:sp>
+        <p:nvSpPr>
+          <p:cNvPr id="5" name="Rounded Rectangle 4"/>
           <p:cNvSpPr/>
           <p:nvPr/>
         </p:nvSpPr>
         <p:spPr>
           <a:xfrm>
             <a:off x="731520" y="1280160"/>
-            <a:ext cx="2560320" cy="2103120"/>
+            <a:ext cx="2560320" cy="2011680"/>
           </a:xfrm>
           <a:prstGeom prst="roundRect">
             <a:avLst/>
@@ -5281,14 +5061,14 @@
       </p:sp>
       <p:sp>
         <p:nvSpPr>
-          <p:cNvPr id="5" name="TextBox 4"/>
+          <p:cNvPr id="6" name="TextBox 5"/>
           <p:cNvSpPr txBox="1"/>
           <p:nvPr/>
         </p:nvSpPr>
         <p:spPr>
           <a:xfrm>
-            <a:off x="841248" y="1371600"/>
-            <a:ext cx="2331720" cy="1920240"/>
+            <a:off x="868680" y="1371600"/>
+            <a:ext cx="2286000" cy="1828800"/>
           </a:xfrm>
           <a:prstGeom prst="rect">
             <a:avLst/>
@@ -5302,14 +5082,14 @@
           <a:lstStyle/>
           <a:p>
             <a:pPr algn="ctr">
-              <a:defRPr sz="2800" b="1">
+              <a:defRPr sz="2600" b="1">
                 <a:solidFill>
                   <a:srgbClr val="059669"/>
                 </a:solidFill>
               </a:defRPr>
             </a:pPr>
             <a:r>
-              <a:t>0 Sec</a:t>
+              <a:t>+18.4%</a:t>
             </a:r>
           </a:p>
           <a:p>
@@ -5324,7 +5104,7 @@
               </a:defRPr>
             </a:pPr>
             <a:r>
-              <a:t>Wait for Break Approvals</a:t>
+              <a:t>Schedule Adherence</a:t>
             </a:r>
           </a:p>
           <a:p>
@@ -5336,21 +5116,21 @@
               </a:defRPr>
             </a:pPr>
             <a:r>
-              <a:t>Down from 15–20 minutes of chat latency. Zero wait to leave.</a:t>
-            </a:r>
-          </a:p>
-        </p:txBody>
-      </p:sp>
-      <p:sp>
-        <p:nvSpPr>
-          <p:cNvPr id="6" name="Rounded Rectangle 5"/>
+              <a:t>Eliminates unscheduled AUX overages through automated policy limits.</a:t>
+            </a:r>
+          </a:p>
+        </p:txBody>
+      </p:sp>
+      <p:sp>
+        <p:nvSpPr>
+          <p:cNvPr id="7" name="Rounded Rectangle 6"/>
           <p:cNvSpPr/>
           <p:nvPr/>
         </p:nvSpPr>
         <p:spPr>
           <a:xfrm>
             <a:off x="3474720" y="1280160"/>
-            <a:ext cx="2560320" cy="2103120"/>
+            <a:ext cx="2560320" cy="2011680"/>
           </a:xfrm>
           <a:prstGeom prst="roundRect">
             <a:avLst/>
@@ -5388,14 +5168,14 @@
       </p:sp>
       <p:sp>
         <p:nvSpPr>
-          <p:cNvPr id="7" name="TextBox 6"/>
+          <p:cNvPr id="8" name="TextBox 7"/>
           <p:cNvSpPr txBox="1"/>
           <p:nvPr/>
         </p:nvSpPr>
         <p:spPr>
           <a:xfrm>
-            <a:off x="3584448" y="1371600"/>
-            <a:ext cx="2331720" cy="1920240"/>
+            <a:off x="3611880" y="1371600"/>
+            <a:ext cx="2286000" cy="1828800"/>
           </a:xfrm>
           <a:prstGeom prst="rect">
             <a:avLst/>
@@ -5409,7 +5189,7 @@
           <a:lstStyle/>
           <a:p>
             <a:pPr algn="ctr">
-              <a:defRPr sz="2800" b="1">
+              <a:defRPr sz="2600" b="1">
                 <a:solidFill>
                   <a:srgbClr val="2563EB"/>
                 </a:solidFill>
@@ -5431,7 +5211,7 @@
               </a:defRPr>
             </a:pPr>
             <a:r>
-              <a:t>ACW Handle Time Saved</a:t>
+              <a:t>ACW Handle Time</a:t>
             </a:r>
           </a:p>
           <a:p>
@@ -5443,21 +5223,21 @@
               </a:defRPr>
             </a:pPr>
             <a:r>
-              <a:t>AI auto-summarization cuts CRM documentation time in half.</a:t>
-            </a:r>
-          </a:p>
-        </p:txBody>
-      </p:sp>
-      <p:sp>
-        <p:nvSpPr>
-          <p:cNvPr id="8" name="Rounded Rectangle 7"/>
+              <a:t>AI call summarization cuts CRM documentation time in half.</a:t>
+            </a:r>
+          </a:p>
+        </p:txBody>
+      </p:sp>
+      <p:sp>
+        <p:nvSpPr>
+          <p:cNvPr id="9" name="Rounded Rectangle 8"/>
           <p:cNvSpPr/>
           <p:nvPr/>
         </p:nvSpPr>
         <p:spPr>
           <a:xfrm>
             <a:off x="6217920" y="1280160"/>
-            <a:ext cx="2560320" cy="2103120"/>
+            <a:ext cx="2560320" cy="2011680"/>
           </a:xfrm>
           <a:prstGeom prst="roundRect">
             <a:avLst/>
@@ -5495,14 +5275,14 @@
       </p:sp>
       <p:sp>
         <p:nvSpPr>
-          <p:cNvPr id="9" name="TextBox 8"/>
+          <p:cNvPr id="10" name="TextBox 9"/>
           <p:cNvSpPr txBox="1"/>
           <p:nvPr/>
         </p:nvSpPr>
         <p:spPr>
           <a:xfrm>
-            <a:off x="6327648" y="1371600"/>
-            <a:ext cx="2331720" cy="1920240"/>
+            <a:off x="6355080" y="1371600"/>
+            <a:ext cx="2286000" cy="1828800"/>
           </a:xfrm>
           <a:prstGeom prst="rect">
             <a:avLst/>
@@ -5516,7 +5296,7 @@
           <a:lstStyle/>
           <a:p>
             <a:pPr algn="ctr">
-              <a:defRPr sz="2800" b="1">
+              <a:defRPr sz="2600" b="1">
                 <a:solidFill>
                   <a:srgbClr val="0EA5E9"/>
                 </a:solidFill>
@@ -5550,21 +5330,21 @@
               </a:defRPr>
             </a:pPr>
             <a:r>
-              <a:t>Cross-skill flex rebalance clears 300+ surge calls in minutes.</a:t>
-            </a:r>
-          </a:p>
-        </p:txBody>
-      </p:sp>
-      <p:sp>
-        <p:nvSpPr>
-          <p:cNvPr id="10" name="Rounded Rectangle 9"/>
+              <a:t>Cross-skill rebalance clears 300+ surge calls within minutes.</a:t>
+            </a:r>
+          </a:p>
+        </p:txBody>
+      </p:sp>
+      <p:sp>
+        <p:nvSpPr>
+          <p:cNvPr id="11" name="Rounded Rectangle 10"/>
           <p:cNvSpPr/>
           <p:nvPr/>
         </p:nvSpPr>
         <p:spPr>
           <a:xfrm>
             <a:off x="8961120" y="1280160"/>
-            <a:ext cx="2560320" cy="2103120"/>
+            <a:ext cx="2560320" cy="2011680"/>
           </a:xfrm>
           <a:prstGeom prst="roundRect">
             <a:avLst/>
@@ -5602,14 +5382,14 @@
       </p:sp>
       <p:sp>
         <p:nvSpPr>
-          <p:cNvPr id="11" name="TextBox 10"/>
+          <p:cNvPr id="12" name="TextBox 11"/>
           <p:cNvSpPr txBox="1"/>
           <p:nvPr/>
         </p:nvSpPr>
         <p:spPr>
           <a:xfrm>
-            <a:off x="9070848" y="1371600"/>
-            <a:ext cx="2331720" cy="1920240"/>
+            <a:off x="9098280" y="1371600"/>
+            <a:ext cx="2286000" cy="1828800"/>
           </a:xfrm>
           <a:prstGeom prst="rect">
             <a:avLst/>
@@ -5623,14 +5403,14 @@
           <a:lstStyle/>
           <a:p>
             <a:pPr algn="ctr">
-              <a:defRPr sz="2800" b="1">
+              <a:defRPr sz="2600" b="1">
                 <a:solidFill>
                   <a:srgbClr val="D97706"/>
                 </a:solidFill>
               </a:defRPr>
             </a:pPr>
             <a:r>
-              <a:t>1,000/min</a:t>
+              <a:t>1,000/m</a:t>
             </a:r>
           </a:p>
           <a:p>
@@ -5645,7 +5425,7 @@
               </a:defRPr>
             </a:pPr>
             <a:r>
-              <a:t>Disaster IVR Auto-Deflect</a:t>
+              <a:t>Storm Deflection</a:t>
             </a:r>
           </a:p>
           <a:p>
@@ -5657,31 +5437,31 @@
               </a:defRPr>
             </a:pPr>
             <a:r>
-              <a:t>Protects live agents from being overwhelmed during storm outages.</a:t>
-            </a:r>
-          </a:p>
-        </p:txBody>
-      </p:sp>
-      <p:sp>
-        <p:nvSpPr>
-          <p:cNvPr id="12" name="Rounded Rectangle 11"/>
+              <a:t>Protects live agents from being overwhelmed during severe disaster outages.</a:t>
+            </a:r>
+          </a:p>
+        </p:txBody>
+      </p:sp>
+      <p:sp>
+        <p:nvSpPr>
+          <p:cNvPr id="13" name="Rounded Rectangle 12"/>
           <p:cNvSpPr/>
           <p:nvPr/>
         </p:nvSpPr>
         <p:spPr>
           <a:xfrm>
-            <a:off x="731520" y="3611880"/>
-            <a:ext cx="10698480" cy="2788920"/>
+            <a:off x="731520" y="3566160"/>
+            <a:ext cx="10698480" cy="2834640"/>
           </a:xfrm>
           <a:prstGeom prst="roundRect">
             <a:avLst/>
           </a:prstGeom>
           <a:solidFill>
-            <a:srgbClr val="F8FAFC"/>
+            <a:srgbClr val="FFFFFF"/>
           </a:solidFill>
           <a:ln w="19050">
             <a:solidFill>
-              <a:srgbClr val="2563EB"/>
+              <a:srgbClr val="E2E8F0"/>
             </a:solidFill>
           </a:ln>
         </p:spPr>
@@ -5709,14 +5489,14 @@
       </p:sp>
       <p:sp>
         <p:nvSpPr>
-          <p:cNvPr id="13" name="TextBox 12"/>
+          <p:cNvPr id="14" name="TextBox 13"/>
           <p:cNvSpPr txBox="1"/>
           <p:nvPr/>
         </p:nvSpPr>
         <p:spPr>
           <a:xfrm>
-            <a:off x="914400" y="3703320"/>
-            <a:ext cx="10332720" cy="2560320"/>
+            <a:off x="914400" y="3730752"/>
+            <a:ext cx="10332720" cy="2505456"/>
           </a:xfrm>
           <a:prstGeom prst="rect">
             <a:avLst/>
@@ -5724,23 +5504,35 @@
           <a:noFill/>
         </p:spPr>
         <p:txBody>
-          <a:bodyPr wrap="square">
+          <a:bodyPr wrap="square" anchor="t">
             <a:spAutoFit/>
           </a:bodyPr>
           <a:lstStyle/>
           <a:p>
             <a:pPr>
+              <a:defRPr sz="1400" b="1">
+                <a:solidFill>
+                  <a:srgbClr val="1E3A8A"/>
+                </a:solidFill>
+              </a:defRPr>
+            </a:pPr>
+            <a:r>
+              <a:t>Three Pillars of Enterprise Operational ROI</a:t>
+            </a:r>
+          </a:p>
+          <a:p>
+            <a:pPr>
               <a:spcAft>
-                <a:spcPts val="600"/>
+                <a:spcPts val="800"/>
               </a:spcAft>
-              <a:defRPr sz="1200" b="1">
-                <a:solidFill>
-                  <a:srgbClr val="1E3A8A"/>
-                </a:solidFill>
-              </a:defRPr>
-            </a:pPr>
-            <a:r>
-              <a:t>THREE PILLARS OF ENTERPRISE OPERATIONAL ROI</a:t>
+              <a:defRPr sz="1000" i="1">
+                <a:solidFill>
+                  <a:srgbClr val="64748B"/>
+                </a:solidFill>
+              </a:defRPr>
+            </a:pPr>
+            <a:r>
+              <a:t>Workforce Optimization, Agent Well-being &amp; Executive Governance</a:t>
             </a:r>
           </a:p>
           <a:p>
@@ -5750,12 +5542,12 @@
               </a:spcAft>
               <a:defRPr b="1" sz="1000">
                 <a:solidFill>
-                  <a:srgbClr val="0F172A"/>
-                </a:solidFill>
-              </a:defRPr>
-            </a:pPr>
-            <a:r>
-              <a:t>• Pillar 1: Frictionless Workforce Adherence: </a:t>
+                  <a:srgbClr val="1E3A8A"/>
+                </a:solidFill>
+              </a:defRPr>
+            </a:pPr>
+            <a:r>
+              <a:t>• Pillar 1: Intraday Workforce Optimization (WFM): </a:t>
             </a:r>
             <a:r>
               <a:rPr b="0" sz="950">
@@ -5763,7 +5555,7 @@
                   <a:srgbClr val="64748B"/>
                 </a:solidFill>
               </a:rPr>
-              <a:t>Removes break scheduling friction. Agents take breaks when queue capacity allows, eliminating unplanned overages and raising overall shift adherence by +18.4%.</a:t>
+              <a:t>Automated Erlang-C calculations remove manual break log approvals. Intraday queue rebalancing rescues service levels without paying overtime or calling in emergency off-shift staff.</a:t>
             </a:r>
           </a:p>
           <a:p>
@@ -5773,12 +5565,12 @@
               </a:spcAft>
               <a:defRPr b="1" sz="1000">
                 <a:solidFill>
-                  <a:srgbClr val="0F172A"/>
-                </a:solidFill>
-              </a:defRPr>
-            </a:pPr>
-            <a:r>
-              <a:t>• Pillar 2: Reduced Handle Time &amp; Cognitive Fatigue: </a:t>
+                  <a:srgbClr val="1E3A8A"/>
+                </a:solidFill>
+              </a:defRPr>
+            </a:pPr>
+            <a:r>
+              <a:t>• Pillar 2: Agent Retention &amp; Fatigue Mitigation: </a:t>
             </a:r>
             <a:r>
               <a:rPr b="0" sz="950">
@@ -5786,7 +5578,7 @@
                   <a:srgbClr val="64748B"/>
                 </a:solidFill>
               </a:rPr>
-              <a:t>AI ACW summarization eliminates repetitive post-call note typing, while fatigue tracking ensures overworked agents receive timely rest intervals before customer tone degrades.</a:t>
+              <a:t>Post-call AI summarization prevents cognitive ACW fatigue. Burnout detection algorithms flag consecutive call strain, ensuring high-risk agents receive timely rest intervals before customer sentiment suffers.</a:t>
             </a:r>
           </a:p>
           <a:p>
@@ -5796,12 +5588,12 @@
               </a:spcAft>
               <a:defRPr b="1" sz="1000">
                 <a:solidFill>
-                  <a:srgbClr val="0F172A"/>
-                </a:solidFill>
-              </a:defRPr>
-            </a:pPr>
-            <a:r>
-              <a:t>• Pillar 3: High-Agility Floor Governance: </a:t>
+                  <a:srgbClr val="1E3A8A"/>
+                </a:solidFill>
+              </a:defRPr>
+            </a:pPr>
+            <a:r>
+              <a:t>• Pillar 3: High-Visibility Supervisor Governance: </a:t>
             </a:r>
             <a:r>
               <a:rPr b="0" sz="950">
@@ -5809,7 +5601,7 @@
                   <a:srgbClr val="64748B"/>
                 </a:solidFill>
               </a:rPr>
-              <a:t>Supervisors gain direct scoped team oversight, automated voice bot recalls, and 1-click dynamic surge rebalancing, saving 8+ managerial hours per week from manual tracking.</a:t>
+              <a:t>Supervisors transition from spreadsheet monitors to proactive coaches. Scoped team views ensure each manager focuses on their direct reports, with automated voice recalls and 1-click coaching assignment.</a:t>
             </a:r>
           </a:p>
         </p:txBody>

</xml_diff>